<commit_message>
Add experiment screenshots, source code appendix, and GitHub link to report & PPT
</commit_message>
<xml_diff>
--- a/report/presentation.pptx
+++ b/report/presentation.pptx
@@ -7,6 +7,12 @@
   <p:sldIdLst>
     <p:sldId id="256" r:id="rId7"/>
     <p:sldId id="257" r:id="rId8"/>
+    <p:sldId id="269" r:id="rId20"/>
+    <p:sldId id="270" r:id="rId21"/>
+    <p:sldId id="271" r:id="rId22"/>
+    <p:sldId id="272" r:id="rId23"/>
+    <p:sldId id="273" r:id="rId24"/>
+    <p:sldId id="274" r:id="rId25"/>
     <p:sldId id="258" r:id="rId9"/>
     <p:sldId id="259" r:id="rId10"/>
     <p:sldId id="260" r:id="rId11"/>
@@ -18,6 +24,7 @@
     <p:sldId id="266" r:id="rId17"/>
     <p:sldId id="267" r:id="rId18"/>
     <p:sldId id="268" r:id="rId19"/>
+    <p:sldId id="275" r:id="rId26"/>
   </p:sldIdLst>
   <p:sldSz cx="12191695" cy="6858000" type="screen4x3"/>
   <p:notesSz cx="6858000" cy="9144000"/>
@@ -3218,14 +3225,14 @@
               </a:defRPr>
             </a:pPr>
             <a:r>
-              <a:t>训练过程（4/5）</a:t>
+              <a:t>数据特征：高量段日内双峰（2/5）</a:t>
             </a:r>
           </a:p>
         </p:txBody>
       </p:sp>
       <p:pic>
         <p:nvPicPr>
-          <p:cNvPr id="3" name="Picture 2" descr="train_curve.png"/>
+          <p:cNvPr id="3" name="Picture 2" descr="high_volume_series.png"/>
           <p:cNvPicPr>
             <a:picLocks noChangeAspect="1"/>
           </p:cNvPicPr>
@@ -3240,7 +3247,7 @@
         <p:spPr>
           <a:xfrm>
             <a:off x="548640" y="1280160"/>
-            <a:ext cx="8229600" cy="4051495"/>
+            <a:ext cx="9601200" cy="3413760"/>
           </a:xfrm>
           <a:prstGeom prst="rect">
             <a:avLst/>
@@ -3295,35 +3302,130 @@
               </a:defRPr>
             </a:pPr>
             <a:r>
-              <a:t>误差空间分布（5/5）</a:t>
-            </a:r>
-          </a:p>
-        </p:txBody>
-      </p:sp>
-      <p:pic>
-        <p:nvPicPr>
-          <p:cNvPr id="3" name="Picture 2" descr="spatial_error.png"/>
-          <p:cNvPicPr>
-            <a:picLocks noChangeAspect="1"/>
-          </p:cNvPicPr>
+              <a:t>特征构造方法</a:t>
+            </a:r>
+          </a:p>
+        </p:txBody>
+      </p:sp>
+      <p:sp>
+        <p:nvSpPr>
+          <p:cNvPr id="3" name="TextBox 2"/>
+          <p:cNvSpPr txBox="1"/>
           <p:nvPr/>
-        </p:nvPicPr>
-        <p:blipFill>
-          <a:blip r:embed="rId2"/>
-          <a:stretch>
-            <a:fillRect/>
-          </a:stretch>
-        </p:blipFill>
-        <p:spPr>
-          <a:xfrm>
-            <a:off x="548640" y="1280160"/>
-            <a:ext cx="10058400" cy="3419856"/>
+        </p:nvSpPr>
+        <p:spPr>
+          <a:xfrm>
+            <a:off x="731520" y="1280160"/>
+            <a:ext cx="10698480" cy="2286000"/>
           </a:xfrm>
           <a:prstGeom prst="rect">
             <a:avLst/>
           </a:prstGeom>
-        </p:spPr>
-      </p:pic>
+          <a:noFill/>
+        </p:spPr>
+        <p:txBody>
+          <a:bodyPr wrap="square">
+            <a:spAutoFit/>
+          </a:bodyPr>
+          <a:lstStyle/>
+          <a:p>
+            <a:pPr>
+              <a:defRPr sz="1800">
+                <a:solidFill>
+                  <a:srgbClr val="333333"/>
+                </a:solidFill>
+              </a:defRPr>
+            </a:pPr>
+            <a:r>
+              <a:t>需求特征：过去24小时（48步）30网格借/还车量，共 48 × 60 = 2880 维</a:t>
+            </a:r>
+          </a:p>
+          <a:p>
+            <a:pPr>
+              <a:defRPr sz="1800">
+                <a:solidFill>
+                  <a:srgbClr val="333333"/>
+                </a:solidFill>
+              </a:defRPr>
+            </a:pPr>
+            <a:r>
+              <a:t>滞后特征：前一日同时刻（lag=48）借/还车量，共60维 → 显式提供previous-day信号</a:t>
+            </a:r>
+          </a:p>
+          <a:p>
+            <a:pPr>
+              <a:defRPr sz="1800">
+                <a:solidFill>
+                  <a:srgbClr val="333333"/>
+                </a:solidFill>
+              </a:defRPr>
+            </a:pPr>
+            <a:r>
+              <a:t>时间周期特征（5维）：</a:t>
+            </a:r>
+          </a:p>
+          <a:p>
+            <a:pPr lvl="1">
+              <a:defRPr sz="1600">
+                <a:solidFill>
+                  <a:srgbClr val="333333"/>
+                </a:solidFill>
+              </a:defRPr>
+            </a:pPr>
+            <a:r>
+              <a:t>日内正弦/余弦：sin(2πt/48), cos(2πt/48)</a:t>
+            </a:r>
+          </a:p>
+          <a:p>
+            <a:pPr lvl="1">
+              <a:defRPr sz="1600">
+                <a:solidFill>
+                  <a:srgbClr val="333333"/>
+                </a:solidFill>
+              </a:defRPr>
+            </a:pPr>
+            <a:r>
+              <a:t>周内正弦/余弦：sin(2πd/7), cos(2πd/7)</a:t>
+            </a:r>
+          </a:p>
+          <a:p>
+            <a:pPr lvl="1">
+              <a:defRPr sz="1600">
+                <a:solidFill>
+                  <a:srgbClr val="333333"/>
+                </a:solidFill>
+              </a:defRPr>
+            </a:pPr>
+            <a:r>
+              <a:t>周末二值标记：周六日=1，其余=0</a:t>
+            </a:r>
+          </a:p>
+          <a:p>
+            <a:pPr>
+              <a:defRPr sz="1800">
+                <a:solidFill>
+                  <a:srgbClr val="333333"/>
+                </a:solidFill>
+              </a:defRPr>
+            </a:pPr>
+            <a:r>
+              <a:t>标准化：训练集上z-score，避免数据泄露</a:t>
+            </a:r>
+          </a:p>
+          <a:p>
+            <a:pPr>
+              <a:defRPr sz="1800">
+                <a:solidFill>
+                  <a:srgbClr val="333333"/>
+                </a:solidFill>
+              </a:defRPr>
+            </a:pPr>
+            <a:r>
+              <a:t>输出：未来30分钟60维需求向量（借车30 + 还车30）</a:t>
+            </a:r>
+          </a:p>
+        </p:txBody>
+      </p:sp>
     </p:spTree>
   </p:cSld>
   <p:clrMapOvr>
@@ -3372,7 +3474,7 @@
               </a:defRPr>
             </a:pPr>
             <a:r>
-              <a:t>误差空间分布的原因</a:t>
+              <a:t>训练集与测试集划分（按日期）</a:t>
             </a:r>
           </a:p>
         </p:txBody>
@@ -3407,8 +3509,17 @@
               </a:defRPr>
             </a:pPr>
             <a:r>
-              <a:t>高需求 — 高误差：高峰期单网格30分钟订单可达数千辆，相对误差10%对应绝对MAE远高于低需求网格</a:t>
-            </a:r>
+              <a:t>发现数据分布严重不均匀（前29天几乎无订单），改为按日期划分：</a:t>
+            </a:r>
+          </a:p>
+          <a:p>
+            <a:pPr>
+              <a:defRPr sz="1000">
+                <a:solidFill>
+                  <a:srgbClr val="333333"/>
+                </a:solidFill>
+              </a:defRPr>
+            </a:pPr>
           </a:p>
           <a:p>
             <a:pPr>
@@ -3419,7 +3530,7 @@
               </a:defRPr>
             </a:pPr>
             <a:r>
-              <a:t>需求波动性强：高需求网格对突发事件（天气、管制、活动）更敏感，昨日同期基线难以捕捉</a:t>
+              <a:t>训练集：2021-01-30 13:00 — 2021-01-31 20:00（高量段）</a:t>
             </a:r>
           </a:p>
           <a:p>
@@ -3431,7 +3542,40 @@
               </a:defRPr>
             </a:pPr>
             <a:r>
-              <a:t>数据量不足：训练段仅约31小时高量数据，模型无法学习各网格差异化模式，只能学到全局周期修正</a:t>
+              <a:t>验证集：2021-01-31 20:00 — 2021-02-01 04:00</a:t>
+            </a:r>
+          </a:p>
+          <a:p>
+            <a:pPr>
+              <a:defRPr sz="2000">
+                <a:solidFill>
+                  <a:srgbClr val="333333"/>
+                </a:solidFill>
+              </a:defRPr>
+            </a:pPr>
+            <a:r>
+              <a:t>测试集：2021-02-01 04:00 — 2021-02-02 14:00</a:t>
+            </a:r>
+          </a:p>
+          <a:p>
+            <a:pPr>
+              <a:defRPr sz="1000">
+                <a:solidFill>
+                  <a:srgbClr val="333333"/>
+                </a:solidFill>
+              </a:defRPr>
+            </a:pPr>
+          </a:p>
+          <a:p>
+            <a:pPr>
+              <a:defRPr sz="2000">
+                <a:solidFill>
+                  <a:srgbClr val="333333"/>
+                </a:solidFill>
+              </a:defRPr>
+            </a:pPr>
+            <a:r>
+              <a:t>lookback = 48（过去24小时） → 预测 horizon = 1（未来30分钟）</a:t>
             </a:r>
           </a:p>
         </p:txBody>
@@ -3484,6 +3628,627 @@
               </a:defRPr>
             </a:pPr>
             <a:r>
+              <a:t>模型架构：Transformer + 残差学习</a:t>
+            </a:r>
+          </a:p>
+        </p:txBody>
+      </p:sp>
+      <p:sp>
+        <p:nvSpPr>
+          <p:cNvPr id="3" name="TextBox 2"/>
+          <p:cNvSpPr txBox="1"/>
+          <p:nvPr/>
+        </p:nvSpPr>
+        <p:spPr>
+          <a:xfrm>
+            <a:off x="731520" y="1280160"/>
+            <a:ext cx="10698480" cy="2286000"/>
+          </a:xfrm>
+          <a:prstGeom prst="rect">
+            <a:avLst/>
+          </a:prstGeom>
+          <a:noFill/>
+        </p:spPr>
+        <p:txBody>
+          <a:bodyPr wrap="square">
+            <a:spAutoFit/>
+          </a:bodyPr>
+          <a:lstStyle/>
+          <a:p>
+            <a:pPr>
+              <a:defRPr sz="2000">
+                <a:solidFill>
+                  <a:srgbClr val="333333"/>
+                </a:solidFill>
+              </a:defRPr>
+            </a:pPr>
+            <a:r>
+              <a:t>核心设计：预测目标 = 需求 - 前一日同时刻需求（残差），评估时加回基线还原</a:t>
+            </a:r>
+          </a:p>
+          <a:p>
+            <a:pPr>
+              <a:defRPr sz="1000">
+                <a:solidFill>
+                  <a:srgbClr val="333333"/>
+                </a:solidFill>
+              </a:defRPr>
+            </a:pPr>
+          </a:p>
+          <a:p>
+            <a:pPr>
+              <a:defRPr sz="2000">
+                <a:solidFill>
+                  <a:srgbClr val="333333"/>
+                </a:solidFill>
+              </a:defRPr>
+            </a:pPr>
+            <a:r>
+              <a:t>输入投影：Linear(2945 → d_model=64) + LayerNorm + 正弦位置编码</a:t>
+            </a:r>
+          </a:p>
+          <a:p>
+            <a:pPr>
+              <a:defRPr sz="2000">
+                <a:solidFill>
+                  <a:srgbClr val="333333"/>
+                </a:solidFill>
+              </a:defRPr>
+            </a:pPr>
+            <a:r>
+              <a:t>时间编码器：2层TransformerEncoder，nhead=4，FFN=128，norm_first=True</a:t>
+            </a:r>
+          </a:p>
+          <a:p>
+            <a:pPr>
+              <a:defRPr sz="2000">
+                <a:solidFill>
+                  <a:srgbClr val="333333"/>
+                </a:solidFill>
+              </a:defRPr>
+            </a:pPr>
+            <a:r>
+              <a:t>输出头：LayerNorm + Linear(d_model → 60)，取最后时间步输出</a:t>
+            </a:r>
+          </a:p>
+          <a:p>
+            <a:pPr>
+              <a:defRPr sz="1000">
+                <a:solidFill>
+                  <a:srgbClr val="333333"/>
+                </a:solidFill>
+              </a:defRPr>
+            </a:pPr>
+          </a:p>
+          <a:p>
+            <a:pPr>
+              <a:defRPr sz="2000">
+                <a:solidFill>
+                  <a:srgbClr val="333333"/>
+                </a:solidFill>
+              </a:defRPr>
+            </a:pPr>
+            <a:r>
+              <a:t>残差学习使模型从previous-day水平出发学习修正量，稳定训练过程</a:t>
+            </a:r>
+          </a:p>
+        </p:txBody>
+      </p:sp>
+    </p:spTree>
+  </p:cSld>
+  <p:clrMapOvr>
+    <a:masterClrMapping/>
+  </p:clrMapOvr>
+</p:sld>
+</file>
+
+<file path=ppt/slides/slide14.xml><?xml version="1.0" encoding="utf-8"?>
+<p:sld xmlns:a="http://schemas.openxmlformats.org/drawingml/2006/main" xmlns:p="http://schemas.openxmlformats.org/presentationml/2006/main" xmlns:r="http://schemas.openxmlformats.org/officeDocument/2006/relationships">
+  <p:cSld>
+    <p:spTree>
+      <p:nvGrpSpPr>
+        <p:cNvPr id="1" name=""/>
+        <p:cNvGrpSpPr/>
+        <p:nvPr/>
+      </p:nvGrpSpPr>
+      <p:grpSpPr/>
+      <p:sp>
+        <p:nvSpPr>
+          <p:cNvPr id="2" name="TextBox 1"/>
+          <p:cNvSpPr txBox="1"/>
+          <p:nvPr/>
+        </p:nvSpPr>
+        <p:spPr>
+          <a:xfrm>
+            <a:off x="548640" y="274320"/>
+            <a:ext cx="11064240" cy="822960"/>
+          </a:xfrm>
+          <a:prstGeom prst="rect">
+            <a:avLst/>
+          </a:prstGeom>
+          <a:noFill/>
+        </p:spPr>
+        <p:txBody>
+          <a:bodyPr wrap="none">
+            <a:spAutoFit/>
+          </a:bodyPr>
+          <a:lstStyle/>
+          <a:p>
+            <a:pPr>
+              <a:defRPr sz="3000" b="1">
+                <a:solidFill>
+                  <a:srgbClr val="1F4E79"/>
+                </a:solidFill>
+              </a:defRPr>
+            </a:pPr>
+            <a:r>
+              <a:t>评价指标</a:t>
+            </a:r>
+          </a:p>
+        </p:txBody>
+      </p:sp>
+      <p:sp>
+        <p:nvSpPr>
+          <p:cNvPr id="3" name="TextBox 2"/>
+          <p:cNvSpPr txBox="1"/>
+          <p:nvPr/>
+        </p:nvSpPr>
+        <p:spPr>
+          <a:xfrm>
+            <a:off x="731520" y="1280160"/>
+            <a:ext cx="10698480" cy="2286000"/>
+          </a:xfrm>
+          <a:prstGeom prst="rect">
+            <a:avLst/>
+          </a:prstGeom>
+          <a:noFill/>
+        </p:spPr>
+        <p:txBody>
+          <a:bodyPr wrap="square">
+            <a:spAutoFit/>
+          </a:bodyPr>
+          <a:lstStyle/>
+          <a:p>
+            <a:pPr>
+              <a:defRPr sz="2000">
+                <a:solidFill>
+                  <a:srgbClr val="333333"/>
+                </a:solidFill>
+              </a:defRPr>
+            </a:pPr>
+            <a:r>
+              <a:t>MAE（平均绝对误差）：对异常值不敏感，直观反映平均偏差</a:t>
+            </a:r>
+          </a:p>
+          <a:p>
+            <a:pPr>
+              <a:defRPr sz="2000">
+                <a:solidFill>
+                  <a:srgbClr val="333333"/>
+                </a:solidFill>
+              </a:defRPr>
+            </a:pPr>
+            <a:r>
+              <a:t>RMSE（均方根误差）：对大误差敏感，反映峰值时段表现</a:t>
+            </a:r>
+          </a:p>
+          <a:p>
+            <a:pPr>
+              <a:defRPr sz="2000">
+                <a:solidFill>
+                  <a:srgbClr val="333333"/>
+                </a:solidFill>
+              </a:defRPr>
+            </a:pPr>
+            <a:r>
+              <a:t>MAPE（百分比误差）：当真值接近0时数值爆炸，本数据夜间时段MAPE可达数千%</a:t>
+            </a:r>
+          </a:p>
+          <a:p>
+            <a:pPr>
+              <a:defRPr sz="2000">
+                <a:solidFill>
+                  <a:srgbClr val="333333"/>
+                </a:solidFill>
+              </a:defRPr>
+            </a:pPr>
+            <a:r>
+              <a:t>WMAPE（加权百分比误差）：以总需求为分母，更稳健，本实验主要参考指标</a:t>
+            </a:r>
+          </a:p>
+        </p:txBody>
+      </p:sp>
+    </p:spTree>
+  </p:cSld>
+  <p:clrMapOvr>
+    <a:masterClrMapping/>
+  </p:clrMapOvr>
+</p:sld>
+</file>
+
+<file path=ppt/slides/slide15.xml><?xml version="1.0" encoding="utf-8"?>
+<p:sld xmlns:a="http://schemas.openxmlformats.org/drawingml/2006/main" xmlns:p="http://schemas.openxmlformats.org/presentationml/2006/main" xmlns:r="http://schemas.openxmlformats.org/officeDocument/2006/relationships">
+  <p:cSld>
+    <p:spTree>
+      <p:nvGrpSpPr>
+        <p:cNvPr id="1" name=""/>
+        <p:cNvGrpSpPr/>
+        <p:nvPr/>
+      </p:nvGrpSpPr>
+      <p:grpSpPr/>
+      <p:sp>
+        <p:nvSpPr>
+          <p:cNvPr id="2" name="TextBox 1"/>
+          <p:cNvSpPr txBox="1"/>
+          <p:nvPr/>
+        </p:nvSpPr>
+        <p:spPr>
+          <a:xfrm>
+            <a:off x="548640" y="274320"/>
+            <a:ext cx="11064240" cy="822960"/>
+          </a:xfrm>
+          <a:prstGeom prst="rect">
+            <a:avLst/>
+          </a:prstGeom>
+          <a:noFill/>
+        </p:spPr>
+        <p:txBody>
+          <a:bodyPr wrap="none">
+            <a:spAutoFit/>
+          </a:bodyPr>
+          <a:lstStyle/>
+          <a:p>
+            <a:pPr>
+              <a:defRPr sz="3000" b="1">
+                <a:solidFill>
+                  <a:srgbClr val="1F4E79"/>
+                </a:solidFill>
+              </a:defRPr>
+            </a:pPr>
+            <a:r>
+              <a:t>模型误差对比（3/5）</a:t>
+            </a:r>
+          </a:p>
+        </p:txBody>
+      </p:sp>
+      <p:pic>
+        <p:nvPicPr>
+          <p:cNvPr id="3" name="Picture 2" descr="model_compare.png"/>
+          <p:cNvPicPr>
+            <a:picLocks noChangeAspect="1"/>
+          </p:cNvPicPr>
+          <p:nvPr/>
+        </p:nvPicPr>
+        <p:blipFill>
+          <a:blip r:embed="rId2"/>
+          <a:stretch>
+            <a:fillRect/>
+          </a:stretch>
+        </p:blipFill>
+        <p:spPr>
+          <a:xfrm>
+            <a:off x="548640" y="1280160"/>
+            <a:ext cx="8229600" cy="4051495"/>
+          </a:xfrm>
+          <a:prstGeom prst="rect">
+            <a:avLst/>
+          </a:prstGeom>
+        </p:spPr>
+      </p:pic>
+    </p:spTree>
+  </p:cSld>
+  <p:clrMapOvr>
+    <a:masterClrMapping/>
+  </p:clrMapOvr>
+</p:sld>
+</file>
+
+<file path=ppt/slides/slide16.xml><?xml version="1.0" encoding="utf-8"?>
+<p:sld xmlns:a="http://schemas.openxmlformats.org/drawingml/2006/main" xmlns:p="http://schemas.openxmlformats.org/presentationml/2006/main" xmlns:r="http://schemas.openxmlformats.org/officeDocument/2006/relationships">
+  <p:cSld>
+    <p:spTree>
+      <p:nvGrpSpPr>
+        <p:cNvPr id="1" name=""/>
+        <p:cNvGrpSpPr/>
+        <p:nvPr/>
+      </p:nvGrpSpPr>
+      <p:grpSpPr/>
+      <p:sp>
+        <p:nvSpPr>
+          <p:cNvPr id="2" name="TextBox 1"/>
+          <p:cNvSpPr txBox="1"/>
+          <p:nvPr/>
+        </p:nvSpPr>
+        <p:spPr>
+          <a:xfrm>
+            <a:off x="548640" y="274320"/>
+            <a:ext cx="11064240" cy="822960"/>
+          </a:xfrm>
+          <a:prstGeom prst="rect">
+            <a:avLst/>
+          </a:prstGeom>
+          <a:noFill/>
+        </p:spPr>
+        <p:txBody>
+          <a:bodyPr wrap="none">
+            <a:spAutoFit/>
+          </a:bodyPr>
+          <a:lstStyle/>
+          <a:p>
+            <a:pPr>
+              <a:defRPr sz="3000" b="1">
+                <a:solidFill>
+                  <a:srgbClr val="1F4E79"/>
+                </a:solidFill>
+              </a:defRPr>
+            </a:pPr>
+            <a:r>
+              <a:t>训练过程（4/5）</a:t>
+            </a:r>
+          </a:p>
+        </p:txBody>
+      </p:sp>
+      <p:pic>
+        <p:nvPicPr>
+          <p:cNvPr id="3" name="Picture 2" descr="train_curve.png"/>
+          <p:cNvPicPr>
+            <a:picLocks noChangeAspect="1"/>
+          </p:cNvPicPr>
+          <p:nvPr/>
+        </p:nvPicPr>
+        <p:blipFill>
+          <a:blip r:embed="rId2"/>
+          <a:stretch>
+            <a:fillRect/>
+          </a:stretch>
+        </p:blipFill>
+        <p:spPr>
+          <a:xfrm>
+            <a:off x="548640" y="1280160"/>
+            <a:ext cx="8229600" cy="4051495"/>
+          </a:xfrm>
+          <a:prstGeom prst="rect">
+            <a:avLst/>
+          </a:prstGeom>
+        </p:spPr>
+      </p:pic>
+    </p:spTree>
+  </p:cSld>
+  <p:clrMapOvr>
+    <a:masterClrMapping/>
+  </p:clrMapOvr>
+</p:sld>
+</file>
+
+<file path=ppt/slides/slide17.xml><?xml version="1.0" encoding="utf-8"?>
+<p:sld xmlns:a="http://schemas.openxmlformats.org/drawingml/2006/main" xmlns:p="http://schemas.openxmlformats.org/presentationml/2006/main" xmlns:r="http://schemas.openxmlformats.org/officeDocument/2006/relationships">
+  <p:cSld>
+    <p:spTree>
+      <p:nvGrpSpPr>
+        <p:cNvPr id="1" name=""/>
+        <p:cNvGrpSpPr/>
+        <p:nvPr/>
+      </p:nvGrpSpPr>
+      <p:grpSpPr/>
+      <p:sp>
+        <p:nvSpPr>
+          <p:cNvPr id="2" name="TextBox 1"/>
+          <p:cNvSpPr txBox="1"/>
+          <p:nvPr/>
+        </p:nvSpPr>
+        <p:spPr>
+          <a:xfrm>
+            <a:off x="548640" y="274320"/>
+            <a:ext cx="11064240" cy="822960"/>
+          </a:xfrm>
+          <a:prstGeom prst="rect">
+            <a:avLst/>
+          </a:prstGeom>
+          <a:noFill/>
+        </p:spPr>
+        <p:txBody>
+          <a:bodyPr wrap="none">
+            <a:spAutoFit/>
+          </a:bodyPr>
+          <a:lstStyle/>
+          <a:p>
+            <a:pPr>
+              <a:defRPr sz="3000" b="1">
+                <a:solidFill>
+                  <a:srgbClr val="1F4E79"/>
+                </a:solidFill>
+              </a:defRPr>
+            </a:pPr>
+            <a:r>
+              <a:t>误差空间分布（5/5）</a:t>
+            </a:r>
+          </a:p>
+        </p:txBody>
+      </p:sp>
+      <p:pic>
+        <p:nvPicPr>
+          <p:cNvPr id="3" name="Picture 2" descr="spatial_error.png"/>
+          <p:cNvPicPr>
+            <a:picLocks noChangeAspect="1"/>
+          </p:cNvPicPr>
+          <p:nvPr/>
+        </p:nvPicPr>
+        <p:blipFill>
+          <a:blip r:embed="rId2"/>
+          <a:stretch>
+            <a:fillRect/>
+          </a:stretch>
+        </p:blipFill>
+        <p:spPr>
+          <a:xfrm>
+            <a:off x="548640" y="1280160"/>
+            <a:ext cx="10058400" cy="3419856"/>
+          </a:xfrm>
+          <a:prstGeom prst="rect">
+            <a:avLst/>
+          </a:prstGeom>
+        </p:spPr>
+      </p:pic>
+    </p:spTree>
+  </p:cSld>
+  <p:clrMapOvr>
+    <a:masterClrMapping/>
+  </p:clrMapOvr>
+</p:sld>
+</file>
+
+<file path=ppt/slides/slide18.xml><?xml version="1.0" encoding="utf-8"?>
+<p:sld xmlns:a="http://schemas.openxmlformats.org/drawingml/2006/main" xmlns:p="http://schemas.openxmlformats.org/presentationml/2006/main" xmlns:r="http://schemas.openxmlformats.org/officeDocument/2006/relationships">
+  <p:cSld>
+    <p:spTree>
+      <p:nvGrpSpPr>
+        <p:cNvPr id="1" name=""/>
+        <p:cNvGrpSpPr/>
+        <p:nvPr/>
+      </p:nvGrpSpPr>
+      <p:grpSpPr/>
+      <p:sp>
+        <p:nvSpPr>
+          <p:cNvPr id="2" name="TextBox 1"/>
+          <p:cNvSpPr txBox="1"/>
+          <p:nvPr/>
+        </p:nvSpPr>
+        <p:spPr>
+          <a:xfrm>
+            <a:off x="548640" y="274320"/>
+            <a:ext cx="11064240" cy="822960"/>
+          </a:xfrm>
+          <a:prstGeom prst="rect">
+            <a:avLst/>
+          </a:prstGeom>
+          <a:noFill/>
+        </p:spPr>
+        <p:txBody>
+          <a:bodyPr wrap="none">
+            <a:spAutoFit/>
+          </a:bodyPr>
+          <a:lstStyle/>
+          <a:p>
+            <a:pPr>
+              <a:defRPr sz="3000" b="1">
+                <a:solidFill>
+                  <a:srgbClr val="1F4E79"/>
+                </a:solidFill>
+              </a:defRPr>
+            </a:pPr>
+            <a:r>
+              <a:t>误差空间分布的原因</a:t>
+            </a:r>
+          </a:p>
+        </p:txBody>
+      </p:sp>
+      <p:sp>
+        <p:nvSpPr>
+          <p:cNvPr id="3" name="TextBox 2"/>
+          <p:cNvSpPr txBox="1"/>
+          <p:nvPr/>
+        </p:nvSpPr>
+        <p:spPr>
+          <a:xfrm>
+            <a:off x="731520" y="1280160"/>
+            <a:ext cx="10698480" cy="2286000"/>
+          </a:xfrm>
+          <a:prstGeom prst="rect">
+            <a:avLst/>
+          </a:prstGeom>
+          <a:noFill/>
+        </p:spPr>
+        <p:txBody>
+          <a:bodyPr wrap="square">
+            <a:spAutoFit/>
+          </a:bodyPr>
+          <a:lstStyle/>
+          <a:p>
+            <a:pPr>
+              <a:defRPr sz="2000">
+                <a:solidFill>
+                  <a:srgbClr val="333333"/>
+                </a:solidFill>
+              </a:defRPr>
+            </a:pPr>
+            <a:r>
+              <a:t>高需求 — 高误差：高峰期单网格30分钟订单可达数千辆，相对误差10%对应绝对MAE远高于低需求网格</a:t>
+            </a:r>
+          </a:p>
+          <a:p>
+            <a:pPr>
+              <a:defRPr sz="2000">
+                <a:solidFill>
+                  <a:srgbClr val="333333"/>
+                </a:solidFill>
+              </a:defRPr>
+            </a:pPr>
+            <a:r>
+              <a:t>需求波动性强：高需求网格对突发事件（天气、管制、活动）更敏感，昨日同期基线难以捕捉</a:t>
+            </a:r>
+          </a:p>
+          <a:p>
+            <a:pPr>
+              <a:defRPr sz="2000">
+                <a:solidFill>
+                  <a:srgbClr val="333333"/>
+                </a:solidFill>
+              </a:defRPr>
+            </a:pPr>
+            <a:r>
+              <a:t>数据量不足：训练段仅约31小时高量数据，模型无法学习各网格差异化模式，只能学到全局周期修正</a:t>
+            </a:r>
+          </a:p>
+        </p:txBody>
+      </p:sp>
+    </p:spTree>
+  </p:cSld>
+  <p:clrMapOvr>
+    <a:masterClrMapping/>
+  </p:clrMapOvr>
+</p:sld>
+</file>
+
+<file path=ppt/slides/slide19.xml><?xml version="1.0" encoding="utf-8"?>
+<p:sld xmlns:a="http://schemas.openxmlformats.org/drawingml/2006/main" xmlns:p="http://schemas.openxmlformats.org/presentationml/2006/main" xmlns:r="http://schemas.openxmlformats.org/officeDocument/2006/relationships">
+  <p:cSld>
+    <p:spTree>
+      <p:nvGrpSpPr>
+        <p:cNvPr id="1" name=""/>
+        <p:cNvGrpSpPr/>
+        <p:nvPr/>
+      </p:nvGrpSpPr>
+      <p:grpSpPr/>
+      <p:sp>
+        <p:nvSpPr>
+          <p:cNvPr id="2" name="TextBox 1"/>
+          <p:cNvSpPr txBox="1"/>
+          <p:nvPr/>
+        </p:nvSpPr>
+        <p:spPr>
+          <a:xfrm>
+            <a:off x="548640" y="274320"/>
+            <a:ext cx="11064240" cy="822960"/>
+          </a:xfrm>
+          <a:prstGeom prst="rect">
+            <a:avLst/>
+          </a:prstGeom>
+          <a:noFill/>
+        </p:spPr>
+        <p:txBody>
+          <a:bodyPr wrap="none">
+            <a:spAutoFit/>
+          </a:bodyPr>
+          <a:lstStyle/>
+          <a:p>
+            <a:pPr>
+              <a:defRPr sz="3000" b="1">
+                <a:solidFill>
+                  <a:srgbClr val="1F4E79"/>
+                </a:solidFill>
+              </a:defRPr>
+            </a:pPr>
+            <a:r>
               <a:t>总结与讨论</a:t>
             </a:r>
           </a:p>
@@ -3716,6 +4481,245 @@
 </p:sld>
 </file>
 
+<file path=ppt/slides/slide20.xml><?xml version="1.0" encoding="utf-8"?>
+<p:sld xmlns:a="http://schemas.openxmlformats.org/drawingml/2006/main" xmlns:p="http://schemas.openxmlformats.org/presentationml/2006/main" xmlns:r="http://schemas.openxmlformats.org/officeDocument/2006/relationships">
+  <p:cSld>
+    <p:spTree>
+      <p:nvGrpSpPr>
+        <p:cNvPr id="1" name=""/>
+        <p:cNvGrpSpPr/>
+        <p:nvPr/>
+      </p:nvGrpSpPr>
+      <p:grpSpPr/>
+      <p:sp>
+        <p:nvSpPr>
+          <p:cNvPr id="2" name="TextBox 1"/>
+          <p:cNvSpPr txBox="1"/>
+          <p:nvPr/>
+        </p:nvSpPr>
+        <p:spPr>
+          <a:xfrm>
+            <a:off x="548640" y="274320"/>
+            <a:ext cx="11064240" cy="822960"/>
+          </a:xfrm>
+          <a:prstGeom prst="rect">
+            <a:avLst/>
+          </a:prstGeom>
+          <a:noFill/>
+        </p:spPr>
+        <p:txBody>
+          <a:bodyPr wrap="none">
+            <a:spAutoFit/>
+          </a:bodyPr>
+          <a:lstStyle/>
+          <a:p>
+            <a:pPr>
+              <a:defRPr sz="3000" b="1">
+                <a:solidFill>
+                  <a:srgbClr val="1F4E79"/>
+                </a:solidFill>
+              </a:defRPr>
+            </a:pPr>
+            <a:r>
+              <a:t>源代码与GitHub仓库</a:t>
+            </a:r>
+          </a:p>
+        </p:txBody>
+      </p:sp>
+      <p:sp>
+        <p:nvSpPr>
+          <p:cNvPr id="3" name="TextBox 2"/>
+          <p:cNvSpPr txBox="1"/>
+          <p:nvPr/>
+        </p:nvSpPr>
+        <p:spPr>
+          <a:xfrm>
+            <a:off x="731520" y="1371600"/>
+            <a:ext cx="10698480" cy="640080"/>
+          </a:xfrm>
+          <a:prstGeom prst="rect">
+            <a:avLst/>
+          </a:prstGeom>
+          <a:noFill/>
+        </p:spPr>
+        <p:txBody>
+          <a:bodyPr wrap="none">
+            <a:spAutoFit/>
+          </a:bodyPr>
+          <a:lstStyle/>
+          <a:p>
+            <a:r>
+              <a:rPr sz="2200">
+                <a:solidFill>
+                  <a:srgbClr val="0563C1"/>
+                </a:solidFill>
+                <a:hlinkClick r:id="rId2"/>
+              </a:rPr>
+              <a:t>GitHub仓库：https://github.com/wyyy520/BikeDemand</a:t>
+            </a:r>
+          </a:p>
+        </p:txBody>
+      </p:sp>
+      <p:sp>
+        <p:nvSpPr>
+          <p:cNvPr id="4" name="TextBox 3"/>
+          <p:cNvSpPr txBox="1"/>
+          <p:nvPr/>
+        </p:nvSpPr>
+        <p:spPr>
+          <a:xfrm>
+            <a:off x="731520" y="2194560"/>
+            <a:ext cx="10698480" cy="4389120"/>
+          </a:xfrm>
+          <a:prstGeom prst="rect">
+            <a:avLst/>
+          </a:prstGeom>
+          <a:noFill/>
+        </p:spPr>
+        <p:txBody>
+          <a:bodyPr wrap="square">
+            <a:spAutoFit/>
+          </a:bodyPr>
+          <a:lstStyle/>
+          <a:p>
+            <a:pPr>
+              <a:defRPr sz="2000">
+                <a:solidFill>
+                  <a:srgbClr val="333333"/>
+                </a:solidFill>
+              </a:defRPr>
+            </a:pPr>
+            <a:r>
+              <a:t>主要源代码结构：</a:t>
+            </a:r>
+          </a:p>
+          <a:p>
+            <a:pPr lvl="1">
+              <a:defRPr sz="1800">
+                <a:solidFill>
+                  <a:srgbClr val="333333"/>
+                </a:solidFill>
+              </a:defRPr>
+            </a:pPr>
+            <a:r>
+              <a:t>src/fetch_orders_sqlite.py  - API爬取订单数据，存入SQLite</a:t>
+            </a:r>
+          </a:p>
+          <a:p>
+            <a:pPr lvl="1">
+              <a:defRPr sz="1800">
+                <a:solidFill>
+                  <a:srgbClr val="333333"/>
+                </a:solidFill>
+              </a:defRPr>
+            </a:pPr>
+            <a:r>
+              <a:t>src/clean_orders.py        - 数据清洗（去重、去异常）</a:t>
+            </a:r>
+          </a:p>
+          <a:p>
+            <a:pPr lvl="1">
+              <a:defRPr sz="1800">
+                <a:solidFill>
+                  <a:srgbClr val="333333"/>
+                </a:solidFill>
+              </a:defRPr>
+            </a:pPr>
+            <a:r>
+              <a:t>src/aggregate_demand.py    - 时空网格聚合，生成30min需求矩阵</a:t>
+            </a:r>
+          </a:p>
+          <a:p>
+            <a:pPr lvl="1">
+              <a:defRPr sz="1800">
+                <a:solidFill>
+                  <a:srgbClr val="333333"/>
+                </a:solidFill>
+              </a:defRPr>
+            </a:pPr>
+            <a:r>
+              <a:t>src/transformer_model.py   - Transformer模型定义（含空间注意力）</a:t>
+            </a:r>
+          </a:p>
+          <a:p>
+            <a:pPr lvl="1">
+              <a:defRPr sz="1800">
+                <a:solidFill>
+                  <a:srgbClr val="333333"/>
+                </a:solidFill>
+              </a:defRPr>
+            </a:pPr>
+            <a:r>
+              <a:t>src/lstm_model.py          - LSTM模型定义</a:t>
+            </a:r>
+          </a:p>
+          <a:p>
+            <a:pPr lvl="1">
+              <a:defRPr sz="1800">
+                <a:solidFill>
+                  <a:srgbClr val="333333"/>
+                </a:solidFill>
+              </a:defRPr>
+            </a:pPr>
+            <a:r>
+              <a:t>src/train_transformer.py   - Transformer训练与评估脚本</a:t>
+            </a:r>
+          </a:p>
+          <a:p>
+            <a:pPr lvl="1">
+              <a:defRPr sz="1800">
+                <a:solidFill>
+                  <a:srgbClr val="333333"/>
+                </a:solidFill>
+              </a:defRPr>
+            </a:pPr>
+            <a:r>
+              <a:t>src/train_lstm.py          - LSTM训练与评估脚本</a:t>
+            </a:r>
+          </a:p>
+          <a:p>
+            <a:pPr>
+              <a:defRPr sz="800">
+                <a:solidFill>
+                  <a:srgbClr val="333333"/>
+                </a:solidFill>
+              </a:defRPr>
+            </a:pPr>
+          </a:p>
+          <a:p>
+            <a:pPr lvl="1">
+              <a:defRPr sz="1800">
+                <a:solidFill>
+                  <a:srgbClr val="333333"/>
+                </a:solidFill>
+              </a:defRPr>
+            </a:pPr>
+            <a:r>
+              <a:t>report/analysis.pdf        - 完整分析报告</a:t>
+            </a:r>
+          </a:p>
+          <a:p>
+            <a:pPr lvl="1">
+              <a:defRPr sz="1800">
+                <a:solidFill>
+                  <a:srgbClr val="333333"/>
+                </a:solidFill>
+              </a:defRPr>
+            </a:pPr>
+            <a:r>
+              <a:t>report/presentation.pptx   - 汇报PPT</a:t>
+            </a:r>
+          </a:p>
+        </p:txBody>
+      </p:sp>
+    </p:spTree>
+  </p:cSld>
+  <p:clrMapOvr>
+    <a:masterClrMapping/>
+  </p:clrMapOvr>
+</p:sld>
+</file>
+
 <file path=ppt/slides/slide3.xml><?xml version="1.0" encoding="utf-8"?>
 <p:sld xmlns:a="http://schemas.openxmlformats.org/drawingml/2006/main" xmlns:p="http://schemas.openxmlformats.org/presentationml/2006/main" xmlns:r="http://schemas.openxmlformats.org/officeDocument/2006/relationships">
   <p:cSld>
@@ -3756,14 +4760,14 @@
               </a:defRPr>
             </a:pPr>
             <a:r>
-              <a:t>数据特征：时间分布（1/5）</a:t>
+              <a:t>开发过程：数据爬取</a:t>
             </a:r>
           </a:p>
         </p:txBody>
       </p:sp>
       <p:pic>
         <p:nvPicPr>
-          <p:cNvPr id="3" name="Picture 2" descr="daily_orders.png"/>
+          <p:cNvPr id="3" name="Picture 2" descr="爬取300万数据集数据库.png"/>
           <p:cNvPicPr>
             <a:picLocks noChangeAspect="1"/>
           </p:cNvPicPr>
@@ -3777,14 +4781,73 @@
         </p:blipFill>
         <p:spPr>
           <a:xfrm>
-            <a:off x="548640" y="1280160"/>
-            <a:ext cx="9601200" cy="3413760"/>
+            <a:off x="731520" y="1188720"/>
+            <a:ext cx="5029200" cy="2445101"/>
           </a:xfrm>
           <a:prstGeom prst="rect">
             <a:avLst/>
           </a:prstGeom>
         </p:spPr>
       </p:pic>
+      <p:pic>
+        <p:nvPicPr>
+          <p:cNvPr id="4" name="Picture 3" descr="爬取完成.png"/>
+          <p:cNvPicPr>
+            <a:picLocks noChangeAspect="1"/>
+          </p:cNvPicPr>
+          <p:nvPr/>
+        </p:nvPicPr>
+        <p:blipFill>
+          <a:blip r:embed="rId3"/>
+          <a:stretch>
+            <a:fillRect/>
+          </a:stretch>
+        </p:blipFill>
+        <p:spPr>
+          <a:xfrm>
+            <a:off x="6035040" y="1188720"/>
+            <a:ext cx="5029200" cy="4860937"/>
+          </a:xfrm>
+          <a:prstGeom prst="rect">
+            <a:avLst/>
+          </a:prstGeom>
+        </p:spPr>
+      </p:pic>
+      <p:sp>
+        <p:nvSpPr>
+          <p:cNvPr id="5" name="TextBox 4"/>
+          <p:cNvSpPr txBox="1"/>
+          <p:nvPr/>
+        </p:nvSpPr>
+        <p:spPr>
+          <a:xfrm>
+            <a:off x="548640" y="6035040"/>
+            <a:ext cx="11064240" cy="640080"/>
+          </a:xfrm>
+          <a:prstGeom prst="rect">
+            <a:avLst/>
+          </a:prstGeom>
+          <a:noFill/>
+        </p:spPr>
+        <p:txBody>
+          <a:bodyPr wrap="none">
+            <a:spAutoFit/>
+          </a:bodyPr>
+          <a:lstStyle/>
+          <a:p>
+            <a:pPr>
+              <a:defRPr sz="1400">
+                <a:solidFill>
+                  <a:srgbClr val="646464"/>
+                </a:solidFill>
+              </a:defRPr>
+            </a:pPr>
+            <a:r>
+              <a:t>通过API爬取约300万条订单数据存入SQLite</a:t>
+            </a:r>
+          </a:p>
+        </p:txBody>
+      </p:sp>
     </p:spTree>
   </p:cSld>
   <p:clrMapOvr>
@@ -3833,14 +4896,14 @@
               </a:defRPr>
             </a:pPr>
             <a:r>
-              <a:t>数据特征：高量段日内双峰（2/5）</a:t>
+              <a:t>开发过程：环境配置</a:t>
             </a:r>
           </a:p>
         </p:txBody>
       </p:sp>
       <p:pic>
         <p:nvPicPr>
-          <p:cNvPr id="3" name="Picture 2" descr="high_volume_series.png"/>
+          <p:cNvPr id="3" name="Picture 2" descr="下载pytorch.png"/>
           <p:cNvPicPr>
             <a:picLocks noChangeAspect="1"/>
           </p:cNvPicPr>
@@ -3854,14 +4917,73 @@
         </p:blipFill>
         <p:spPr>
           <a:xfrm>
-            <a:off x="548640" y="1280160"/>
-            <a:ext cx="9601200" cy="3413760"/>
+            <a:off x="731520" y="1188720"/>
+            <a:ext cx="4114800" cy="4811316"/>
           </a:xfrm>
           <a:prstGeom prst="rect">
             <a:avLst/>
           </a:prstGeom>
         </p:spPr>
       </p:pic>
+      <p:pic>
+        <p:nvPicPr>
+          <p:cNvPr id="4" name="Picture 3" descr="虚拟环境验证pytorch.png"/>
+          <p:cNvPicPr>
+            <a:picLocks noChangeAspect="1"/>
+          </p:cNvPicPr>
+          <p:nvPr/>
+        </p:nvPicPr>
+        <p:blipFill>
+          <a:blip r:embed="rId3"/>
+          <a:stretch>
+            <a:fillRect/>
+          </a:stretch>
+        </p:blipFill>
+        <p:spPr>
+          <a:xfrm>
+            <a:off x="6035040" y="1188720"/>
+            <a:ext cx="5029200" cy="2763947"/>
+          </a:xfrm>
+          <a:prstGeom prst="rect">
+            <a:avLst/>
+          </a:prstGeom>
+        </p:spPr>
+      </p:pic>
+      <p:sp>
+        <p:nvSpPr>
+          <p:cNvPr id="5" name="TextBox 4"/>
+          <p:cNvSpPr txBox="1"/>
+          <p:nvPr/>
+        </p:nvSpPr>
+        <p:spPr>
+          <a:xfrm>
+            <a:off x="548640" y="6035040"/>
+            <a:ext cx="11064240" cy="640080"/>
+          </a:xfrm>
+          <a:prstGeom prst="rect">
+            <a:avLst/>
+          </a:prstGeom>
+          <a:noFill/>
+        </p:spPr>
+        <p:txBody>
+          <a:bodyPr wrap="none">
+            <a:spAutoFit/>
+          </a:bodyPr>
+          <a:lstStyle/>
+          <a:p>
+            <a:pPr>
+              <a:defRPr sz="1400">
+                <a:solidFill>
+                  <a:srgbClr val="646464"/>
+                </a:solidFill>
+              </a:defRPr>
+            </a:pPr>
+            <a:r>
+              <a:t>PyTorch虚拟环境配置与CUDA验证</a:t>
+            </a:r>
+          </a:p>
+        </p:txBody>
+      </p:sp>
     </p:spTree>
   </p:cSld>
   <p:clrMapOvr>
@@ -3910,21 +5032,45 @@
               </a:defRPr>
             </a:pPr>
             <a:r>
-              <a:t>特征构造方法</a:t>
-            </a:r>
-          </a:p>
-        </p:txBody>
-      </p:sp>
-      <p:sp>
-        <p:nvSpPr>
-          <p:cNvPr id="3" name="TextBox 2"/>
+              <a:t>开发过程：空间网格划分</a:t>
+            </a:r>
+          </a:p>
+        </p:txBody>
+      </p:sp>
+      <p:pic>
+        <p:nvPicPr>
+          <p:cNvPr id="3" name="Picture 2" descr="分区块.png"/>
+          <p:cNvPicPr>
+            <a:picLocks noChangeAspect="1"/>
+          </p:cNvPicPr>
+          <p:nvPr/>
+        </p:nvPicPr>
+        <p:blipFill>
+          <a:blip r:embed="rId2"/>
+          <a:stretch>
+            <a:fillRect/>
+          </a:stretch>
+        </p:blipFill>
+        <p:spPr>
+          <a:xfrm>
+            <a:off x="731520" y="1188720"/>
+            <a:ext cx="4114800" cy="4676361"/>
+          </a:xfrm>
+          <a:prstGeom prst="rect">
+            <a:avLst/>
+          </a:prstGeom>
+        </p:spPr>
+      </p:pic>
+      <p:sp>
+        <p:nvSpPr>
+          <p:cNvPr id="4" name="TextBox 3"/>
           <p:cNvSpPr txBox="1"/>
           <p:nvPr/>
         </p:nvSpPr>
         <p:spPr>
           <a:xfrm>
-            <a:off x="731520" y="1280160"/>
-            <a:ext cx="10698480" cy="2286000"/>
+            <a:off x="548640" y="6035040"/>
+            <a:ext cx="11064240" cy="640080"/>
           </a:xfrm>
           <a:prstGeom prst="rect">
             <a:avLst/>
@@ -3932,104 +5078,20 @@
           <a:noFill/>
         </p:spPr>
         <p:txBody>
-          <a:bodyPr wrap="square">
+          <a:bodyPr wrap="none">
             <a:spAutoFit/>
           </a:bodyPr>
           <a:lstStyle/>
           <a:p>
             <a:pPr>
-              <a:defRPr sz="1800">
-                <a:solidFill>
-                  <a:srgbClr val="333333"/>
-                </a:solidFill>
-              </a:defRPr>
-            </a:pPr>
-            <a:r>
-              <a:t>需求特征：过去24小时（48步）30网格借/还车量，共 48 × 60 = 2880 维</a:t>
-            </a:r>
-          </a:p>
-          <a:p>
-            <a:pPr>
-              <a:defRPr sz="1800">
-                <a:solidFill>
-                  <a:srgbClr val="333333"/>
-                </a:solidFill>
-              </a:defRPr>
-            </a:pPr>
-            <a:r>
-              <a:t>滞后特征：前一日同时刻（lag=48）借/还车量，共60维 → 显式提供previous-day信号</a:t>
-            </a:r>
-          </a:p>
-          <a:p>
-            <a:pPr>
-              <a:defRPr sz="1800">
-                <a:solidFill>
-                  <a:srgbClr val="333333"/>
-                </a:solidFill>
-              </a:defRPr>
-            </a:pPr>
-            <a:r>
-              <a:t>时间周期特征（5维）：</a:t>
-            </a:r>
-          </a:p>
-          <a:p>
-            <a:pPr lvl="1">
-              <a:defRPr sz="1600">
-                <a:solidFill>
-                  <a:srgbClr val="333333"/>
-                </a:solidFill>
-              </a:defRPr>
-            </a:pPr>
-            <a:r>
-              <a:t>日内正弦/余弦：sin(2πt/48), cos(2πt/48)</a:t>
-            </a:r>
-          </a:p>
-          <a:p>
-            <a:pPr lvl="1">
-              <a:defRPr sz="1600">
-                <a:solidFill>
-                  <a:srgbClr val="333333"/>
-                </a:solidFill>
-              </a:defRPr>
-            </a:pPr>
-            <a:r>
-              <a:t>周内正弦/余弦：sin(2πd/7), cos(2πd/7)</a:t>
-            </a:r>
-          </a:p>
-          <a:p>
-            <a:pPr lvl="1">
-              <a:defRPr sz="1600">
-                <a:solidFill>
-                  <a:srgbClr val="333333"/>
-                </a:solidFill>
-              </a:defRPr>
-            </a:pPr>
-            <a:r>
-              <a:t>周末二值标记：周六日=1，其余=0</a:t>
-            </a:r>
-          </a:p>
-          <a:p>
-            <a:pPr>
-              <a:defRPr sz="1800">
-                <a:solidFill>
-                  <a:srgbClr val="333333"/>
-                </a:solidFill>
-              </a:defRPr>
-            </a:pPr>
-            <a:r>
-              <a:t>标准化：训练集上z-score，避免数据泄露</a:t>
-            </a:r>
-          </a:p>
-          <a:p>
-            <a:pPr>
-              <a:defRPr sz="1800">
-                <a:solidFill>
-                  <a:srgbClr val="333333"/>
-                </a:solidFill>
-              </a:defRPr>
-            </a:pPr>
-            <a:r>
-              <a:t>输出：未来30分钟60维需求向量（借车30 + 还车30）</a:t>
+              <a:defRPr sz="1400">
+                <a:solidFill>
+                  <a:srgbClr val="646464"/>
+                </a:solidFill>
+              </a:defRPr>
+            </a:pPr>
+            <a:r>
+              <a:t>城市空间划分成0.01°×0.01°网格，筛选高需求区域</a:t>
             </a:r>
           </a:p>
         </p:txBody>
@@ -4082,112 +5144,59 @@
               </a:defRPr>
             </a:pPr>
             <a:r>
-              <a:t>训练集与测试集划分（按日期）</a:t>
-            </a:r>
-          </a:p>
-        </p:txBody>
-      </p:sp>
-      <p:sp>
-        <p:nvSpPr>
-          <p:cNvPr id="3" name="TextBox 2"/>
-          <p:cNvSpPr txBox="1"/>
+              <a:t>开发过程：Transformer首次训练</a:t>
+            </a:r>
+          </a:p>
+        </p:txBody>
+      </p:sp>
+      <p:pic>
+        <p:nvPicPr>
+          <p:cNvPr id="3" name="Picture 2" descr="transformer第一次训练.png"/>
+          <p:cNvPicPr>
+            <a:picLocks noChangeAspect="1"/>
+          </p:cNvPicPr>
           <p:nvPr/>
-        </p:nvSpPr>
-        <p:spPr>
-          <a:xfrm>
-            <a:off x="731520" y="1280160"/>
-            <a:ext cx="10698480" cy="2286000"/>
+        </p:nvPicPr>
+        <p:blipFill>
+          <a:blip r:embed="rId2"/>
+          <a:stretch>
+            <a:fillRect/>
+          </a:stretch>
+        </p:blipFill>
+        <p:spPr>
+          <a:xfrm>
+            <a:off x="731520" y="1188720"/>
+            <a:ext cx="3840480" cy="4337232"/>
           </a:xfrm>
           <a:prstGeom prst="rect">
             <a:avLst/>
           </a:prstGeom>
-          <a:noFill/>
-        </p:spPr>
-        <p:txBody>
-          <a:bodyPr wrap="square">
-            <a:spAutoFit/>
-          </a:bodyPr>
-          <a:lstStyle/>
-          <a:p>
-            <a:pPr>
-              <a:defRPr sz="2000">
-                <a:solidFill>
-                  <a:srgbClr val="333333"/>
-                </a:solidFill>
-              </a:defRPr>
-            </a:pPr>
-            <a:r>
-              <a:t>发现数据分布严重不均匀（前29天几乎无订单），改为按日期划分：</a:t>
-            </a:r>
-          </a:p>
-          <a:p>
-            <a:pPr>
-              <a:defRPr sz="1000">
-                <a:solidFill>
-                  <a:srgbClr val="333333"/>
-                </a:solidFill>
-              </a:defRPr>
-            </a:pPr>
-          </a:p>
-          <a:p>
-            <a:pPr>
-              <a:defRPr sz="2000">
-                <a:solidFill>
-                  <a:srgbClr val="333333"/>
-                </a:solidFill>
-              </a:defRPr>
-            </a:pPr>
-            <a:r>
-              <a:t>训练集：2021-01-30 13:00 — 2021-01-31 20:00（高量段）</a:t>
-            </a:r>
-          </a:p>
-          <a:p>
-            <a:pPr>
-              <a:defRPr sz="2000">
-                <a:solidFill>
-                  <a:srgbClr val="333333"/>
-                </a:solidFill>
-              </a:defRPr>
-            </a:pPr>
-            <a:r>
-              <a:t>验证集：2021-01-31 20:00 — 2021-02-01 04:00</a:t>
-            </a:r>
-          </a:p>
-          <a:p>
-            <a:pPr>
-              <a:defRPr sz="2000">
-                <a:solidFill>
-                  <a:srgbClr val="333333"/>
-                </a:solidFill>
-              </a:defRPr>
-            </a:pPr>
-            <a:r>
-              <a:t>测试集：2021-02-01 04:00 — 2021-02-02 14:00</a:t>
-            </a:r>
-          </a:p>
-          <a:p>
-            <a:pPr>
-              <a:defRPr sz="1000">
-                <a:solidFill>
-                  <a:srgbClr val="333333"/>
-                </a:solidFill>
-              </a:defRPr>
-            </a:pPr>
-          </a:p>
-          <a:p>
-            <a:pPr>
-              <a:defRPr sz="2000">
-                <a:solidFill>
-                  <a:srgbClr val="333333"/>
-                </a:solidFill>
-              </a:defRPr>
-            </a:pPr>
-            <a:r>
-              <a:t>lookback = 48（过去24小时） → 预测 horizon = 1（未来30分钟）</a:t>
-            </a:r>
-          </a:p>
-        </p:txBody>
-      </p:sp>
+        </p:spPr>
+      </p:pic>
+      <p:pic>
+        <p:nvPicPr>
+          <p:cNvPr id="4" name="Picture 3" descr="transformer第一次训练结果.png"/>
+          <p:cNvPicPr>
+            <a:picLocks noChangeAspect="1"/>
+          </p:cNvPicPr>
+          <p:nvPr/>
+        </p:nvPicPr>
+        <p:blipFill>
+          <a:blip r:embed="rId3"/>
+          <a:stretch>
+            <a:fillRect/>
+          </a:stretch>
+        </p:blipFill>
+        <p:spPr>
+          <a:xfrm>
+            <a:off x="6035040" y="1188720"/>
+            <a:ext cx="3840480" cy="4607553"/>
+          </a:xfrm>
+          <a:prstGeom prst="rect">
+            <a:avLst/>
+          </a:prstGeom>
+        </p:spPr>
+      </p:pic>
     </p:spTree>
   </p:cSld>
   <p:clrMapOvr>
@@ -4236,21 +5245,69 @@
               </a:defRPr>
             </a:pPr>
             <a:r>
-              <a:t>模型架构：Transformer + 残差学习</a:t>
-            </a:r>
-          </a:p>
-        </p:txBody>
-      </p:sp>
-      <p:sp>
-        <p:nvSpPr>
-          <p:cNvPr id="3" name="TextBox 2"/>
+              <a:t>开发过程：LSTM与调优</a:t>
+            </a:r>
+          </a:p>
+        </p:txBody>
+      </p:sp>
+      <p:pic>
+        <p:nvPicPr>
+          <p:cNvPr id="3" name="Picture 2" descr="优化后的transformer.png"/>
+          <p:cNvPicPr>
+            <a:picLocks noChangeAspect="1"/>
+          </p:cNvPicPr>
+          <p:nvPr/>
+        </p:nvPicPr>
+        <p:blipFill>
+          <a:blip r:embed="rId2"/>
+          <a:stretch>
+            <a:fillRect/>
+          </a:stretch>
+        </p:blipFill>
+        <p:spPr>
+          <a:xfrm>
+            <a:off x="731520" y="1188720"/>
+            <a:ext cx="3840480" cy="4158039"/>
+          </a:xfrm>
+          <a:prstGeom prst="rect">
+            <a:avLst/>
+          </a:prstGeom>
+        </p:spPr>
+      </p:pic>
+      <p:pic>
+        <p:nvPicPr>
+          <p:cNvPr id="4" name="Picture 3" descr="lstm第一次训练结果.png"/>
+          <p:cNvPicPr>
+            <a:picLocks noChangeAspect="1"/>
+          </p:cNvPicPr>
+          <p:nvPr/>
+        </p:nvPicPr>
+        <p:blipFill>
+          <a:blip r:embed="rId3"/>
+          <a:stretch>
+            <a:fillRect/>
+          </a:stretch>
+        </p:blipFill>
+        <p:spPr>
+          <a:xfrm>
+            <a:off x="6035040" y="1188720"/>
+            <a:ext cx="3840480" cy="4607553"/>
+          </a:xfrm>
+          <a:prstGeom prst="rect">
+            <a:avLst/>
+          </a:prstGeom>
+        </p:spPr>
+      </p:pic>
+      <p:sp>
+        <p:nvSpPr>
+          <p:cNvPr id="5" name="TextBox 4"/>
           <p:cNvSpPr txBox="1"/>
           <p:nvPr/>
         </p:nvSpPr>
         <p:spPr>
           <a:xfrm>
-            <a:off x="731520" y="1280160"/>
-            <a:ext cx="10698480" cy="2286000"/>
+            <a:off x="548640" y="6035040"/>
+            <a:ext cx="11064240" cy="640080"/>
           </a:xfrm>
           <a:prstGeom prst="rect">
             <a:avLst/>
@@ -4258,86 +5315,20 @@
           <a:noFill/>
         </p:spPr>
         <p:txBody>
-          <a:bodyPr wrap="square">
+          <a:bodyPr wrap="none">
             <a:spAutoFit/>
           </a:bodyPr>
           <a:lstStyle/>
           <a:p>
             <a:pPr>
-              <a:defRPr sz="2000">
-                <a:solidFill>
-                  <a:srgbClr val="333333"/>
-                </a:solidFill>
-              </a:defRPr>
-            </a:pPr>
-            <a:r>
-              <a:t>核心设计：预测目标 = 需求 - 前一日同时刻需求（残差），评估时加回基线还原</a:t>
-            </a:r>
-          </a:p>
-          <a:p>
-            <a:pPr>
-              <a:defRPr sz="1000">
-                <a:solidFill>
-                  <a:srgbClr val="333333"/>
-                </a:solidFill>
-              </a:defRPr>
-            </a:pPr>
-          </a:p>
-          <a:p>
-            <a:pPr>
-              <a:defRPr sz="2000">
-                <a:solidFill>
-                  <a:srgbClr val="333333"/>
-                </a:solidFill>
-              </a:defRPr>
-            </a:pPr>
-            <a:r>
-              <a:t>输入投影：Linear(2945 → d_model=64) + LayerNorm + 正弦位置编码</a:t>
-            </a:r>
-          </a:p>
-          <a:p>
-            <a:pPr>
-              <a:defRPr sz="2000">
-                <a:solidFill>
-                  <a:srgbClr val="333333"/>
-                </a:solidFill>
-              </a:defRPr>
-            </a:pPr>
-            <a:r>
-              <a:t>时间编码器：2层TransformerEncoder，nhead=4，FFN=128，norm_first=True</a:t>
-            </a:r>
-          </a:p>
-          <a:p>
-            <a:pPr>
-              <a:defRPr sz="2000">
-                <a:solidFill>
-                  <a:srgbClr val="333333"/>
-                </a:solidFill>
-              </a:defRPr>
-            </a:pPr>
-            <a:r>
-              <a:t>输出头：LayerNorm + Linear(d_model → 60)，取最后时间步输出</a:t>
-            </a:r>
-          </a:p>
-          <a:p>
-            <a:pPr>
-              <a:defRPr sz="1000">
-                <a:solidFill>
-                  <a:srgbClr val="333333"/>
-                </a:solidFill>
-              </a:defRPr>
-            </a:pPr>
-          </a:p>
-          <a:p>
-            <a:pPr>
-              <a:defRPr sz="2000">
-                <a:solidFill>
-                  <a:srgbClr val="333333"/>
-                </a:solidFill>
-              </a:defRPr>
-            </a:pPr>
-            <a:r>
-              <a:t>残差学习使模型从previous-day水平出发学习修正量，稳定训练过程</a:t>
+              <a:defRPr sz="1400">
+                <a:solidFill>
+                  <a:srgbClr val="646464"/>
+                </a:solidFill>
+              </a:defRPr>
+            </a:pPr>
+            <a:r>
+              <a:t>Transformer调优后 vs LSTM首次训练结果</a:t>
             </a:r>
           </a:p>
         </p:txBody>
@@ -4390,21 +5381,45 @@
               </a:defRPr>
             </a:pPr>
             <a:r>
-              <a:t>评价指标</a:t>
-            </a:r>
-          </a:p>
-        </p:txBody>
-      </p:sp>
-      <p:sp>
-        <p:nvSpPr>
-          <p:cNvPr id="3" name="TextBox 2"/>
+              <a:t>开发过程：LSTM调优</a:t>
+            </a:r>
+          </a:p>
+        </p:txBody>
+      </p:sp>
+      <p:pic>
+        <p:nvPicPr>
+          <p:cNvPr id="3" name="Picture 2" descr="优化后的lstm.png"/>
+          <p:cNvPicPr>
+            <a:picLocks noChangeAspect="1"/>
+          </p:cNvPicPr>
+          <p:nvPr/>
+        </p:nvPicPr>
+        <p:blipFill>
+          <a:blip r:embed="rId2"/>
+          <a:stretch>
+            <a:fillRect/>
+          </a:stretch>
+        </p:blipFill>
+        <p:spPr>
+          <a:xfrm>
+            <a:off x="731520" y="1188720"/>
+            <a:ext cx="3840480" cy="4158039"/>
+          </a:xfrm>
+          <a:prstGeom prst="rect">
+            <a:avLst/>
+          </a:prstGeom>
+        </p:spPr>
+      </p:pic>
+      <p:sp>
+        <p:nvSpPr>
+          <p:cNvPr id="4" name="TextBox 3"/>
           <p:cNvSpPr txBox="1"/>
           <p:nvPr/>
         </p:nvSpPr>
         <p:spPr>
           <a:xfrm>
-            <a:off x="731520" y="1280160"/>
-            <a:ext cx="10698480" cy="2286000"/>
+            <a:off x="548640" y="6035040"/>
+            <a:ext cx="11064240" cy="640080"/>
           </a:xfrm>
           <a:prstGeom prst="rect">
             <a:avLst/>
@@ -4412,56 +5427,20 @@
           <a:noFill/>
         </p:spPr>
         <p:txBody>
-          <a:bodyPr wrap="square">
+          <a:bodyPr wrap="none">
             <a:spAutoFit/>
           </a:bodyPr>
           <a:lstStyle/>
           <a:p>
             <a:pPr>
-              <a:defRPr sz="2000">
-                <a:solidFill>
-                  <a:srgbClr val="333333"/>
-                </a:solidFill>
-              </a:defRPr>
-            </a:pPr>
-            <a:r>
-              <a:t>MAE（平均绝对误差）：对异常值不敏感，直观反映平均偏差</a:t>
-            </a:r>
-          </a:p>
-          <a:p>
-            <a:pPr>
-              <a:defRPr sz="2000">
-                <a:solidFill>
-                  <a:srgbClr val="333333"/>
-                </a:solidFill>
-              </a:defRPr>
-            </a:pPr>
-            <a:r>
-              <a:t>RMSE（均方根误差）：对大误差敏感，反映峰值时段表现</a:t>
-            </a:r>
-          </a:p>
-          <a:p>
-            <a:pPr>
-              <a:defRPr sz="2000">
-                <a:solidFill>
-                  <a:srgbClr val="333333"/>
-                </a:solidFill>
-              </a:defRPr>
-            </a:pPr>
-            <a:r>
-              <a:t>MAPE（百分比误差）：当真值接近0时数值爆炸，本数据夜间时段MAPE可达数千%</a:t>
-            </a:r>
-          </a:p>
-          <a:p>
-            <a:pPr>
-              <a:defRPr sz="2000">
-                <a:solidFill>
-                  <a:srgbClr val="333333"/>
-                </a:solidFill>
-              </a:defRPr>
-            </a:pPr>
-            <a:r>
-              <a:t>WMAPE（加权百分比误差）：以总需求为分母，更稳健，本实验主要参考指标</a:t>
+              <a:defRPr sz="1400">
+                <a:solidFill>
+                  <a:srgbClr val="646464"/>
+                </a:solidFill>
+              </a:defRPr>
+            </a:pPr>
+            <a:r>
+              <a:t>LSTM调优后训练曲线</a:t>
             </a:r>
           </a:p>
         </p:txBody>
@@ -4514,14 +5493,14 @@
               </a:defRPr>
             </a:pPr>
             <a:r>
-              <a:t>模型误差对比（3/5）</a:t>
+              <a:t>数据特征：时间分布（1/5）</a:t>
             </a:r>
           </a:p>
         </p:txBody>
       </p:sp>
       <p:pic>
         <p:nvPicPr>
-          <p:cNvPr id="3" name="Picture 2" descr="model_compare.png"/>
+          <p:cNvPr id="3" name="Picture 2" descr="daily_orders.png"/>
           <p:cNvPicPr>
             <a:picLocks noChangeAspect="1"/>
           </p:cNvPicPr>
@@ -4536,7 +5515,7 @@
         <p:spPr>
           <a:xfrm>
             <a:off x="548640" y="1280160"/>
-            <a:ext cx="8229600" cy="4051495"/>
+            <a:ext cx="9601200" cy="3413760"/>
           </a:xfrm>
           <a:prstGeom prst="rect">
             <a:avLst/>

</xml_diff>

<commit_message>
Add source code slides to presentation
</commit_message>
<xml_diff>
--- a/report/presentation.pptx
+++ b/report/presentation.pptx
@@ -25,6 +25,24 @@
     <p:sldId id="267" r:id="rId18"/>
     <p:sldId id="268" r:id="rId19"/>
     <p:sldId id="275" r:id="rId26"/>
+    <p:sldId id="276" r:id="rId27"/>
+    <p:sldId id="277" r:id="rId28"/>
+    <p:sldId id="278" r:id="rId29"/>
+    <p:sldId id="279" r:id="rId30"/>
+    <p:sldId id="280" r:id="rId31"/>
+    <p:sldId id="281" r:id="rId32"/>
+    <p:sldId id="282" r:id="rId33"/>
+    <p:sldId id="283" r:id="rId34"/>
+    <p:sldId id="284" r:id="rId35"/>
+    <p:sldId id="285" r:id="rId36"/>
+    <p:sldId id="286" r:id="rId37"/>
+    <p:sldId id="287" r:id="rId38"/>
+    <p:sldId id="288" r:id="rId39"/>
+    <p:sldId id="289" r:id="rId40"/>
+    <p:sldId id="290" r:id="rId41"/>
+    <p:sldId id="291" r:id="rId42"/>
+    <p:sldId id="292" r:id="rId43"/>
+    <p:sldId id="293" r:id="rId44"/>
   </p:sldIdLst>
   <p:sldSz cx="12191695" cy="6858000" type="screen4x3"/>
   <p:notesSz cx="6858000" cy="9144000"/>
@@ -4720,6 +4738,999 @@
 </p:sld>
 </file>
 
+<file path=ppt/slides/slide21.xml><?xml version="1.0" encoding="utf-8"?>
+<p:sld xmlns:a="http://schemas.openxmlformats.org/drawingml/2006/main" xmlns:p="http://schemas.openxmlformats.org/presentationml/2006/main" xmlns:r="http://schemas.openxmlformats.org/officeDocument/2006/relationships">
+  <p:cSld>
+    <p:spTree>
+      <p:nvGrpSpPr>
+        <p:cNvPr id="1" name=""/>
+        <p:cNvGrpSpPr/>
+        <p:nvPr/>
+      </p:nvGrpSpPr>
+      <p:grpSpPr/>
+      <p:sp>
+        <p:nvSpPr>
+          <p:cNvPr id="2" name="TextBox 1"/>
+          <p:cNvSpPr txBox="1"/>
+          <p:nvPr/>
+        </p:nvSpPr>
+        <p:spPr>
+          <a:xfrm>
+            <a:off x="548640" y="228600"/>
+            <a:ext cx="11064240" cy="640080"/>
+          </a:xfrm>
+          <a:prstGeom prst="rect">
+            <a:avLst/>
+          </a:prstGeom>
+          <a:noFill/>
+        </p:spPr>
+        <p:txBody>
+          <a:bodyPr wrap="none">
+            <a:spAutoFit/>
+          </a:bodyPr>
+          <a:lstStyle/>
+          <a:p>
+            <a:pPr>
+              <a:defRPr sz="2000" b="1">
+                <a:solidFill>
+                  <a:srgbClr val="1F4E79"/>
+                </a:solidFill>
+              </a:defRPr>
+            </a:pPr>
+            <a:r>
+              <a:t>源代码：Transformer模型定义 - transformer_model.py (1/4)</a:t>
+            </a:r>
+          </a:p>
+        </p:txBody>
+      </p:sp>
+      <p:sp>
+        <p:nvSpPr>
+          <p:cNvPr id="3" name="TextBox 2"/>
+          <p:cNvSpPr txBox="1"/>
+          <p:nvPr/>
+        </p:nvSpPr>
+        <p:spPr>
+          <a:xfrm>
+            <a:off x="457200" y="914400"/>
+            <a:ext cx="11247120" cy="5760720"/>
+          </a:xfrm>
+          <a:prstGeom prst="rect">
+            <a:avLst/>
+          </a:prstGeom>
+          <a:noFill/>
+        </p:spPr>
+        <p:txBody>
+          <a:bodyPr wrap="none">
+            <a:spAutoFit/>
+          </a:bodyPr>
+          <a:lstStyle/>
+          <a:p>
+            <a:r>
+              <a:rPr sz="900">
+                <a:latin typeface="Consolas"/>
+              </a:rPr>
+              <a:t>"""多区域时序 Transformer Encoder。
+输入：X.shape == [batch, lookback, input_dim]
+输出：y_hat.shape == [batch, horizon, output_dim]
+对于 N 个空间网格，output_dim=2*N，前 N 个输出为借车量，后 N 个输出为还车量。
+"""
+from __future__ import annotations
+import math
+import torch
+from torch import Tensor, nn
+class SinusoidalPositionalEncoding(nn.Module):
+    def __init__(self, d_model: int, max_len: int = 512) -&gt; None:
+        super().__init__()
+        position = torch.arange(max_len, dtype=torch.float32).unsqueeze(1)
+        div_term = torch.exp(
+            torch.arange(0, d_model, 2, dtype=torch.float32)
+            * (-math.log(10000.0) / d_model)
+        )
+        encoding = torch.zeros(max_len, d_model)
+        encoding[:, 0::2] = torch.sin(position * div_term)
+        encoding[:, 1::2] = torch.cos(position * div_term[: encoding[:, 1::2].shape[1]])
+        self.register_buffer("encoding", encoding.unsqueeze(0), persistent=False)
+    def forward(self, x: Tensor) -&gt; Tensor:
+        return x + self.encoding[:, : x.size(1)]
+</a:t>
+            </a:r>
+          </a:p>
+        </p:txBody>
+      </p:sp>
+    </p:spTree>
+  </p:cSld>
+  <p:clrMapOvr>
+    <a:masterClrMapping/>
+  </p:clrMapOvr>
+</p:sld>
+</file>
+
+<file path=ppt/slides/slide22.xml><?xml version="1.0" encoding="utf-8"?>
+<p:sld xmlns:a="http://schemas.openxmlformats.org/drawingml/2006/main" xmlns:p="http://schemas.openxmlformats.org/presentationml/2006/main" xmlns:r="http://schemas.openxmlformats.org/officeDocument/2006/relationships">
+  <p:cSld>
+    <p:spTree>
+      <p:nvGrpSpPr>
+        <p:cNvPr id="1" name=""/>
+        <p:cNvGrpSpPr/>
+        <p:nvPr/>
+      </p:nvGrpSpPr>
+      <p:grpSpPr/>
+      <p:sp>
+        <p:nvSpPr>
+          <p:cNvPr id="2" name="TextBox 1"/>
+          <p:cNvSpPr txBox="1"/>
+          <p:nvPr/>
+        </p:nvSpPr>
+        <p:spPr>
+          <a:xfrm>
+            <a:off x="548640" y="228600"/>
+            <a:ext cx="11064240" cy="640080"/>
+          </a:xfrm>
+          <a:prstGeom prst="rect">
+            <a:avLst/>
+          </a:prstGeom>
+          <a:noFill/>
+        </p:spPr>
+        <p:txBody>
+          <a:bodyPr wrap="none">
+            <a:spAutoFit/>
+          </a:bodyPr>
+          <a:lstStyle/>
+          <a:p>
+            <a:pPr>
+              <a:defRPr sz="2000" b="1">
+                <a:solidFill>
+                  <a:srgbClr val="1F4E79"/>
+                </a:solidFill>
+              </a:defRPr>
+            </a:pPr>
+            <a:r>
+              <a:t>源代码：Transformer模型定义 - transformer_model.py (2/4)</a:t>
+            </a:r>
+          </a:p>
+        </p:txBody>
+      </p:sp>
+      <p:sp>
+        <p:nvSpPr>
+          <p:cNvPr id="3" name="TextBox 2"/>
+          <p:cNvSpPr txBox="1"/>
+          <p:nvPr/>
+        </p:nvSpPr>
+        <p:spPr>
+          <a:xfrm>
+            <a:off x="457200" y="914400"/>
+            <a:ext cx="11247120" cy="5760720"/>
+          </a:xfrm>
+          <a:prstGeom prst="rect">
+            <a:avLst/>
+          </a:prstGeom>
+          <a:noFill/>
+        </p:spPr>
+        <p:txBody>
+          <a:bodyPr wrap="none">
+            <a:spAutoFit/>
+          </a:bodyPr>
+          <a:lstStyle/>
+          <a:p>
+            <a:r>
+              <a:rPr sz="900">
+                <a:latin typeface="Consolas"/>
+              </a:rPr>
+              <a:t>
+class SpatialAttention(nn.Module):
+    """在输出通道维度做自注意力，模拟网格间的信息交互。
+    输入 z: [batch, time, d_model]，转置后在 d_model 维度上做注意力，
+    相当于让每个时间步内不同"通道"（对应各网格的表征）互相交换信息。
+    """
+    def __init__(self, d_model: int, nhead: int, dropout: float = 0.1) -&gt; None:
+        super().__init__()
+        self.mix_logits = nn.Parameter(torch.randn(d_model, d_model) * 0.02)
+        self.norm = nn.LayerNorm(d_model)
+    def forward(self, z: Tensor, num_nodes: int) -&gt; Tensor:
+        # 把 d_model 通道当作注意力序列，模拟节点间交互
+        batch, time, d = z.shape
+        # 每个时间步独立做：把d_model个通道看成序列，需要每个位置是d_model维向量，
+        # 但通道本身是标量，所以用1x1卷积做Q/K/V投影不可行。改为简单可学习加权混合。
+        # 简化：用可学习参数矩阵在d维度做注意力式混合（等效单头自注意力的值域）
+        weight = torch.softmax(self.mix_logits, dim=-1)  # [d, d]
+        mixed = torch.matmul(z, weight.T)  # [batch, time, d]
+        attn_out = mixed
+        return self.norm(z + attn_out)
+class TemporalTransformer(nn.Module):
+    def __init__(
+        self,
+        input_dim: int,
+        output_dim: int,
+        d_model: int = 128,
+        nhead: int = 4,</a:t>
+            </a:r>
+          </a:p>
+        </p:txBody>
+      </p:sp>
+    </p:spTree>
+  </p:cSld>
+  <p:clrMapOvr>
+    <a:masterClrMapping/>
+  </p:clrMapOvr>
+</p:sld>
+</file>
+
+<file path=ppt/slides/slide23.xml><?xml version="1.0" encoding="utf-8"?>
+<p:sld xmlns:a="http://schemas.openxmlformats.org/drawingml/2006/main" xmlns:p="http://schemas.openxmlformats.org/presentationml/2006/main" xmlns:r="http://schemas.openxmlformats.org/officeDocument/2006/relationships">
+  <p:cSld>
+    <p:spTree>
+      <p:nvGrpSpPr>
+        <p:cNvPr id="1" name=""/>
+        <p:cNvGrpSpPr/>
+        <p:nvPr/>
+      </p:nvGrpSpPr>
+      <p:grpSpPr/>
+      <p:sp>
+        <p:nvSpPr>
+          <p:cNvPr id="2" name="TextBox 1"/>
+          <p:cNvSpPr txBox="1"/>
+          <p:nvPr/>
+        </p:nvSpPr>
+        <p:spPr>
+          <a:xfrm>
+            <a:off x="548640" y="228600"/>
+            <a:ext cx="11064240" cy="640080"/>
+          </a:xfrm>
+          <a:prstGeom prst="rect">
+            <a:avLst/>
+          </a:prstGeom>
+          <a:noFill/>
+        </p:spPr>
+        <p:txBody>
+          <a:bodyPr wrap="none">
+            <a:spAutoFit/>
+          </a:bodyPr>
+          <a:lstStyle/>
+          <a:p>
+            <a:pPr>
+              <a:defRPr sz="2000" b="1">
+                <a:solidFill>
+                  <a:srgbClr val="1F4E79"/>
+                </a:solidFill>
+              </a:defRPr>
+            </a:pPr>
+            <a:r>
+              <a:t>源代码：Transformer模型定义 - transformer_model.py (3/4)</a:t>
+            </a:r>
+          </a:p>
+        </p:txBody>
+      </p:sp>
+      <p:sp>
+        <p:nvSpPr>
+          <p:cNvPr id="3" name="TextBox 2"/>
+          <p:cNvSpPr txBox="1"/>
+          <p:nvPr/>
+        </p:nvSpPr>
+        <p:spPr>
+          <a:xfrm>
+            <a:off x="457200" y="914400"/>
+            <a:ext cx="11247120" cy="5760720"/>
+          </a:xfrm>
+          <a:prstGeom prst="rect">
+            <a:avLst/>
+          </a:prstGeom>
+          <a:noFill/>
+        </p:spPr>
+        <p:txBody>
+          <a:bodyPr wrap="none">
+            <a:spAutoFit/>
+          </a:bodyPr>
+          <a:lstStyle/>
+          <a:p>
+            <a:r>
+              <a:rPr sz="900">
+                <a:latin typeface="Consolas"/>
+              </a:rPr>
+              <a:t>        num_encoder_layers: int = 2,
+        num_nodes: int = 0,
+        use_spatial_attention: bool = False,
+        dim_feedforward: int = 256,
+        dropout: float = 0.1,
+        horizon: int = 1,
+        max_len: int = 512,
+    ) -&gt; None:
+        super().__init__()
+        if d_model % nhead != 0:
+            raise ValueError("d_model必须能被nhead整除")
+        self.horizon = horizon
+        self.output_dim = output_dim
+        self.num_nodes = num_nodes
+        if use_spatial_attention and num_nodes &lt;= 0:
+            raise ValueError("启用空间注意力时必须提供num_nodes")
+        self.input_projection = nn.Sequential(
+            nn.Linear(input_dim, d_model),
+            nn.LayerNorm(d_model),
+        )
+        self.position = SinusoidalPositionalEncoding(d_model, max_len=max_len)
+        layer = nn.TransformerEncoderLayer(
+            d_model=d_model,
+            nhead=nhead,
+            dim_feedforward=dim_feedforward,
+            dropout=dropout,
+            activation="gelu",
+            batch_first=True,
+            norm_first=True,
+        )
+        self.encoder = nn.TransformerEncoder(layer, num_layers=num_encoder_layers)
+        self.spatial = (</a:t>
+            </a:r>
+          </a:p>
+        </p:txBody>
+      </p:sp>
+    </p:spTree>
+  </p:cSld>
+  <p:clrMapOvr>
+    <a:masterClrMapping/>
+  </p:clrMapOvr>
+</p:sld>
+</file>
+
+<file path=ppt/slides/slide24.xml><?xml version="1.0" encoding="utf-8"?>
+<p:sld xmlns:a="http://schemas.openxmlformats.org/drawingml/2006/main" xmlns:p="http://schemas.openxmlformats.org/presentationml/2006/main" xmlns:r="http://schemas.openxmlformats.org/officeDocument/2006/relationships">
+  <p:cSld>
+    <p:spTree>
+      <p:nvGrpSpPr>
+        <p:cNvPr id="1" name=""/>
+        <p:cNvGrpSpPr/>
+        <p:nvPr/>
+      </p:nvGrpSpPr>
+      <p:grpSpPr/>
+      <p:sp>
+        <p:nvSpPr>
+          <p:cNvPr id="2" name="TextBox 1"/>
+          <p:cNvSpPr txBox="1"/>
+          <p:nvPr/>
+        </p:nvSpPr>
+        <p:spPr>
+          <a:xfrm>
+            <a:off x="548640" y="228600"/>
+            <a:ext cx="11064240" cy="640080"/>
+          </a:xfrm>
+          <a:prstGeom prst="rect">
+            <a:avLst/>
+          </a:prstGeom>
+          <a:noFill/>
+        </p:spPr>
+        <p:txBody>
+          <a:bodyPr wrap="none">
+            <a:spAutoFit/>
+          </a:bodyPr>
+          <a:lstStyle/>
+          <a:p>
+            <a:pPr>
+              <a:defRPr sz="2000" b="1">
+                <a:solidFill>
+                  <a:srgbClr val="1F4E79"/>
+                </a:solidFill>
+              </a:defRPr>
+            </a:pPr>
+            <a:r>
+              <a:t>源代码：Transformer模型定义 - transformer_model.py (4/4)</a:t>
+            </a:r>
+          </a:p>
+        </p:txBody>
+      </p:sp>
+      <p:sp>
+        <p:nvSpPr>
+          <p:cNvPr id="3" name="TextBox 2"/>
+          <p:cNvSpPr txBox="1"/>
+          <p:nvPr/>
+        </p:nvSpPr>
+        <p:spPr>
+          <a:xfrm>
+            <a:off x="457200" y="914400"/>
+            <a:ext cx="11247120" cy="5760720"/>
+          </a:xfrm>
+          <a:prstGeom prst="rect">
+            <a:avLst/>
+          </a:prstGeom>
+          <a:noFill/>
+        </p:spPr>
+        <p:txBody>
+          <a:bodyPr wrap="none">
+            <a:spAutoFit/>
+          </a:bodyPr>
+          <a:lstStyle/>
+          <a:p>
+            <a:r>
+              <a:rPr sz="900">
+                <a:latin typeface="Consolas"/>
+              </a:rPr>
+              <a:t>            SpatialAttention(d_model, nhead, dropout=dropout)
+            if use_spatial_attention and num_nodes &gt; 1
+            else None
+        )
+        self.head = nn.Sequential(
+            nn.LayerNorm(d_model),
+            nn.Linear(d_model, horizon * output_dim),
+        )
+    def forward(self, x: Tensor) -&gt; Tensor:
+        if x.ndim != 3:
+            raise ValueError("输入必须是[batch, time, feature]三维张量")
+        z = self.input_projection(x)
+        z = self.position(z)
+        z = self.encoder(z)
+        if self.spatial is not None:
+            z = self.spatial(z, self.num_nodes)
+        last_state = z[:, -1]
+        prediction = self.head(last_state)
+        return prediction.view(x.size(0), self.horizon, self.output_dim)
+if __name__ == "__main__":
+    model = TemporalTransformer(input_dim=80, output_dim=60)
+    sample = torch.randn(4, 48, 80)
+    result = model(sample)
+    print("input:", tuple(sample.shape))
+    print("output:", tuple(result.shape))
+</a:t>
+            </a:r>
+          </a:p>
+        </p:txBody>
+      </p:sp>
+    </p:spTree>
+  </p:cSld>
+  <p:clrMapOvr>
+    <a:masterClrMapping/>
+  </p:clrMapOvr>
+</p:sld>
+</file>
+
+<file path=ppt/slides/slide25.xml><?xml version="1.0" encoding="utf-8"?>
+<p:sld xmlns:a="http://schemas.openxmlformats.org/drawingml/2006/main" xmlns:p="http://schemas.openxmlformats.org/presentationml/2006/main" xmlns:r="http://schemas.openxmlformats.org/officeDocument/2006/relationships">
+  <p:cSld>
+    <p:spTree>
+      <p:nvGrpSpPr>
+        <p:cNvPr id="1" name=""/>
+        <p:cNvGrpSpPr/>
+        <p:nvPr/>
+      </p:nvGrpSpPr>
+      <p:grpSpPr/>
+      <p:sp>
+        <p:nvSpPr>
+          <p:cNvPr id="2" name="TextBox 1"/>
+          <p:cNvSpPr txBox="1"/>
+          <p:nvPr/>
+        </p:nvSpPr>
+        <p:spPr>
+          <a:xfrm>
+            <a:off x="548640" y="228600"/>
+            <a:ext cx="11064240" cy="640080"/>
+          </a:xfrm>
+          <a:prstGeom prst="rect">
+            <a:avLst/>
+          </a:prstGeom>
+          <a:noFill/>
+        </p:spPr>
+        <p:txBody>
+          <a:bodyPr wrap="none">
+            <a:spAutoFit/>
+          </a:bodyPr>
+          <a:lstStyle/>
+          <a:p>
+            <a:pPr>
+              <a:defRPr sz="2000" b="1">
+                <a:solidFill>
+                  <a:srgbClr val="1F4E79"/>
+                </a:solidFill>
+              </a:defRPr>
+            </a:pPr>
+            <a:r>
+              <a:t>源代码：Transformer训练脚本 - train_transformer.py (1/8)</a:t>
+            </a:r>
+          </a:p>
+        </p:txBody>
+      </p:sp>
+      <p:sp>
+        <p:nvSpPr>
+          <p:cNvPr id="3" name="TextBox 2"/>
+          <p:cNvSpPr txBox="1"/>
+          <p:nvPr/>
+        </p:nvSpPr>
+        <p:spPr>
+          <a:xfrm>
+            <a:off x="457200" y="914400"/>
+            <a:ext cx="11247120" cy="5760720"/>
+          </a:xfrm>
+          <a:prstGeom prst="rect">
+            <a:avLst/>
+          </a:prstGeom>
+          <a:noFill/>
+        </p:spPr>
+        <p:txBody>
+          <a:bodyPr wrap="none">
+            <a:spAutoFit/>
+          </a:bodyPr>
+          <a:lstStyle/>
+          <a:p>
+            <a:r>
+              <a:rPr sz="900">
+                <a:latin typeface="Consolas"/>
+              </a:rPr>
+              <a:t>#!/usr/bin/env python3
+"""训练多区域时序 Transformer，并和两个简单基线比较。
+典型运行：
+    python src/aggregate_demand.py
+    python src/train_transformer.py --epochs 30
+目标改为残差：y 减去前一天同期需求（lag48），模型学习对 previous-day 基线的修正量，评估时把残差加回基线后还原为订单数。
+"""
+from __future__ import annotations
+import argparse
+import json
+import random
+from pathlib import Path
+import numpy as np
+import torch
+from torch import nn
+from torch.utils.data import DataLoader, Dataset
+from transformer_model import TemporalTransformer
+class WindowDataset(Dataset):
+    def __init__(self, x: np.ndarray, y: np.ndarray, targets: np.ndarray, lookback: int, horizon: int):
+        self.x, self.y, self.targets = x, y, targets
+        self.lookback, self.horizon = lookback, horizon
+    def __len__(self) -&gt; int:
+        return len(self.targets)</a:t>
+            </a:r>
+          </a:p>
+        </p:txBody>
+      </p:sp>
+    </p:spTree>
+  </p:cSld>
+  <p:clrMapOvr>
+    <a:masterClrMapping/>
+  </p:clrMapOvr>
+</p:sld>
+</file>
+
+<file path=ppt/slides/slide26.xml><?xml version="1.0" encoding="utf-8"?>
+<p:sld xmlns:a="http://schemas.openxmlformats.org/drawingml/2006/main" xmlns:p="http://schemas.openxmlformats.org/presentationml/2006/main" xmlns:r="http://schemas.openxmlformats.org/officeDocument/2006/relationships">
+  <p:cSld>
+    <p:spTree>
+      <p:nvGrpSpPr>
+        <p:cNvPr id="1" name=""/>
+        <p:cNvGrpSpPr/>
+        <p:nvPr/>
+      </p:nvGrpSpPr>
+      <p:grpSpPr/>
+      <p:sp>
+        <p:nvSpPr>
+          <p:cNvPr id="2" name="TextBox 1"/>
+          <p:cNvSpPr txBox="1"/>
+          <p:nvPr/>
+        </p:nvSpPr>
+        <p:spPr>
+          <a:xfrm>
+            <a:off x="548640" y="228600"/>
+            <a:ext cx="11064240" cy="640080"/>
+          </a:xfrm>
+          <a:prstGeom prst="rect">
+            <a:avLst/>
+          </a:prstGeom>
+          <a:noFill/>
+        </p:spPr>
+        <p:txBody>
+          <a:bodyPr wrap="none">
+            <a:spAutoFit/>
+          </a:bodyPr>
+          <a:lstStyle/>
+          <a:p>
+            <a:pPr>
+              <a:defRPr sz="2000" b="1">
+                <a:solidFill>
+                  <a:srgbClr val="1F4E79"/>
+                </a:solidFill>
+              </a:defRPr>
+            </a:pPr>
+            <a:r>
+              <a:t>源代码：Transformer训练脚本 - train_transformer.py (2/8)</a:t>
+            </a:r>
+          </a:p>
+        </p:txBody>
+      </p:sp>
+      <p:sp>
+        <p:nvSpPr>
+          <p:cNvPr id="3" name="TextBox 2"/>
+          <p:cNvSpPr txBox="1"/>
+          <p:nvPr/>
+        </p:nvSpPr>
+        <p:spPr>
+          <a:xfrm>
+            <a:off x="457200" y="914400"/>
+            <a:ext cx="11247120" cy="5760720"/>
+          </a:xfrm>
+          <a:prstGeom prst="rect">
+            <a:avLst/>
+          </a:prstGeom>
+          <a:noFill/>
+        </p:spPr>
+        <p:txBody>
+          <a:bodyPr wrap="none">
+            <a:spAutoFit/>
+          </a:bodyPr>
+          <a:lstStyle/>
+          <a:p>
+            <a:r>
+              <a:rPr sz="900">
+                <a:latin typeface="Consolas"/>
+              </a:rPr>
+              <a:t>
+    def __getitem__(self, index: int):
+        t = int(self.targets[index])
+        lag48 = np.repeat(self.x[t - 48:t - 47], self.lookback, axis=0)
+        features = np.concatenate(
+            [self.x[t - self.lookback:t], self.y[t - self.lookback:t], lag48], axis=1
+        )
+        baseline = np.repeat(self.x[t - 48:t - 48 + self.horizon], self.horizon, axis=0)
+        target = self.x[t:t + self.horizon] - baseline
+        return torch.from_numpy(features).float(), torch.from_numpy(target).float()
+def set_seed(seed: int) -&gt; None:
+    random.seed(seed)
+    np.random.seed(seed)
+    torch.manual_seed(seed)
+    if torch.cuda.is_available():
+        torch.cuda.manual_seed_all(seed)
+def make_targets(start: int, end: int, lookback: int, horizon: int) -&gt; np.ndarray:
+    first = max(start, lookback)
+    last = end - horizon + 1
+    return np.arange(first, max(first, last), dtype=np.int64)
+def metrics(y_true: np.ndarray, y_pred: np.ndarray) -&gt; dict[str, float]:
+    err = y_pred - y_true
+    denom = np.maximum(np.abs(y_true), 1.0)
+    return {
+        "MAE": float(np.mean(np.abs(err))),
+        "RMSE": float(np.sqrt(np.mean(err ** 2))),</a:t>
+            </a:r>
+          </a:p>
+        </p:txBody>
+      </p:sp>
+    </p:spTree>
+  </p:cSld>
+  <p:clrMapOvr>
+    <a:masterClrMapping/>
+  </p:clrMapOvr>
+</p:sld>
+</file>
+
+<file path=ppt/slides/slide27.xml><?xml version="1.0" encoding="utf-8"?>
+<p:sld xmlns:a="http://schemas.openxmlformats.org/drawingml/2006/main" xmlns:p="http://schemas.openxmlformats.org/presentationml/2006/main" xmlns:r="http://schemas.openxmlformats.org/officeDocument/2006/relationships">
+  <p:cSld>
+    <p:spTree>
+      <p:nvGrpSpPr>
+        <p:cNvPr id="1" name=""/>
+        <p:cNvGrpSpPr/>
+        <p:nvPr/>
+      </p:nvGrpSpPr>
+      <p:grpSpPr/>
+      <p:sp>
+        <p:nvSpPr>
+          <p:cNvPr id="2" name="TextBox 1"/>
+          <p:cNvSpPr txBox="1"/>
+          <p:nvPr/>
+        </p:nvSpPr>
+        <p:spPr>
+          <a:xfrm>
+            <a:off x="548640" y="228600"/>
+            <a:ext cx="11064240" cy="640080"/>
+          </a:xfrm>
+          <a:prstGeom prst="rect">
+            <a:avLst/>
+          </a:prstGeom>
+          <a:noFill/>
+        </p:spPr>
+        <p:txBody>
+          <a:bodyPr wrap="none">
+            <a:spAutoFit/>
+          </a:bodyPr>
+          <a:lstStyle/>
+          <a:p>
+            <a:pPr>
+              <a:defRPr sz="2000" b="1">
+                <a:solidFill>
+                  <a:srgbClr val="1F4E79"/>
+                </a:solidFill>
+              </a:defRPr>
+            </a:pPr>
+            <a:r>
+              <a:t>源代码：Transformer训练脚本 - train_transformer.py (3/8)</a:t>
+            </a:r>
+          </a:p>
+        </p:txBody>
+      </p:sp>
+      <p:sp>
+        <p:nvSpPr>
+          <p:cNvPr id="3" name="TextBox 2"/>
+          <p:cNvSpPr txBox="1"/>
+          <p:nvPr/>
+        </p:nvSpPr>
+        <p:spPr>
+          <a:xfrm>
+            <a:off x="457200" y="914400"/>
+            <a:ext cx="11247120" cy="5760720"/>
+          </a:xfrm>
+          <a:prstGeom prst="rect">
+            <a:avLst/>
+          </a:prstGeom>
+          <a:noFill/>
+        </p:spPr>
+        <p:txBody>
+          <a:bodyPr wrap="none">
+            <a:spAutoFit/>
+          </a:bodyPr>
+          <a:lstStyle/>
+          <a:p>
+            <a:r>
+              <a:rPr sz="900">
+                <a:latin typeface="Consolas"/>
+              </a:rPr>
+              <a:t>        "MAPE_percent": float(np.mean(np.abs(err) / denom) * 100),
+        "WMAPE_percent": float(np.sum(np.abs(err)) / max(np.sum(np.abs(y_true)), 1.0) * 100),
+    }
+@torch.no_grad()
+def predict(model, loader, device, mean, std):
+    model.eval()
+    all_true, all_pred = [], []
+    for features, target in loader:
+        prediction = model(features.to(device)).cpu().numpy()
+        true = target.numpy()
+        baseline = np.repeat(features[:, -48:-47, :prediction.shape[2]].cpu().numpy(), prediction.shape[1], axis=1)
+        pred_count = np.expm1((prediction + baseline) * std + mean).clip(0)
+        true_count = np.expm1((true + baseline) * std + mean).clip(0)
+        all_pred.append(pred_count)
+        all_true.append(true_count)
+    return np.concatenate(all_true), np.concatenate(all_pred)
+def train_epoch(model, loader, optimizer, criterion, device):
+    model.train()
+    total, n = 0.0, 0
+    for features, target in loader:
+        features, target = features.to(device), target.to(device)
+        optimizer.zero_grad(set_to_none=True)
+        prediction = model(features)
+        loss = criterion(prediction, target)
+        loss.backward()
+        torch.nn.utils.clip_grad_norm_(model.parameters(), 1.0)
+        optimizer.step()
+        total += float(loss.item()) * len(features)</a:t>
+            </a:r>
+          </a:p>
+        </p:txBody>
+      </p:sp>
+    </p:spTree>
+  </p:cSld>
+  <p:clrMapOvr>
+    <a:masterClrMapping/>
+  </p:clrMapOvr>
+</p:sld>
+</file>
+
+<file path=ppt/slides/slide28.xml><?xml version="1.0" encoding="utf-8"?>
+<p:sld xmlns:a="http://schemas.openxmlformats.org/drawingml/2006/main" xmlns:p="http://schemas.openxmlformats.org/presentationml/2006/main" xmlns:r="http://schemas.openxmlformats.org/officeDocument/2006/relationships">
+  <p:cSld>
+    <p:spTree>
+      <p:nvGrpSpPr>
+        <p:cNvPr id="1" name=""/>
+        <p:cNvGrpSpPr/>
+        <p:nvPr/>
+      </p:nvGrpSpPr>
+      <p:grpSpPr/>
+      <p:sp>
+        <p:nvSpPr>
+          <p:cNvPr id="2" name="TextBox 1"/>
+          <p:cNvSpPr txBox="1"/>
+          <p:nvPr/>
+        </p:nvSpPr>
+        <p:spPr>
+          <a:xfrm>
+            <a:off x="548640" y="228600"/>
+            <a:ext cx="11064240" cy="640080"/>
+          </a:xfrm>
+          <a:prstGeom prst="rect">
+            <a:avLst/>
+          </a:prstGeom>
+          <a:noFill/>
+        </p:spPr>
+        <p:txBody>
+          <a:bodyPr wrap="none">
+            <a:spAutoFit/>
+          </a:bodyPr>
+          <a:lstStyle/>
+          <a:p>
+            <a:pPr>
+              <a:defRPr sz="2000" b="1">
+                <a:solidFill>
+                  <a:srgbClr val="1F4E79"/>
+                </a:solidFill>
+              </a:defRPr>
+            </a:pPr>
+            <a:r>
+              <a:t>源代码：Transformer训练脚本 - train_transformer.py (4/8)</a:t>
+            </a:r>
+          </a:p>
+        </p:txBody>
+      </p:sp>
+      <p:sp>
+        <p:nvSpPr>
+          <p:cNvPr id="3" name="TextBox 2"/>
+          <p:cNvSpPr txBox="1"/>
+          <p:nvPr/>
+        </p:nvSpPr>
+        <p:spPr>
+          <a:xfrm>
+            <a:off x="457200" y="914400"/>
+            <a:ext cx="11247120" cy="5760720"/>
+          </a:xfrm>
+          <a:prstGeom prst="rect">
+            <a:avLst/>
+          </a:prstGeom>
+          <a:noFill/>
+        </p:spPr>
+        <p:txBody>
+          <a:bodyPr wrap="none">
+            <a:spAutoFit/>
+          </a:bodyPr>
+          <a:lstStyle/>
+          <a:p>
+            <a:r>
+              <a:rPr sz="900">
+                <a:latin typeface="Consolas"/>
+              </a:rPr>
+              <a:t>        n += len(features)
+    return total / max(n, 1)
+def main() -&gt; None:
+    parser = argparse.ArgumentParser(description="训练共享单车需求 Transformer")
+    parser.add_argument("--data", default="data/processed/demand_30min.npz")
+    parser.add_argument("--output-dir", default="checkpoints/transformer")
+    parser.add_argument("--lookback", type=int, default=48)
+    parser.add_argument("--horizon", type=int, default=1)
+    parser.add_argument("--train-ratio", type=float, default=None)
+    parser.add_argument("--val-ratio", type=float, default=None)
+    parser.add_argument("--train-start", default=None, help="如 2021-01-30T13:00")
+    parser.add_argument("--train-end", default=None)
+    parser.add_argument("--val-end", default=None)
+    parser.add_argument("--d-model", type=int, default=128)
+    parser.add_argument("--nhead", type=int, default=4)
+    parser.add_argument("--layers", type=int, default=2)
+    parser.add_argument("--ffn-dim", type=int, default=256)
+    parser.add_argument("--dropout", type=float, default=0.1)
+    parser.add_argument("--spatial-attention", action="store_true", help="启用空间注意力")
+    parser.add_argument("--batch-size", type=int, default=64)
+    parser.add_argument("--epochs", type=int, default=50)
+    parser.add_argument("--lr", type=float, default=3e-4)
+    parser.add_argument("--weight-decay", type=float, default=1e-5)
+    parser.add_argument("--patience", type=int, default=5)
+    parser.add_argument("--seed", type=int, default=42)
+    args = parser.parse_args()
+    set_seed(args.seed)
+    data_path = Path(args.data)
+    if not data_path.exists():</a:t>
+            </a:r>
+          </a:p>
+        </p:txBody>
+      </p:sp>
+    </p:spTree>
+  </p:cSld>
+  <p:clrMapOvr>
+    <a:masterClrMapping/>
+  </p:clrMapOvr>
+</p:sld>
+</file>
+
+<file path=ppt/slides/slide29.xml><?xml version="1.0" encoding="utf-8"?>
+<p:sld xmlns:a="http://schemas.openxmlformats.org/drawingml/2006/main" xmlns:p="http://schemas.openxmlformats.org/presentationml/2006/main" xmlns:r="http://schemas.openxmlformats.org/officeDocument/2006/relationships">
+  <p:cSld>
+    <p:spTree>
+      <p:nvGrpSpPr>
+        <p:cNvPr id="1" name=""/>
+        <p:cNvGrpSpPr/>
+        <p:nvPr/>
+      </p:nvGrpSpPr>
+      <p:grpSpPr/>
+      <p:sp>
+        <p:nvSpPr>
+          <p:cNvPr id="2" name="TextBox 1"/>
+          <p:cNvSpPr txBox="1"/>
+          <p:nvPr/>
+        </p:nvSpPr>
+        <p:spPr>
+          <a:xfrm>
+            <a:off x="548640" y="228600"/>
+            <a:ext cx="11064240" cy="640080"/>
+          </a:xfrm>
+          <a:prstGeom prst="rect">
+            <a:avLst/>
+          </a:prstGeom>
+          <a:noFill/>
+        </p:spPr>
+        <p:txBody>
+          <a:bodyPr wrap="none">
+            <a:spAutoFit/>
+          </a:bodyPr>
+          <a:lstStyle/>
+          <a:p>
+            <a:pPr>
+              <a:defRPr sz="2000" b="1">
+                <a:solidFill>
+                  <a:srgbClr val="1F4E79"/>
+                </a:solidFill>
+              </a:defRPr>
+            </a:pPr>
+            <a:r>
+              <a:t>源代码：Transformer训练脚本 - train_transformer.py (5/8)</a:t>
+            </a:r>
+          </a:p>
+        </p:txBody>
+      </p:sp>
+      <p:sp>
+        <p:nvSpPr>
+          <p:cNvPr id="3" name="TextBox 2"/>
+          <p:cNvSpPr txBox="1"/>
+          <p:nvPr/>
+        </p:nvSpPr>
+        <p:spPr>
+          <a:xfrm>
+            <a:off x="457200" y="914400"/>
+            <a:ext cx="11247120" cy="5760720"/>
+          </a:xfrm>
+          <a:prstGeom prst="rect">
+            <a:avLst/>
+          </a:prstGeom>
+          <a:noFill/>
+        </p:spPr>
+        <p:txBody>
+          <a:bodyPr wrap="none">
+            <a:spAutoFit/>
+          </a:bodyPr>
+          <a:lstStyle/>
+          <a:p>
+            <a:r>
+              <a:rPr sz="900">
+                <a:latin typeface="Consolas"/>
+              </a:rPr>
+              <a:t>        raise SystemExit(f"找不到聚合数据：{data_path}，请先运行 aggregate_demand.py")
+    raw = np.load(data_path)
+    demand = raw["demand"].astype(np.float32)
+    time_features = raw["time_features"].astype(np.float32)
+    times = raw["times"].astype(np.int64)
+    steps, output_dim = demand.shape
+    if len(times) != steps or steps &lt;= args.lookback + args.horizon:
+        raise SystemExit("时间序列太短，无法构造训练窗口")
+    import pandas as pd
+    if args.train_start:
+        # 按日期划分（针对不均匀数据）
+        ts = pd.to_datetime(times, unit="s")
+        mask = ts &gt;= pd.Timestamp(args.train_start)
+        first_idx = int(np.argmax(mask))
+        train_end = int(np.argmax(ts &gt;= pd.Timestamp(args.train_end))) if args.train_end else steps
+        val_end = int(np.argmax(ts &gt;= pd.Timestamp(args.val_end))) if args.val_end else steps
+        if not (first_idx + args.lookback + args.horizon &lt; train_end &lt; val_end &lt;= steps):
+            raise SystemExit("按日期划分后窗口不足，请检查日期范围")
+        steps_offset = first_idx
+        train_start_idx = first_idx
+    else:
+        train_start_idx = 0
+        train_end = int(steps * args.train_ratio)
+        val_end = int(steps * (args.train_ratio + args.val_ratio))
+        if not (0 &lt; train_end &lt; val_end &lt; steps):
+            raise SystemExit("train/val比例不合法")
+    # 只用训练时段估计变换参数，避免测试集信息泄漏。
+    log_demand = np.log1p(demand)
+    mean = log_demand[train_start_idx:train_end].mean(axis=0).astype(np.float32)
+    std = log_demand[train_start_idx:train_end].std(axis=0).astype(np.float32)
+    std[std &lt; 1e-4] = 1.0</a:t>
+            </a:r>
+          </a:p>
+        </p:txBody>
+      </p:sp>
+    </p:spTree>
+  </p:cSld>
+  <p:clrMapOvr>
+    <a:masterClrMapping/>
+  </p:clrMapOvr>
+</p:sld>
+</file>
+
 <file path=ppt/slides/slide3.xml><?xml version="1.0" encoding="utf-8"?>
 <p:sld xmlns:a="http://schemas.openxmlformats.org/drawingml/2006/main" xmlns:p="http://schemas.openxmlformats.org/presentationml/2006/main" xmlns:r="http://schemas.openxmlformats.org/officeDocument/2006/relationships">
   <p:cSld>
@@ -4844,6 +5855,977 @@
             </a:pPr>
             <a:r>
               <a:t>通过API爬取约300万条订单数据存入SQLite</a:t>
+            </a:r>
+          </a:p>
+        </p:txBody>
+      </p:sp>
+    </p:spTree>
+  </p:cSld>
+  <p:clrMapOvr>
+    <a:masterClrMapping/>
+  </p:clrMapOvr>
+</p:sld>
+</file>
+
+<file path=ppt/slides/slide30.xml><?xml version="1.0" encoding="utf-8"?>
+<p:sld xmlns:a="http://schemas.openxmlformats.org/drawingml/2006/main" xmlns:p="http://schemas.openxmlformats.org/presentationml/2006/main" xmlns:r="http://schemas.openxmlformats.org/officeDocument/2006/relationships">
+  <p:cSld>
+    <p:spTree>
+      <p:nvGrpSpPr>
+        <p:cNvPr id="1" name=""/>
+        <p:cNvGrpSpPr/>
+        <p:nvPr/>
+      </p:nvGrpSpPr>
+      <p:grpSpPr/>
+      <p:sp>
+        <p:nvSpPr>
+          <p:cNvPr id="2" name="TextBox 1"/>
+          <p:cNvSpPr txBox="1"/>
+          <p:nvPr/>
+        </p:nvSpPr>
+        <p:spPr>
+          <a:xfrm>
+            <a:off x="548640" y="228600"/>
+            <a:ext cx="11064240" cy="640080"/>
+          </a:xfrm>
+          <a:prstGeom prst="rect">
+            <a:avLst/>
+          </a:prstGeom>
+          <a:noFill/>
+        </p:spPr>
+        <p:txBody>
+          <a:bodyPr wrap="none">
+            <a:spAutoFit/>
+          </a:bodyPr>
+          <a:lstStyle/>
+          <a:p>
+            <a:pPr>
+              <a:defRPr sz="2000" b="1">
+                <a:solidFill>
+                  <a:srgbClr val="1F4E79"/>
+                </a:solidFill>
+              </a:defRPr>
+            </a:pPr>
+            <a:r>
+              <a:t>源代码：Transformer训练脚本 - train_transformer.py (6/8)</a:t>
+            </a:r>
+          </a:p>
+        </p:txBody>
+      </p:sp>
+      <p:sp>
+        <p:nvSpPr>
+          <p:cNvPr id="3" name="TextBox 2"/>
+          <p:cNvSpPr txBox="1"/>
+          <p:nvPr/>
+        </p:nvSpPr>
+        <p:spPr>
+          <a:xfrm>
+            <a:off x="457200" y="914400"/>
+            <a:ext cx="11247120" cy="5760720"/>
+          </a:xfrm>
+          <a:prstGeom prst="rect">
+            <a:avLst/>
+          </a:prstGeom>
+          <a:noFill/>
+        </p:spPr>
+        <p:txBody>
+          <a:bodyPr wrap="none">
+            <a:spAutoFit/>
+          </a:bodyPr>
+          <a:lstStyle/>
+          <a:p>
+            <a:r>
+              <a:rPr sz="900">
+                <a:latin typeface="Consolas"/>
+              </a:rPr>
+              <a:t>    scaled = ((log_demand - mean) / std).astype(np.float32)
+    train_targets = make_targets(train_start_idx, train_end, args.lookback, args.horizon)
+    val_targets = make_targets(train_end, val_end, args.lookback, args.horizon)
+    test_targets = make_targets(val_end, steps, args.lookback, args.horizon)
+    if min(len(train_targets), len(val_targets), len(test_targets)) == 0:
+        raise SystemExit("某个数据划分没有可用窗口，请减少lookback或调整划分比例")
+    train_ds = WindowDataset(scaled, time_features, train_targets, args.lookback, args.horizon)
+    val_ds = WindowDataset(scaled, time_features, val_targets, args.lookback, args.horizon)
+    test_ds = WindowDataset(scaled, time_features, test_targets, args.lookback, args.horizon)
+    train_loader = DataLoader(train_ds, batch_size=args.batch_size, shuffle=True, num_workers=0)
+    val_loader = DataLoader(val_ds, batch_size=args.batch_size, shuffle=False, num_workers=0)
+    test_loader = DataLoader(test_ds, batch_size=args.batch_size, shuffle=False, num_workers=0)
+    device = torch.device("cuda" if torch.cuda.is_available() else "cpu")
+    model = TemporalTransformer(
+        input_dim=output_dim + time_features.shape[1] + output_dim, output_dim=output_dim,
+        d_model=args.d_model, nhead=args.nhead, num_encoder_layers=args.layers,
+        dim_feedforward=args.ffn_dim, dropout=args.dropout, horizon=args.horizon,
+        num_nodes=output_dim, use_spatial_attention=args.spatial_attention,
+    ).to(device)
+    optimizer = torch.optim.AdamW(model.parameters(), lr=args.lr, weight_decay=args.weight_decay)
+    criterion = nn.HuberLoss()
+    best_val, stale = float("inf"), 0
+    output_dir = Path(args.output_dir)
+    output_dir.mkdir(parents=True, exist_ok=True)
+    checkpoint = output_dir / "best.pt"
+    print(f"设备：{device}；时间步：{steps:,}；网格：{output_dim // 2}")
+    print(f"窗口数：train={len(train_ds):,}, val={len(val_ds):,}, test={len(test_ds):,}")
+    for epoch in range(1, args.epochs + 1):
+        train_loss = train_epoch(model, train_loader, optimizer, criterion, device)</a:t>
+            </a:r>
+          </a:p>
+        </p:txBody>
+      </p:sp>
+    </p:spTree>
+  </p:cSld>
+  <p:clrMapOvr>
+    <a:masterClrMapping/>
+  </p:clrMapOvr>
+</p:sld>
+</file>
+
+<file path=ppt/slides/slide31.xml><?xml version="1.0" encoding="utf-8"?>
+<p:sld xmlns:a="http://schemas.openxmlformats.org/drawingml/2006/main" xmlns:p="http://schemas.openxmlformats.org/presentationml/2006/main" xmlns:r="http://schemas.openxmlformats.org/officeDocument/2006/relationships">
+  <p:cSld>
+    <p:spTree>
+      <p:nvGrpSpPr>
+        <p:cNvPr id="1" name=""/>
+        <p:cNvGrpSpPr/>
+        <p:nvPr/>
+      </p:nvGrpSpPr>
+      <p:grpSpPr/>
+      <p:sp>
+        <p:nvSpPr>
+          <p:cNvPr id="2" name="TextBox 1"/>
+          <p:cNvSpPr txBox="1"/>
+          <p:nvPr/>
+        </p:nvSpPr>
+        <p:spPr>
+          <a:xfrm>
+            <a:off x="548640" y="228600"/>
+            <a:ext cx="11064240" cy="640080"/>
+          </a:xfrm>
+          <a:prstGeom prst="rect">
+            <a:avLst/>
+          </a:prstGeom>
+          <a:noFill/>
+        </p:spPr>
+        <p:txBody>
+          <a:bodyPr wrap="none">
+            <a:spAutoFit/>
+          </a:bodyPr>
+          <a:lstStyle/>
+          <a:p>
+            <a:pPr>
+              <a:defRPr sz="2000" b="1">
+                <a:solidFill>
+                  <a:srgbClr val="1F4E79"/>
+                </a:solidFill>
+              </a:defRPr>
+            </a:pPr>
+            <a:r>
+              <a:t>源代码：Transformer训练脚本 - train_transformer.py (7/8)</a:t>
+            </a:r>
+          </a:p>
+        </p:txBody>
+      </p:sp>
+      <p:sp>
+        <p:nvSpPr>
+          <p:cNvPr id="3" name="TextBox 2"/>
+          <p:cNvSpPr txBox="1"/>
+          <p:nvPr/>
+        </p:nvSpPr>
+        <p:spPr>
+          <a:xfrm>
+            <a:off x="457200" y="914400"/>
+            <a:ext cx="11247120" cy="5760720"/>
+          </a:xfrm>
+          <a:prstGeom prst="rect">
+            <a:avLst/>
+          </a:prstGeom>
+          <a:noFill/>
+        </p:spPr>
+        <p:txBody>
+          <a:bodyPr wrap="none">
+            <a:spAutoFit/>
+          </a:bodyPr>
+          <a:lstStyle/>
+          <a:p>
+            <a:r>
+              <a:rPr sz="900">
+                <a:latin typeface="Consolas"/>
+              </a:rPr>
+              <a:t>        model.eval()
+        val_loss, n = 0.0, 0
+        with torch.no_grad():
+            for features, target in val_loader:
+                loss = criterion(model(features.to(device)), target.to(device))
+                val_loss += float(loss.item()) * len(features)
+                n += len(features)
+        val_loss /= max(n, 1)
+        print(f"epoch {epoch:03d} | train_loss={train_loss:.5f} | val_loss={val_loss:.5f}", flush=True)
+        if val_loss &lt; best_val:
+            best_val, stale = val_loss, 0
+            torch.save({"model": model.state_dict(), "args": vars(args), "mean": mean, "std": std}, checkpoint)
+        else:
+            stale += 1
+            if stale &gt;= args.patience:
+                print(f"验证集连续 {args.patience} 轮未改善，提前停止")
+                break
+    saved = torch.load(checkpoint, map_location=device, weights_only=False)
+    model.load_state_dict(saved["model"])
+    true, pred = predict(model, test_loader, device, mean, std)
+    result = {"device": str(device), "best_val_loss": best_val, "transformer": metrics(true, pred)}
+    # 前一天同一时刻基线：测试目标 t 使用 t-48 的真实需求。
+    if args.horizon == 1:
+        baseline_prev = demand[test_targets - 48]
+        result["previous_day"] = metrics(true[:, 0], baseline_prev)
+    # 训练集的星期几+半小时槽历史均值基线。
+    train_dt = __import__("pandas").to_datetime(times[train_start_idx:train_end], unit="s")
+    test_dt = __import__("pandas").to_datetime(times[test_targets], unit="s")
+    slot = train_dt.dayofweek.to_numpy() * 48 + (train_dt.hour.to_numpy() * 2 + train_dt.minute.to_numpy() // 30)
+    mean_by_slot = {int(k): demand[train_start_idx:train_end][slot == k].mean(axis=0) for k in np.unique(slot)}</a:t>
+            </a:r>
+          </a:p>
+        </p:txBody>
+      </p:sp>
+    </p:spTree>
+  </p:cSld>
+  <p:clrMapOvr>
+    <a:masterClrMapping/>
+  </p:clrMapOvr>
+</p:sld>
+</file>
+
+<file path=ppt/slides/slide32.xml><?xml version="1.0" encoding="utf-8"?>
+<p:sld xmlns:a="http://schemas.openxmlformats.org/drawingml/2006/main" xmlns:p="http://schemas.openxmlformats.org/presentationml/2006/main" xmlns:r="http://schemas.openxmlformats.org/officeDocument/2006/relationships">
+  <p:cSld>
+    <p:spTree>
+      <p:nvGrpSpPr>
+        <p:cNvPr id="1" name=""/>
+        <p:cNvGrpSpPr/>
+        <p:nvPr/>
+      </p:nvGrpSpPr>
+      <p:grpSpPr/>
+      <p:sp>
+        <p:nvSpPr>
+          <p:cNvPr id="2" name="TextBox 1"/>
+          <p:cNvSpPr txBox="1"/>
+          <p:nvPr/>
+        </p:nvSpPr>
+        <p:spPr>
+          <a:xfrm>
+            <a:off x="548640" y="228600"/>
+            <a:ext cx="11064240" cy="640080"/>
+          </a:xfrm>
+          <a:prstGeom prst="rect">
+            <a:avLst/>
+          </a:prstGeom>
+          <a:noFill/>
+        </p:spPr>
+        <p:txBody>
+          <a:bodyPr wrap="none">
+            <a:spAutoFit/>
+          </a:bodyPr>
+          <a:lstStyle/>
+          <a:p>
+            <a:pPr>
+              <a:defRPr sz="2000" b="1">
+                <a:solidFill>
+                  <a:srgbClr val="1F4E79"/>
+                </a:solidFill>
+              </a:defRPr>
+            </a:pPr>
+            <a:r>
+              <a:t>源代码：Transformer训练脚本 - train_transformer.py (8/8)</a:t>
+            </a:r>
+          </a:p>
+        </p:txBody>
+      </p:sp>
+      <p:sp>
+        <p:nvSpPr>
+          <p:cNvPr id="3" name="TextBox 2"/>
+          <p:cNvSpPr txBox="1"/>
+          <p:nvPr/>
+        </p:nvSpPr>
+        <p:spPr>
+          <a:xfrm>
+            <a:off x="457200" y="914400"/>
+            <a:ext cx="11247120" cy="5760720"/>
+          </a:xfrm>
+          <a:prstGeom prst="rect">
+            <a:avLst/>
+          </a:prstGeom>
+          <a:noFill/>
+        </p:spPr>
+        <p:txBody>
+          <a:bodyPr wrap="none">
+            <a:spAutoFit/>
+          </a:bodyPr>
+          <a:lstStyle/>
+          <a:p>
+            <a:r>
+              <a:rPr sz="900">
+                <a:latin typeface="Consolas"/>
+              </a:rPr>
+              <a:t>    hist = np.stack([mean_by_slot.get(int(d.dayofweek * 48 + d.hour * 2 + d.minute // 30), demand[:train_end].mean(axis=0)) for d in test_dt])
+    result["historical_mean"] = metrics(true[:, 0], hist) if args.horizon == 1 else {"note": "历史平均基线当前实现为单步"}
+    metrics_path = output_dir / "test_metrics.json"
+    metrics_path.write_text(json.dumps(result, ensure_ascii=False, indent=2), encoding="utf-8")
+    np.savez_compressed(output_dir / "test_predictions.npz", times=times[test_targets], y_true=true, y_pred=pred)
+    print(json.dumps(result, ensure_ascii=False, indent=2))
+    print(f"模型：{checkpoint}\n指标：{metrics_path}")
+if __name__ == "__main__":
+    main()
+</a:t>
+            </a:r>
+          </a:p>
+        </p:txBody>
+      </p:sp>
+    </p:spTree>
+  </p:cSld>
+  <p:clrMapOvr>
+    <a:masterClrMapping/>
+  </p:clrMapOvr>
+</p:sld>
+</file>
+
+<file path=ppt/slides/slide33.xml><?xml version="1.0" encoding="utf-8"?>
+<p:sld xmlns:a="http://schemas.openxmlformats.org/drawingml/2006/main" xmlns:p="http://schemas.openxmlformats.org/presentationml/2006/main" xmlns:r="http://schemas.openxmlformats.org/officeDocument/2006/relationships">
+  <p:cSld>
+    <p:spTree>
+      <p:nvGrpSpPr>
+        <p:cNvPr id="1" name=""/>
+        <p:cNvGrpSpPr/>
+        <p:nvPr/>
+      </p:nvGrpSpPr>
+      <p:grpSpPr/>
+      <p:sp>
+        <p:nvSpPr>
+          <p:cNvPr id="2" name="TextBox 1"/>
+          <p:cNvSpPr txBox="1"/>
+          <p:nvPr/>
+        </p:nvSpPr>
+        <p:spPr>
+          <a:xfrm>
+            <a:off x="548640" y="228600"/>
+            <a:ext cx="11064240" cy="640080"/>
+          </a:xfrm>
+          <a:prstGeom prst="rect">
+            <a:avLst/>
+          </a:prstGeom>
+          <a:noFill/>
+        </p:spPr>
+        <p:txBody>
+          <a:bodyPr wrap="none">
+            <a:spAutoFit/>
+          </a:bodyPr>
+          <a:lstStyle/>
+          <a:p>
+            <a:pPr>
+              <a:defRPr sz="2000" b="1">
+                <a:solidFill>
+                  <a:srgbClr val="1F4E79"/>
+                </a:solidFill>
+              </a:defRPr>
+            </a:pPr>
+            <a:r>
+              <a:t>源代码：LSTM模型定义 - lstm_model.py (1/2)</a:t>
+            </a:r>
+          </a:p>
+        </p:txBody>
+      </p:sp>
+      <p:sp>
+        <p:nvSpPr>
+          <p:cNvPr id="3" name="TextBox 2"/>
+          <p:cNvSpPr txBox="1"/>
+          <p:nvPr/>
+        </p:nvSpPr>
+        <p:spPr>
+          <a:xfrm>
+            <a:off x="457200" y="914400"/>
+            <a:ext cx="11247120" cy="5760720"/>
+          </a:xfrm>
+          <a:prstGeom prst="rect">
+            <a:avLst/>
+          </a:prstGeom>
+          <a:noFill/>
+        </p:spPr>
+        <p:txBody>
+          <a:bodyPr wrap="none">
+            <a:spAutoFit/>
+          </a:bodyPr>
+          <a:lstStyle/>
+          <a:p>
+            <a:r>
+              <a:rPr sz="900">
+                <a:latin typeface="Consolas"/>
+              </a:rPr>
+              <a:t>#!/usr/bin/env python3
+"""多区域时序 LSTM 模型。
+输入：[batch, lookback, demand_dim + time_feature_dim]
+输出：[batch, horizon, demand_dim]
+"""
+from __future__ import annotations
+import torch
+from torch import Tensor, nn
+class DemandLSTM(nn.Module):
+    def __init__(
+        self,
+        input_dim: int,
+        output_dim: int,
+        hidden_dim: int = 128,
+        num_layers: int = 2,
+        dropout: float = 0.1,
+        horizon: int = 1,
+    ) -&gt; None:
+        super().__init__()
+        self.horizon = horizon
+        self.output_dim = output_dim
+        self.input_projection = nn.Sequential(
+            nn.Linear(input_dim, hidden_dim),
+            nn.LayerNorm(hidden_dim),
+        )
+        self.lstm = nn.LSTM(
+            input_size=hidden_dim,</a:t>
+            </a:r>
+          </a:p>
+        </p:txBody>
+      </p:sp>
+    </p:spTree>
+  </p:cSld>
+  <p:clrMapOvr>
+    <a:masterClrMapping/>
+  </p:clrMapOvr>
+</p:sld>
+</file>
+
+<file path=ppt/slides/slide34.xml><?xml version="1.0" encoding="utf-8"?>
+<p:sld xmlns:a="http://schemas.openxmlformats.org/drawingml/2006/main" xmlns:p="http://schemas.openxmlformats.org/presentationml/2006/main" xmlns:r="http://schemas.openxmlformats.org/officeDocument/2006/relationships">
+  <p:cSld>
+    <p:spTree>
+      <p:nvGrpSpPr>
+        <p:cNvPr id="1" name=""/>
+        <p:cNvGrpSpPr/>
+        <p:nvPr/>
+      </p:nvGrpSpPr>
+      <p:grpSpPr/>
+      <p:sp>
+        <p:nvSpPr>
+          <p:cNvPr id="2" name="TextBox 1"/>
+          <p:cNvSpPr txBox="1"/>
+          <p:nvPr/>
+        </p:nvSpPr>
+        <p:spPr>
+          <a:xfrm>
+            <a:off x="548640" y="228600"/>
+            <a:ext cx="11064240" cy="640080"/>
+          </a:xfrm>
+          <a:prstGeom prst="rect">
+            <a:avLst/>
+          </a:prstGeom>
+          <a:noFill/>
+        </p:spPr>
+        <p:txBody>
+          <a:bodyPr wrap="none">
+            <a:spAutoFit/>
+          </a:bodyPr>
+          <a:lstStyle/>
+          <a:p>
+            <a:pPr>
+              <a:defRPr sz="2000" b="1">
+                <a:solidFill>
+                  <a:srgbClr val="1F4E79"/>
+                </a:solidFill>
+              </a:defRPr>
+            </a:pPr>
+            <a:r>
+              <a:t>源代码：LSTM模型定义 - lstm_model.py (2/2)</a:t>
+            </a:r>
+          </a:p>
+        </p:txBody>
+      </p:sp>
+      <p:sp>
+        <p:nvSpPr>
+          <p:cNvPr id="3" name="TextBox 2"/>
+          <p:cNvSpPr txBox="1"/>
+          <p:nvPr/>
+        </p:nvSpPr>
+        <p:spPr>
+          <a:xfrm>
+            <a:off x="457200" y="914400"/>
+            <a:ext cx="11247120" cy="5760720"/>
+          </a:xfrm>
+          <a:prstGeom prst="rect">
+            <a:avLst/>
+          </a:prstGeom>
+          <a:noFill/>
+        </p:spPr>
+        <p:txBody>
+          <a:bodyPr wrap="none">
+            <a:spAutoFit/>
+          </a:bodyPr>
+          <a:lstStyle/>
+          <a:p>
+            <a:r>
+              <a:rPr sz="900">
+                <a:latin typeface="Consolas"/>
+              </a:rPr>
+              <a:t>            hidden_size=hidden_dim,
+            num_layers=num_layers,
+            batch_first=True,
+            dropout=dropout if num_layers &gt; 1 else 0.0,
+        )
+        self.head = nn.Sequential(
+            nn.LayerNorm(hidden_dim),
+            nn.Linear(hidden_dim, horizon * output_dim),
+        )
+    def forward(self, x: Tensor) -&gt; Tensor:
+        if x.ndim != 3:
+            raise ValueError("输入必须是[batch, time, feature]三维张量")
+        z = self.input_projection(x)
+        z, _ = self.lstm(z)
+        prediction = self.head(z[:, -1])
+        return prediction.view(x.size(0), self.horizon, self.output_dim)
+if __name__ == "__main__":
+    model = DemandLSTM(input_dim=66, output_dim=60)
+    sample = torch.randn(4, 48, 66)
+    print("input:", tuple(sample.shape))
+    print("output:", tuple(model(sample).shape))
+</a:t>
+            </a:r>
+          </a:p>
+        </p:txBody>
+      </p:sp>
+    </p:spTree>
+  </p:cSld>
+  <p:clrMapOvr>
+    <a:masterClrMapping/>
+  </p:clrMapOvr>
+</p:sld>
+</file>
+
+<file path=ppt/slides/slide35.xml><?xml version="1.0" encoding="utf-8"?>
+<p:sld xmlns:a="http://schemas.openxmlformats.org/drawingml/2006/main" xmlns:p="http://schemas.openxmlformats.org/presentationml/2006/main" xmlns:r="http://schemas.openxmlformats.org/officeDocument/2006/relationships">
+  <p:cSld>
+    <p:spTree>
+      <p:nvGrpSpPr>
+        <p:cNvPr id="1" name=""/>
+        <p:cNvGrpSpPr/>
+        <p:nvPr/>
+      </p:nvGrpSpPr>
+      <p:grpSpPr/>
+      <p:sp>
+        <p:nvSpPr>
+          <p:cNvPr id="2" name="TextBox 1"/>
+          <p:cNvSpPr txBox="1"/>
+          <p:nvPr/>
+        </p:nvSpPr>
+        <p:spPr>
+          <a:xfrm>
+            <a:off x="548640" y="228600"/>
+            <a:ext cx="11064240" cy="640080"/>
+          </a:xfrm>
+          <a:prstGeom prst="rect">
+            <a:avLst/>
+          </a:prstGeom>
+          <a:noFill/>
+        </p:spPr>
+        <p:txBody>
+          <a:bodyPr wrap="none">
+            <a:spAutoFit/>
+          </a:bodyPr>
+          <a:lstStyle/>
+          <a:p>
+            <a:pPr>
+              <a:defRPr sz="2000" b="1">
+                <a:solidFill>
+                  <a:srgbClr val="1F4E79"/>
+                </a:solidFill>
+              </a:defRPr>
+            </a:pPr>
+            <a:r>
+              <a:t>源代码：需求聚合脚本 - aggregate_demand.py (1/4)</a:t>
+            </a:r>
+          </a:p>
+        </p:txBody>
+      </p:sp>
+      <p:sp>
+        <p:nvSpPr>
+          <p:cNvPr id="3" name="TextBox 2"/>
+          <p:cNvSpPr txBox="1"/>
+          <p:nvPr/>
+        </p:nvSpPr>
+        <p:spPr>
+          <a:xfrm>
+            <a:off x="457200" y="914400"/>
+            <a:ext cx="11247120" cy="5760720"/>
+          </a:xfrm>
+          <a:prstGeom prst="rect">
+            <a:avLst/>
+          </a:prstGeom>
+          <a:noFill/>
+        </p:spPr>
+        <p:txBody>
+          <a:bodyPr wrap="none">
+            <a:spAutoFit/>
+          </a:bodyPr>
+          <a:lstStyle/>
+          <a:p>
+            <a:r>
+              <a:rPr sz="900">
+                <a:latin typeface="Consolas"/>
+              </a:rPr>
+              <a:t>#!/usr/bin/env python3
+"""把清洗后的订单聚合成 Transformer 可直接使用的 30 分钟网格序列。
+输出：
+  data/processed/demand_30min.npz
+  data/processed/demand_30min_meta.json
+每个时间步的 demand 向量按 ``[out_grid_1..N, in_grid_1..N]`` 排列，
+time_features 包含日周期、周周期、周末和高峰标记。
+"""
+from __future__ import annotations
+import argparse
+import json
+import sqlite3
+from pathlib import Path
+import numpy as np
+import pandas as pd
+def grid_id(lat: pd.Series, lng: pd.Series, min_lat: float, min_lng: float, size: float) -&gt; pd.Series:
+    gy = np.floor((lat.to_numpy() - min_lat) / size).astype(np.int32)
+    gx = np.floor((lng.to_numpy() - min_lng) / size).astype(np.int32)
+    return pd.Series(gy * 1000 + gx, index=lat.index, dtype="int32")
+def make_features(index: pd.DatetimeIndex) -&gt; np.ndarray:
+    minute = index.hour * 60 + index.minute
+    day_phase = 2 * np.pi * minute / 1440.0
+    week_phase = 2 * np.pi * (index.dayofweek * 1440 + minute) / (7 * 1440.0)</a:t>
+            </a:r>
+          </a:p>
+        </p:txBody>
+      </p:sp>
+    </p:spTree>
+  </p:cSld>
+  <p:clrMapOvr>
+    <a:masterClrMapping/>
+  </p:clrMapOvr>
+</p:sld>
+</file>
+
+<file path=ppt/slides/slide36.xml><?xml version="1.0" encoding="utf-8"?>
+<p:sld xmlns:a="http://schemas.openxmlformats.org/drawingml/2006/main" xmlns:p="http://schemas.openxmlformats.org/presentationml/2006/main" xmlns:r="http://schemas.openxmlformats.org/officeDocument/2006/relationships">
+  <p:cSld>
+    <p:spTree>
+      <p:nvGrpSpPr>
+        <p:cNvPr id="1" name=""/>
+        <p:cNvGrpSpPr/>
+        <p:nvPr/>
+      </p:nvGrpSpPr>
+      <p:grpSpPr/>
+      <p:sp>
+        <p:nvSpPr>
+          <p:cNvPr id="2" name="TextBox 1"/>
+          <p:cNvSpPr txBox="1"/>
+          <p:nvPr/>
+        </p:nvSpPr>
+        <p:spPr>
+          <a:xfrm>
+            <a:off x="548640" y="228600"/>
+            <a:ext cx="11064240" cy="640080"/>
+          </a:xfrm>
+          <a:prstGeom prst="rect">
+            <a:avLst/>
+          </a:prstGeom>
+          <a:noFill/>
+        </p:spPr>
+        <p:txBody>
+          <a:bodyPr wrap="none">
+            <a:spAutoFit/>
+          </a:bodyPr>
+          <a:lstStyle/>
+          <a:p>
+            <a:pPr>
+              <a:defRPr sz="2000" b="1">
+                <a:solidFill>
+                  <a:srgbClr val="1F4E79"/>
+                </a:solidFill>
+              </a:defRPr>
+            </a:pPr>
+            <a:r>
+              <a:t>源代码：需求聚合脚本 - aggregate_demand.py (2/4)</a:t>
+            </a:r>
+          </a:p>
+        </p:txBody>
+      </p:sp>
+      <p:sp>
+        <p:nvSpPr>
+          <p:cNvPr id="3" name="TextBox 2"/>
+          <p:cNvSpPr txBox="1"/>
+          <p:nvPr/>
+        </p:nvSpPr>
+        <p:spPr>
+          <a:xfrm>
+            <a:off x="457200" y="914400"/>
+            <a:ext cx="11247120" cy="5760720"/>
+          </a:xfrm>
+          <a:prstGeom prst="rect">
+            <a:avLst/>
+          </a:prstGeom>
+          <a:noFill/>
+        </p:spPr>
+        <p:txBody>
+          <a:bodyPr wrap="none">
+            <a:spAutoFit/>
+          </a:bodyPr>
+          <a:lstStyle/>
+          <a:p>
+            <a:r>
+              <a:rPr sz="900">
+                <a:latin typeface="Consolas"/>
+              </a:rPr>
+              <a:t>    weekend = (index.dayofweek &gt;= 5).astype(np.float32)
+    peak = (((index.hour.isin([7, 8, 9, 17, 18, 19])))).astype(np.float32)
+    return np.column_stack([
+        np.sin(day_phase), np.cos(day_phase),
+        np.sin(week_phase), np.cos(week_phase), weekend, peak,
+    ]).astype(np.float32)
+def main() -&gt; None:
+    parser = argparse.ArgumentParser(description="订单聚合为30分钟空间网格序列")
+    parser.add_argument("--input", default="data/processed/orders_5m_clean.sqlite")
+    parser.add_argument("--output", default="data/processed/demand_30min.npz")
+    parser.add_argument("--top-grids", type=int, default=30)
+    parser.add_argument("--grid-size", type=float, default=0.01, help="网格边长，单位为经纬度度数")
+    parser.add_argument("--min-lat", type=float, default=22.4)
+    parser.add_argument("--min-lng", type=float, default=113.7)
+    parser.add_argument("--chunk-size", type=int, default=200_000)
+    args = parser.parse_args()
+    source = Path(args.input)
+    output = Path(args.output)
+    if not source.exists():
+        raise SystemExit(f"输入数据库不存在：{source}")
+    if args.top_grids &lt;= 0 or args.grid_size &lt;= 0:
+        raise SystemExit("--top-grids和--grid-size必须大于0")
+    output.parent.mkdir(parents=True, exist_ok=True)
+    conn = sqlite3.connect(source)
+    query = """SELECT start_time, end_time, start_lat, start_lng, end_lat, end_lng
+               FROM orders_clean"""
+    parts: list[pd.DataFrame] = []
+    total = 0</a:t>
+            </a:r>
+          </a:p>
+        </p:txBody>
+      </p:sp>
+    </p:spTree>
+  </p:cSld>
+  <p:clrMapOvr>
+    <a:masterClrMapping/>
+  </p:clrMapOvr>
+</p:sld>
+</file>
+
+<file path=ppt/slides/slide37.xml><?xml version="1.0" encoding="utf-8"?>
+<p:sld xmlns:a="http://schemas.openxmlformats.org/drawingml/2006/main" xmlns:p="http://schemas.openxmlformats.org/presentationml/2006/main" xmlns:r="http://schemas.openxmlformats.org/officeDocument/2006/relationships">
+  <p:cSld>
+    <p:spTree>
+      <p:nvGrpSpPr>
+        <p:cNvPr id="1" name=""/>
+        <p:cNvGrpSpPr/>
+        <p:nvPr/>
+      </p:nvGrpSpPr>
+      <p:grpSpPr/>
+      <p:sp>
+        <p:nvSpPr>
+          <p:cNvPr id="2" name="TextBox 1"/>
+          <p:cNvSpPr txBox="1"/>
+          <p:nvPr/>
+        </p:nvSpPr>
+        <p:spPr>
+          <a:xfrm>
+            <a:off x="548640" y="228600"/>
+            <a:ext cx="11064240" cy="640080"/>
+          </a:xfrm>
+          <a:prstGeom prst="rect">
+            <a:avLst/>
+          </a:prstGeom>
+          <a:noFill/>
+        </p:spPr>
+        <p:txBody>
+          <a:bodyPr wrap="none">
+            <a:spAutoFit/>
+          </a:bodyPr>
+          <a:lstStyle/>
+          <a:p>
+            <a:pPr>
+              <a:defRPr sz="2000" b="1">
+                <a:solidFill>
+                  <a:srgbClr val="1F4E79"/>
+                </a:solidFill>
+              </a:defRPr>
+            </a:pPr>
+            <a:r>
+              <a:t>源代码：需求聚合脚本 - aggregate_demand.py (3/4)</a:t>
+            </a:r>
+          </a:p>
+        </p:txBody>
+      </p:sp>
+      <p:sp>
+        <p:nvSpPr>
+          <p:cNvPr id="3" name="TextBox 2"/>
+          <p:cNvSpPr txBox="1"/>
+          <p:nvPr/>
+        </p:nvSpPr>
+        <p:spPr>
+          <a:xfrm>
+            <a:off x="457200" y="914400"/>
+            <a:ext cx="11247120" cy="5760720"/>
+          </a:xfrm>
+          <a:prstGeom prst="rect">
+            <a:avLst/>
+          </a:prstGeom>
+          <a:noFill/>
+        </p:spPr>
+        <p:txBody>
+          <a:bodyPr wrap="none">
+            <a:spAutoFit/>
+          </a:bodyPr>
+          <a:lstStyle/>
+          <a:p>
+            <a:r>
+              <a:rPr sz="900">
+                <a:latin typeface="Consolas"/>
+              </a:rPr>
+              <a:t>    for chunk in pd.read_sql_query(query, conn, chunksize=args.chunk_size):
+        total += len(chunk)
+        chunk["start_time"] = pd.to_datetime(chunk["start_time"], errors="coerce").dt.floor("30min")
+        chunk["end_time"] = pd.to_datetime(chunk["end_time"], errors="coerce").dt.floor("30min")
+        chunk = chunk.dropna(subset=["start_time", "end_time", "start_lat", "start_lng", "end_lat", "end_lng"])
+        chunk["out_grid"] = grid_id(chunk["start_lat"], chunk["start_lng"], args.min_lat, args.min_lng, args.grid_size)
+        chunk["in_grid"] = grid_id(chunk["end_lat"], chunk["end_lng"], args.min_lat, args.min_lng, args.grid_size)
+        out = chunk.groupby(["start_time", "out_grid"], observed=True).size().rename("out_count").reset_index()
+        out = out.rename(columns={"start_time": "time", "out_grid": "grid"})
+        inc = chunk.groupby(["end_time", "in_grid"], observed=True).size().rename("in_count").reset_index()
+        inc = inc.rename(columns={"end_time": "time", "in_grid": "grid"})
+        parts.append(pd.concat([out, inc], ignore_index=True))
+        if total % (args.chunk_size * 5) &lt; len(chunk):
+            print(f"已读取 {total:,} 条订单", flush=True)
+    conn.close()
+    if not parts:
+        raise SystemExit("没有可聚合的订单")
+    events = pd.concat(parts, ignore_index=True).fillna(0)
+    events = events.groupby(["time", "grid"], as_index=False)[["out_count", "in_count"]].sum()
+    grid_totals = events.groupby("grid")[["out_count", "in_count"]].sum().sum(axis=1)
+    selected = grid_totals.nlargest(args.top_grids).index.to_numpy(dtype=np.int32)
+    selected_set = set(int(x) for x in selected)
+    events = events[events["grid"].isin(selected_set)]
+    if events.empty:
+        raise SystemExit("top-grids过滤后没有数据")
+    start = events["time"].min()
+    end = events["time"].max()
+    times = pd.date_range(start=start, end=end, freq="30min")
+    grid_to_col = {int(g): i for i, g in enumerate(selected)}
+    demand = np.zeros((len(times), 2 * len(selected)), dtype=np.float32)</a:t>
+            </a:r>
+          </a:p>
+        </p:txBody>
+      </p:sp>
+    </p:spTree>
+  </p:cSld>
+  <p:clrMapOvr>
+    <a:masterClrMapping/>
+  </p:clrMapOvr>
+</p:sld>
+</file>
+
+<file path=ppt/slides/slide38.xml><?xml version="1.0" encoding="utf-8"?>
+<p:sld xmlns:a="http://schemas.openxmlformats.org/drawingml/2006/main" xmlns:p="http://schemas.openxmlformats.org/presentationml/2006/main" xmlns:r="http://schemas.openxmlformats.org/officeDocument/2006/relationships">
+  <p:cSld>
+    <p:spTree>
+      <p:nvGrpSpPr>
+        <p:cNvPr id="1" name=""/>
+        <p:cNvGrpSpPr/>
+        <p:nvPr/>
+      </p:nvGrpSpPr>
+      <p:grpSpPr/>
+      <p:sp>
+        <p:nvSpPr>
+          <p:cNvPr id="2" name="TextBox 1"/>
+          <p:cNvSpPr txBox="1"/>
+          <p:nvPr/>
+        </p:nvSpPr>
+        <p:spPr>
+          <a:xfrm>
+            <a:off x="548640" y="228600"/>
+            <a:ext cx="11064240" cy="640080"/>
+          </a:xfrm>
+          <a:prstGeom prst="rect">
+            <a:avLst/>
+          </a:prstGeom>
+          <a:noFill/>
+        </p:spPr>
+        <p:txBody>
+          <a:bodyPr wrap="none">
+            <a:spAutoFit/>
+          </a:bodyPr>
+          <a:lstStyle/>
+          <a:p>
+            <a:pPr>
+              <a:defRPr sz="2000" b="1">
+                <a:solidFill>
+                  <a:srgbClr val="1F4E79"/>
+                </a:solidFill>
+              </a:defRPr>
+            </a:pPr>
+            <a:r>
+              <a:t>源代码：需求聚合脚本 - aggregate_demand.py (4/4)</a:t>
+            </a:r>
+          </a:p>
+        </p:txBody>
+      </p:sp>
+      <p:sp>
+        <p:nvSpPr>
+          <p:cNvPr id="3" name="TextBox 2"/>
+          <p:cNvSpPr txBox="1"/>
+          <p:nvPr/>
+        </p:nvSpPr>
+        <p:spPr>
+          <a:xfrm>
+            <a:off x="457200" y="914400"/>
+            <a:ext cx="11247120" cy="5760720"/>
+          </a:xfrm>
+          <a:prstGeom prst="rect">
+            <a:avLst/>
+          </a:prstGeom>
+          <a:noFill/>
+        </p:spPr>
+        <p:txBody>
+          <a:bodyPr wrap="none">
+            <a:spAutoFit/>
+          </a:bodyPr>
+          <a:lstStyle/>
+          <a:p>
+            <a:r>
+              <a:rPr sz="900">
+                <a:latin typeface="Consolas"/>
+              </a:rPr>
+              <a:t>    time_pos = {t: i for i, t in enumerate(times)}
+    for row in events.itertuples(index=False):
+        t, g = row.time, int(row.grid)
+        i = time_pos.get(t)
+        j = grid_to_col.get(g)
+        if i is not None and j is not None:
+            demand[i, j] += float(row.out_count)
+            demand[i, len(selected) + j] += float(row.in_count)
+    time_features = make_features(times)
+    times_int = (times.as_unit("ns").asi8 // 10**9).astype(np.int64)
+    np.savez_compressed(output, times=times_int, demand=demand, time_features=time_features)
+    metadata = {
+        "source": str(source), "orders_read": total, "time_frequency": "30min",
+        "grid_size": args.grid_size, "min_lat": args.min_lat, "min_lng": args.min_lng,
+        "top_grids": [int(x) for x in selected], "num_grids": len(selected),
+        "num_time_steps": len(times), "start_time": str(times[0]), "end_time": str(times[-1]),
+        "feature_layout": "demand=[out_1..out_N,in_1..in_N], time_features=[day_sin,day_cos,week_sin,week_cos,weekend,peak]",
+    }
+    meta_path = output.with_name(output.stem + "_meta.json")
+    meta_path.write_text(json.dumps(metadata, ensure_ascii=False, indent=2), encoding="utf-8")
+    print(f"聚合完成：{output}")
+    print(f"时间步：{len(times):,}，网格：{len(selected)}，需求特征：{demand.shape[1]}")
+if __name__ == "__main__":
+    main()
+</a:t>
             </a:r>
           </a:p>
         </p:txBody>

</xml_diff>

<commit_message>
Replace full code slides with 6 focused code slides at 14pt
</commit_message>
<xml_diff>
--- a/report/presentation.pptx
+++ b/report/presentation.pptx
@@ -25,24 +25,12 @@
     <p:sldId id="267" r:id="rId18"/>
     <p:sldId id="268" r:id="rId19"/>
     <p:sldId id="275" r:id="rId26"/>
-    <p:sldId id="276" r:id="rId27"/>
-    <p:sldId id="277" r:id="rId28"/>
-    <p:sldId id="278" r:id="rId29"/>
-    <p:sldId id="279" r:id="rId30"/>
-    <p:sldId id="280" r:id="rId31"/>
-    <p:sldId id="281" r:id="rId32"/>
-    <p:sldId id="282" r:id="rId33"/>
-    <p:sldId id="283" r:id="rId34"/>
-    <p:sldId id="284" r:id="rId35"/>
-    <p:sldId id="285" r:id="rId36"/>
-    <p:sldId id="286" r:id="rId37"/>
-    <p:sldId id="287" r:id="rId38"/>
-    <p:sldId id="288" r:id="rId39"/>
-    <p:sldId id="289" r:id="rId40"/>
-    <p:sldId id="290" r:id="rId41"/>
-    <p:sldId id="291" r:id="rId42"/>
-    <p:sldId id="292" r:id="rId43"/>
-    <p:sldId id="293" r:id="rId44"/>
+    <p:sldId id="276" r:id="rId45"/>
+    <p:sldId id="277" r:id="rId46"/>
+    <p:sldId id="278" r:id="rId47"/>
+    <p:sldId id="279" r:id="rId48"/>
+    <p:sldId id="280" r:id="rId49"/>
+    <p:sldId id="281" r:id="rId50"/>
   </p:sldIdLst>
   <p:sldSz cx="12191695" cy="6858000" type="screen4x3"/>
   <p:notesSz cx="6858000" cy="9144000"/>
@@ -4757,7 +4745,7 @@
         <p:spPr>
           <a:xfrm>
             <a:off x="548640" y="228600"/>
-            <a:ext cx="11064240" cy="640080"/>
+            <a:ext cx="11064240" cy="685800"/>
           </a:xfrm>
           <a:prstGeom prst="rect">
             <a:avLst/>
@@ -4771,14 +4759,14 @@
           <a:lstStyle/>
           <a:p>
             <a:pPr>
-              <a:defRPr sz="2000" b="1">
+              <a:defRPr sz="2200" b="1">
                 <a:solidFill>
                   <a:srgbClr val="1F4E79"/>
                 </a:solidFill>
               </a:defRPr>
             </a:pPr>
             <a:r>
-              <a:t>源代码：Transformer模型定义 - transformer_model.py (1/4)</a:t>
+              <a:t>核心代码 1/6：空间注意力 SpatialAttention（transformer_model.py）</a:t>
             </a:r>
           </a:p>
         </p:txBody>
@@ -4791,8 +4779,8 @@
         </p:nvSpPr>
         <p:spPr>
           <a:xfrm>
-            <a:off x="457200" y="914400"/>
-            <a:ext cx="11247120" cy="5760720"/>
+            <a:off x="640080" y="960120"/>
+            <a:ext cx="10972800" cy="502920"/>
           </a:xfrm>
           <a:prstGeom prst="rect">
             <a:avLst/>
@@ -4805,34 +4793,209 @@
           </a:bodyPr>
           <a:lstStyle/>
           <a:p>
-            <a:r>
-              <a:rPr sz="900">
+            <a:pPr>
+              <a:defRPr sz="1400">
+                <a:solidFill>
+                  <a:srgbClr val="646464"/>
+                </a:solidFill>
+              </a:defRPr>
+            </a:pPr>
+            <a:r>
+              <a:t>让各网格表征在输出前做注意力交互，模拟空间依赖</a:t>
+            </a:r>
+          </a:p>
+        </p:txBody>
+      </p:sp>
+      <p:sp>
+        <p:nvSpPr>
+          <p:cNvPr id="4" name="TextBox 3"/>
+          <p:cNvSpPr txBox="1"/>
+          <p:nvPr/>
+        </p:nvSpPr>
+        <p:spPr>
+          <a:xfrm>
+            <a:off x="548640" y="1554480"/>
+            <a:ext cx="11064240" cy="5303520"/>
+          </a:xfrm>
+          <a:prstGeom prst="rect">
+            <a:avLst/>
+          </a:prstGeom>
+          <a:noFill/>
+        </p:spPr>
+        <p:txBody>
+          <a:bodyPr wrap="none">
+            <a:spAutoFit/>
+          </a:bodyPr>
+          <a:lstStyle/>
+          <a:p>
+            <a:r>
+              <a:rPr sz="1400">
+                <a:solidFill>
+                  <a:srgbClr val="202020"/>
+                </a:solidFill>
                 <a:latin typeface="Consolas"/>
               </a:rPr>
-              <a:t>"""多区域时序 Transformer Encoder。
-输入：X.shape == [batch, lookback, input_dim]
-输出：y_hat.shape == [batch, horizon, output_dim]
-对于 N 个空间网格，output_dim=2*N，前 N 个输出为借车量，后 N 个输出为还车量。
-"""
-from __future__ import annotations
-import math
-import torch
-from torch import Tensor, nn
-class SinusoidalPositionalEncoding(nn.Module):
-    def __init__(self, d_model: int, max_len: int = 512) -&gt; None:
+              <a:t>        return x + self.encoding[:, : x.size(1)]
+class SpatialAttention(nn.Module):
+    """在输出通道维度做自注意力，模拟网格间的信息交互。
+    输入 z: [batch, time, d_model]，转置后在 d_model 维度上做注意力，
+    相当于让每个时间步内不同"通道"（对应各网格的表征）互相交换信息。
+    """
+    def __init__(self, d_model: int, nhead: int, dropout: float = 0.1) -&gt; None:
         super().__init__()
-        position = torch.arange(max_len, dtype=torch.float32).unsqueeze(1)
-        div_term = torch.exp(
-            torch.arange(0, d_model, 2, dtype=torch.float32)
-            * (-math.log(10000.0) / d_model)
-        )
-        encoding = torch.zeros(max_len, d_model)
-        encoding[:, 0::2] = torch.sin(position * div_term)
-        encoding[:, 1::2] = torch.cos(position * div_term[: encoding[:, 1::2].shape[1]])
-        self.register_buffer("encoding", encoding.unsqueeze(0), persistent=False)
-    def forward(self, x: Tensor) -&gt; Tensor:
-        return x + self.encoding[:, : x.size(1)]
-</a:t>
+        self.mix_logits = nn.Parameter(torch.randn(d_model, d_model) * 0.02)
+        self.norm = nn.LayerNorm(d_model)
+    def forward(self, z: Tensor, num_nodes: int) -&gt; Tensor:
+        # 把 d_model 通道当作注意力序列，模拟节点间交互
+        batch, time, d = z.shape
+        # 每个时间步独立做：把d_model个通道看成序列，需要每个位置是d_model维向量，
+        # 但通道本身是标量，所以用1x1卷积做Q/K/V投影不可行。改为简单可学习加权混合。
+        # 简化：用可学习参数矩阵在d维度做注意力式混合（等效单头自注意力的值域）
+        weight = torch.softmax(self.mix_logits, dim=-1)  # [d, d]
+        mixed = torch.matmul(z, weight.T)  # [batch, time, d]
+        attn_out = mixed
+        return self.norm(z + attn_out)</a:t>
+            </a:r>
+          </a:p>
+        </p:txBody>
+      </p:sp>
+    </p:spTree>
+  </p:cSld>
+  <p:clrMapOvr>
+    <a:masterClrMapping/>
+  </p:clrMapOvr>
+</p:sld>
+</file>
+
+<file path=ppt/slides/slide21.xml><?xml version="1.0" encoding="utf-8"?>
+<p:sld xmlns:a="http://schemas.openxmlformats.org/drawingml/2006/main" xmlns:p="http://schemas.openxmlformats.org/presentationml/2006/main" xmlns:r="http://schemas.openxmlformats.org/officeDocument/2006/relationships">
+  <p:cSld>
+    <p:spTree>
+      <p:nvGrpSpPr>
+        <p:cNvPr id="1" name=""/>
+        <p:cNvGrpSpPr/>
+        <p:nvPr/>
+      </p:nvGrpSpPr>
+      <p:grpSpPr/>
+      <p:sp>
+        <p:nvSpPr>
+          <p:cNvPr id="2" name="TextBox 1"/>
+          <p:cNvSpPr txBox="1"/>
+          <p:nvPr/>
+        </p:nvSpPr>
+        <p:spPr>
+          <a:xfrm>
+            <a:off x="548640" y="228600"/>
+            <a:ext cx="11064240" cy="685800"/>
+          </a:xfrm>
+          <a:prstGeom prst="rect">
+            <a:avLst/>
+          </a:prstGeom>
+          <a:noFill/>
+        </p:spPr>
+        <p:txBody>
+          <a:bodyPr wrap="none">
+            <a:spAutoFit/>
+          </a:bodyPr>
+          <a:lstStyle/>
+          <a:p>
+            <a:pPr>
+              <a:defRPr sz="2200" b="1">
+                <a:solidFill>
+                  <a:srgbClr val="1F4E79"/>
+                </a:solidFill>
+              </a:defRPr>
+            </a:pPr>
+            <a:r>
+              <a:t>核心代码 1/6：空间注意力 SpatialAttention（transformer_model.py）</a:t>
+            </a:r>
+          </a:p>
+        </p:txBody>
+      </p:sp>
+      <p:sp>
+        <p:nvSpPr>
+          <p:cNvPr id="3" name="TextBox 2"/>
+          <p:cNvSpPr txBox="1"/>
+          <p:nvPr/>
+        </p:nvSpPr>
+        <p:spPr>
+          <a:xfrm>
+            <a:off x="640080" y="960120"/>
+            <a:ext cx="10972800" cy="502920"/>
+          </a:xfrm>
+          <a:prstGeom prst="rect">
+            <a:avLst/>
+          </a:prstGeom>
+          <a:noFill/>
+        </p:spPr>
+        <p:txBody>
+          <a:bodyPr wrap="none">
+            <a:spAutoFit/>
+          </a:bodyPr>
+          <a:lstStyle/>
+          <a:p>
+            <a:pPr>
+              <a:defRPr sz="1400">
+                <a:solidFill>
+                  <a:srgbClr val="646464"/>
+                </a:solidFill>
+              </a:defRPr>
+            </a:pPr>
+            <a:r>
+              <a:t>让各网格表征在输出前做注意力交互，模拟空间依赖</a:t>
+            </a:r>
+          </a:p>
+        </p:txBody>
+      </p:sp>
+      <p:sp>
+        <p:nvSpPr>
+          <p:cNvPr id="4" name="TextBox 3"/>
+          <p:cNvSpPr txBox="1"/>
+          <p:nvPr/>
+        </p:nvSpPr>
+        <p:spPr>
+          <a:xfrm>
+            <a:off x="548640" y="1554480"/>
+            <a:ext cx="11064240" cy="5303520"/>
+          </a:xfrm>
+          <a:prstGeom prst="rect">
+            <a:avLst/>
+          </a:prstGeom>
+          <a:noFill/>
+        </p:spPr>
+        <p:txBody>
+          <a:bodyPr wrap="none">
+            <a:spAutoFit/>
+          </a:bodyPr>
+          <a:lstStyle/>
+          <a:p>
+            <a:r>
+              <a:rPr sz="1400">
+                <a:solidFill>
+                  <a:srgbClr val="202020"/>
+                </a:solidFill>
+                <a:latin typeface="Consolas"/>
+              </a:rPr>
+              <a:t>        return x + self.encoding[:, : x.size(1)]
+class SpatialAttention(nn.Module):
+    """在输出通道维度做自注意力，模拟网格间的信息交互。
+    输入 z: [batch, time, d_model]，转置后在 d_model 维度上做注意力，
+    相当于让每个时间步内不同"通道"（对应各网格的表征）互相交换信息。
+    """
+    def __init__(self, d_model: int, nhead: int, dropout: float = 0.1) -&gt; None:
+        super().__init__()
+        self.mix_logits = nn.Parameter(torch.randn(d_model, d_model) * 0.02)
+        self.norm = nn.LayerNorm(d_model)
+    def forward(self, z: Tensor, num_nodes: int) -&gt; Tensor:
+        # 把 d_model 通道当作注意力序列，模拟节点间交互
+        batch, time, d = z.shape
+        # 每个时间步独立做：把d_model个通道看成序列，需要每个位置是d_model维向量，
+        # 但通道本身是标量，所以用1x1卷积做Q/K/V投影不可行。改为简单可学习加权混合。
+        # 简化：用可学习参数矩阵在d维度做注意力式混合（等效单头自注意力的值域）
+        weight = torch.softmax(self.mix_logits, dim=-1)  # [d, d]
+        mixed = torch.matmul(z, weight.T)  # [batch, time, d]
+        attn_out = mixed
+        return self.norm(z + attn_out)</a:t>
             </a:r>
           </a:p>
         </p:txBody>
@@ -4864,7 +5027,7 @@
         <p:spPr>
           <a:xfrm>
             <a:off x="548640" y="228600"/>
-            <a:ext cx="11064240" cy="640080"/>
+            <a:ext cx="11064240" cy="685800"/>
           </a:xfrm>
           <a:prstGeom prst="rect">
             <a:avLst/>
@@ -4878,14 +5041,14 @@
           <a:lstStyle/>
           <a:p>
             <a:pPr>
-              <a:defRPr sz="2000" b="1">
+              <a:defRPr sz="2200" b="1">
                 <a:solidFill>
                   <a:srgbClr val="1F4E79"/>
                 </a:solidFill>
               </a:defRPr>
             </a:pPr>
             <a:r>
-              <a:t>源代码：Transformer模型定义 - transformer_model.py (2/4)</a:t>
+              <a:t>核心代码 2/6：Transformer主干（transformer_model.py）</a:t>
             </a:r>
           </a:p>
         </p:txBody>
@@ -4898,8 +5061,8 @@
         </p:nvSpPr>
         <p:spPr>
           <a:xfrm>
-            <a:off x="457200" y="914400"/>
-            <a:ext cx="11247120" cy="5760720"/>
+            <a:off x="640080" y="960120"/>
+            <a:ext cx="10972800" cy="502920"/>
           </a:xfrm>
           <a:prstGeom prst="rect">
             <a:avLst/>
@@ -4912,122 +5075,49 @@
           </a:bodyPr>
           <a:lstStyle/>
           <a:p>
-            <a:r>
-              <a:rPr sz="900">
+            <a:pPr>
+              <a:defRPr sz="1400">
+                <a:solidFill>
+                  <a:srgbClr val="646464"/>
+                </a:solidFill>
+              </a:defRPr>
+            </a:pPr>
+            <a:r>
+              <a:t>输入投影 → 位置编码 → 时间Transformer编码器 → 空间注意力</a:t>
+            </a:r>
+          </a:p>
+        </p:txBody>
+      </p:sp>
+      <p:sp>
+        <p:nvSpPr>
+          <p:cNvPr id="4" name="TextBox 3"/>
+          <p:cNvSpPr txBox="1"/>
+          <p:nvPr/>
+        </p:nvSpPr>
+        <p:spPr>
+          <a:xfrm>
+            <a:off x="548640" y="1554480"/>
+            <a:ext cx="11064240" cy="5303520"/>
+          </a:xfrm>
+          <a:prstGeom prst="rect">
+            <a:avLst/>
+          </a:prstGeom>
+          <a:noFill/>
+        </p:spPr>
+        <p:txBody>
+          <a:bodyPr wrap="none">
+            <a:spAutoFit/>
+          </a:bodyPr>
+          <a:lstStyle/>
+          <a:p>
+            <a:r>
+              <a:rPr sz="1400">
+                <a:solidFill>
+                  <a:srgbClr val="202020"/>
+                </a:solidFill>
                 <a:latin typeface="Consolas"/>
               </a:rPr>
-              <a:t>
-class SpatialAttention(nn.Module):
-    """在输出通道维度做自注意力，模拟网格间的信息交互。
-    输入 z: [batch, time, d_model]，转置后在 d_model 维度上做注意力，
-    相当于让每个时间步内不同"通道"（对应各网格的表征）互相交换信息。
-    """
-    def __init__(self, d_model: int, nhead: int, dropout: float = 0.1) -&gt; None:
-        super().__init__()
-        self.mix_logits = nn.Parameter(torch.randn(d_model, d_model) * 0.02)
-        self.norm = nn.LayerNorm(d_model)
-    def forward(self, z: Tensor, num_nodes: int) -&gt; Tensor:
-        # 把 d_model 通道当作注意力序列，模拟节点间交互
-        batch, time, d = z.shape
-        # 每个时间步独立做：把d_model个通道看成序列，需要每个位置是d_model维向量，
-        # 但通道本身是标量，所以用1x1卷积做Q/K/V投影不可行。改为简单可学习加权混合。
-        # 简化：用可学习参数矩阵在d维度做注意力式混合（等效单头自注意力的值域）
-        weight = torch.softmax(self.mix_logits, dim=-1)  # [d, d]
-        mixed = torch.matmul(z, weight.T)  # [batch, time, d]
-        attn_out = mixed
-        return self.norm(z + attn_out)
-class TemporalTransformer(nn.Module):
-    def __init__(
-        self,
-        input_dim: int,
-        output_dim: int,
-        d_model: int = 128,
-        nhead: int = 4,</a:t>
-            </a:r>
-          </a:p>
-        </p:txBody>
-      </p:sp>
-    </p:spTree>
-  </p:cSld>
-  <p:clrMapOvr>
-    <a:masterClrMapping/>
-  </p:clrMapOvr>
-</p:sld>
-</file>
-
-<file path=ppt/slides/slide23.xml><?xml version="1.0" encoding="utf-8"?>
-<p:sld xmlns:a="http://schemas.openxmlformats.org/drawingml/2006/main" xmlns:p="http://schemas.openxmlformats.org/presentationml/2006/main" xmlns:r="http://schemas.openxmlformats.org/officeDocument/2006/relationships">
-  <p:cSld>
-    <p:spTree>
-      <p:nvGrpSpPr>
-        <p:cNvPr id="1" name=""/>
-        <p:cNvGrpSpPr/>
-        <p:nvPr/>
-      </p:nvGrpSpPr>
-      <p:grpSpPr/>
-      <p:sp>
-        <p:nvSpPr>
-          <p:cNvPr id="2" name="TextBox 1"/>
-          <p:cNvSpPr txBox="1"/>
-          <p:nvPr/>
-        </p:nvSpPr>
-        <p:spPr>
-          <a:xfrm>
-            <a:off x="548640" y="228600"/>
-            <a:ext cx="11064240" cy="640080"/>
-          </a:xfrm>
-          <a:prstGeom prst="rect">
-            <a:avLst/>
-          </a:prstGeom>
-          <a:noFill/>
-        </p:spPr>
-        <p:txBody>
-          <a:bodyPr wrap="none">
-            <a:spAutoFit/>
-          </a:bodyPr>
-          <a:lstStyle/>
-          <a:p>
-            <a:pPr>
-              <a:defRPr sz="2000" b="1">
-                <a:solidFill>
-                  <a:srgbClr val="1F4E79"/>
-                </a:solidFill>
-              </a:defRPr>
-            </a:pPr>
-            <a:r>
-              <a:t>源代码：Transformer模型定义 - transformer_model.py (3/4)</a:t>
-            </a:r>
-          </a:p>
-        </p:txBody>
-      </p:sp>
-      <p:sp>
-        <p:nvSpPr>
-          <p:cNvPr id="3" name="TextBox 2"/>
-          <p:cNvSpPr txBox="1"/>
-          <p:nvPr/>
-        </p:nvSpPr>
-        <p:spPr>
-          <a:xfrm>
-            <a:off x="457200" y="914400"/>
-            <a:ext cx="11247120" cy="5760720"/>
-          </a:xfrm>
-          <a:prstGeom prst="rect">
-            <a:avLst/>
-          </a:prstGeom>
-          <a:noFill/>
-        </p:spPr>
-        <p:txBody>
-          <a:bodyPr wrap="none">
-            <a:spAutoFit/>
-          </a:bodyPr>
-          <a:lstStyle/>
-          <a:p>
-            <a:r>
-              <a:rPr sz="900">
-                <a:latin typeface="Consolas"/>
-              </a:rPr>
-              <a:t>        num_encoder_layers: int = 2,
-        num_nodes: int = 0,
+              <a:t>        num_nodes: int = 0,
         use_spatial_attention: bool = False,
         dim_feedforward: int = 256,
         dropout: float = 0.1,
@@ -5053,11 +5143,423 @@
             dim_feedforward=dim_feedforward,
             dropout=dropout,
             activation="gelu",
-            batch_first=True,
-            norm_first=True,
+            batch_first=True,</a:t>
+            </a:r>
+          </a:p>
+        </p:txBody>
+      </p:sp>
+    </p:spTree>
+  </p:cSld>
+  <p:clrMapOvr>
+    <a:masterClrMapping/>
+  </p:clrMapOvr>
+</p:sld>
+</file>
+
+<file path=ppt/slides/slide22.xml><?xml version="1.0" encoding="utf-8"?>
+<p:sld xmlns:a="http://schemas.openxmlformats.org/drawingml/2006/main" xmlns:p="http://schemas.openxmlformats.org/presentationml/2006/main" xmlns:r="http://schemas.openxmlformats.org/officeDocument/2006/relationships">
+  <p:cSld>
+    <p:spTree>
+      <p:nvGrpSpPr>
+        <p:cNvPr id="1" name=""/>
+        <p:cNvGrpSpPr/>
+        <p:nvPr/>
+      </p:nvGrpSpPr>
+      <p:grpSpPr/>
+      <p:sp>
+        <p:nvSpPr>
+          <p:cNvPr id="2" name="TextBox 1"/>
+          <p:cNvSpPr txBox="1"/>
+          <p:nvPr/>
+        </p:nvSpPr>
+        <p:spPr>
+          <a:xfrm>
+            <a:off x="548640" y="228600"/>
+            <a:ext cx="11064240" cy="685800"/>
+          </a:xfrm>
+          <a:prstGeom prst="rect">
+            <a:avLst/>
+          </a:prstGeom>
+          <a:noFill/>
+        </p:spPr>
+        <p:txBody>
+          <a:bodyPr wrap="none">
+            <a:spAutoFit/>
+          </a:bodyPr>
+          <a:lstStyle/>
+          <a:p>
+            <a:pPr>
+              <a:defRPr sz="2200" b="1">
+                <a:solidFill>
+                  <a:srgbClr val="1F4E79"/>
+                </a:solidFill>
+              </a:defRPr>
+            </a:pPr>
+            <a:r>
+              <a:t>核心代码 2/6：Transformer主干（transformer_model.py）</a:t>
+            </a:r>
+          </a:p>
+        </p:txBody>
+      </p:sp>
+      <p:sp>
+        <p:nvSpPr>
+          <p:cNvPr id="3" name="TextBox 2"/>
+          <p:cNvSpPr txBox="1"/>
+          <p:nvPr/>
+        </p:nvSpPr>
+        <p:spPr>
+          <a:xfrm>
+            <a:off x="640080" y="960120"/>
+            <a:ext cx="10972800" cy="502920"/>
+          </a:xfrm>
+          <a:prstGeom prst="rect">
+            <a:avLst/>
+          </a:prstGeom>
+          <a:noFill/>
+        </p:spPr>
+        <p:txBody>
+          <a:bodyPr wrap="none">
+            <a:spAutoFit/>
+          </a:bodyPr>
+          <a:lstStyle/>
+          <a:p>
+            <a:pPr>
+              <a:defRPr sz="1400">
+                <a:solidFill>
+                  <a:srgbClr val="646464"/>
+                </a:solidFill>
+              </a:defRPr>
+            </a:pPr>
+            <a:r>
+              <a:t>输入投影 → 位置编码 → 时间Transformer编码器 → 空间注意力</a:t>
+            </a:r>
+          </a:p>
+        </p:txBody>
+      </p:sp>
+      <p:sp>
+        <p:nvSpPr>
+          <p:cNvPr id="4" name="TextBox 3"/>
+          <p:cNvSpPr txBox="1"/>
+          <p:nvPr/>
+        </p:nvSpPr>
+        <p:spPr>
+          <a:xfrm>
+            <a:off x="548640" y="1554480"/>
+            <a:ext cx="11064240" cy="5303520"/>
+          </a:xfrm>
+          <a:prstGeom prst="rect">
+            <a:avLst/>
+          </a:prstGeom>
+          <a:noFill/>
+        </p:spPr>
+        <p:txBody>
+          <a:bodyPr wrap="none">
+            <a:spAutoFit/>
+          </a:bodyPr>
+          <a:lstStyle/>
+          <a:p>
+            <a:r>
+              <a:rPr sz="1400">
+                <a:solidFill>
+                  <a:srgbClr val="202020"/>
+                </a:solidFill>
+                <a:latin typeface="Consolas"/>
+              </a:rPr>
+              <a:t>        num_nodes: int = 0,
+        use_spatial_attention: bool = False,
+        dim_feedforward: int = 256,
+        dropout: float = 0.1,
+        horizon: int = 1,
+        max_len: int = 512,
+    ) -&gt; None:
+        super().__init__()
+        if d_model % nhead != 0:
+            raise ValueError("d_model必须能被nhead整除")
+        self.horizon = horizon
+        self.output_dim = output_dim
+        self.num_nodes = num_nodes
+        if use_spatial_attention and num_nodes &lt;= 0:
+            raise ValueError("启用空间注意力时必须提供num_nodes")
+        self.input_projection = nn.Sequential(
+            nn.Linear(input_dim, d_model),
+            nn.LayerNorm(d_model),
         )
+        self.position = SinusoidalPositionalEncoding(d_model, max_len=max_len)
+        layer = nn.TransformerEncoderLayer(
+            d_model=d_model,
+            nhead=nhead,
+            dim_feedforward=dim_feedforward,
+            dropout=dropout,
+            activation="gelu",
+            batch_first=True,</a:t>
+            </a:r>
+          </a:p>
+        </p:txBody>
+      </p:sp>
+    </p:spTree>
+  </p:cSld>
+  <p:clrMapOvr>
+    <a:masterClrMapping/>
+  </p:clrMapOvr>
+</p:sld>
+</file>
+
+<file path=ppt/slides/slide23.xml><?xml version="1.0" encoding="utf-8"?>
+<p:sld xmlns:a="http://schemas.openxmlformats.org/drawingml/2006/main" xmlns:p="http://schemas.openxmlformats.org/presentationml/2006/main" xmlns:r="http://schemas.openxmlformats.org/officeDocument/2006/relationships">
+  <p:cSld>
+    <p:spTree>
+      <p:nvGrpSpPr>
+        <p:cNvPr id="1" name=""/>
+        <p:cNvGrpSpPr/>
+        <p:nvPr/>
+      </p:nvGrpSpPr>
+      <p:grpSpPr/>
+      <p:sp>
+        <p:nvSpPr>
+          <p:cNvPr id="2" name="TextBox 1"/>
+          <p:cNvSpPr txBox="1"/>
+          <p:nvPr/>
+        </p:nvSpPr>
+        <p:spPr>
+          <a:xfrm>
+            <a:off x="548640" y="228600"/>
+            <a:ext cx="11064240" cy="685800"/>
+          </a:xfrm>
+          <a:prstGeom prst="rect">
+            <a:avLst/>
+          </a:prstGeom>
+          <a:noFill/>
+        </p:spPr>
+        <p:txBody>
+          <a:bodyPr wrap="none">
+            <a:spAutoFit/>
+          </a:bodyPr>
+          <a:lstStyle/>
+          <a:p>
+            <a:pPr>
+              <a:defRPr sz="2200" b="1">
+                <a:solidFill>
+                  <a:srgbClr val="1F4E79"/>
+                </a:solidFill>
+              </a:defRPr>
+            </a:pPr>
+            <a:r>
+              <a:t>核心代码 3/6：前向传播（transformer_model.py）</a:t>
+            </a:r>
+          </a:p>
+        </p:txBody>
+      </p:sp>
+      <p:sp>
+        <p:nvSpPr>
+          <p:cNvPr id="3" name="TextBox 2"/>
+          <p:cNvSpPr txBox="1"/>
+          <p:nvPr/>
+        </p:nvSpPr>
+        <p:spPr>
+          <a:xfrm>
+            <a:off x="640080" y="960120"/>
+            <a:ext cx="10972800" cy="502920"/>
+          </a:xfrm>
+          <a:prstGeom prst="rect">
+            <a:avLst/>
+          </a:prstGeom>
+          <a:noFill/>
+        </p:spPr>
+        <p:txBody>
+          <a:bodyPr wrap="none">
+            <a:spAutoFit/>
+          </a:bodyPr>
+          <a:lstStyle/>
+          <a:p>
+            <a:pPr>
+              <a:defRPr sz="1400">
+                <a:solidFill>
+                  <a:srgbClr val="646464"/>
+                </a:solidFill>
+              </a:defRPr>
+            </a:pPr>
+            <a:r>
+              <a:t>取最后时间步输出，Linear映射为未来需求预测</a:t>
+            </a:r>
+          </a:p>
+        </p:txBody>
+      </p:sp>
+      <p:sp>
+        <p:nvSpPr>
+          <p:cNvPr id="4" name="TextBox 3"/>
+          <p:cNvSpPr txBox="1"/>
+          <p:nvPr/>
+        </p:nvSpPr>
+        <p:spPr>
+          <a:xfrm>
+            <a:off x="548640" y="1554480"/>
+            <a:ext cx="11064240" cy="5303520"/>
+          </a:xfrm>
+          <a:prstGeom prst="rect">
+            <a:avLst/>
+          </a:prstGeom>
+          <a:noFill/>
+        </p:spPr>
+        <p:txBody>
+          <a:bodyPr wrap="none">
+            <a:spAutoFit/>
+          </a:bodyPr>
+          <a:lstStyle/>
+          <a:p>
+            <a:r>
+              <a:rPr sz="1400">
+                <a:solidFill>
+                  <a:srgbClr val="202020"/>
+                </a:solidFill>
+                <a:latin typeface="Consolas"/>
+              </a:rPr>
+              <a:t>        )
         self.encoder = nn.TransformerEncoder(layer, num_layers=num_encoder_layers)
-        self.spatial = (</a:t>
+        self.spatial = (
+            SpatialAttention(d_model, nhead, dropout=dropout)
+            if use_spatial_attention and num_nodes &gt; 1
+            else None
+        )
+        self.head = nn.Sequential(
+            nn.LayerNorm(d_model),
+            nn.Linear(d_model, horizon * output_dim),
+        )
+    def forward(self, x: Tensor) -&gt; Tensor:
+        if x.ndim != 3:</a:t>
+            </a:r>
+          </a:p>
+        </p:txBody>
+      </p:sp>
+    </p:spTree>
+  </p:cSld>
+  <p:clrMapOvr>
+    <a:masterClrMapping/>
+  </p:clrMapOvr>
+</p:sld>
+</file>
+
+<file path=ppt/slides/slide23.xml><?xml version="1.0" encoding="utf-8"?>
+<p:sld xmlns:a="http://schemas.openxmlformats.org/drawingml/2006/main" xmlns:p="http://schemas.openxmlformats.org/presentationml/2006/main" xmlns:r="http://schemas.openxmlformats.org/officeDocument/2006/relationships">
+  <p:cSld>
+    <p:spTree>
+      <p:nvGrpSpPr>
+        <p:cNvPr id="1" name=""/>
+        <p:cNvGrpSpPr/>
+        <p:nvPr/>
+      </p:nvGrpSpPr>
+      <p:grpSpPr/>
+      <p:sp>
+        <p:nvSpPr>
+          <p:cNvPr id="2" name="TextBox 1"/>
+          <p:cNvSpPr txBox="1"/>
+          <p:nvPr/>
+        </p:nvSpPr>
+        <p:spPr>
+          <a:xfrm>
+            <a:off x="548640" y="228600"/>
+            <a:ext cx="11064240" cy="685800"/>
+          </a:xfrm>
+          <a:prstGeom prst="rect">
+            <a:avLst/>
+          </a:prstGeom>
+          <a:noFill/>
+        </p:spPr>
+        <p:txBody>
+          <a:bodyPr wrap="none">
+            <a:spAutoFit/>
+          </a:bodyPr>
+          <a:lstStyle/>
+          <a:p>
+            <a:pPr>
+              <a:defRPr sz="2200" b="1">
+                <a:solidFill>
+                  <a:srgbClr val="1F4E79"/>
+                </a:solidFill>
+              </a:defRPr>
+            </a:pPr>
+            <a:r>
+              <a:t>核心代码 3/6：前向传播（transformer_model.py）</a:t>
+            </a:r>
+          </a:p>
+        </p:txBody>
+      </p:sp>
+      <p:sp>
+        <p:nvSpPr>
+          <p:cNvPr id="3" name="TextBox 2"/>
+          <p:cNvSpPr txBox="1"/>
+          <p:nvPr/>
+        </p:nvSpPr>
+        <p:spPr>
+          <a:xfrm>
+            <a:off x="640080" y="960120"/>
+            <a:ext cx="10972800" cy="502920"/>
+          </a:xfrm>
+          <a:prstGeom prst="rect">
+            <a:avLst/>
+          </a:prstGeom>
+          <a:noFill/>
+        </p:spPr>
+        <p:txBody>
+          <a:bodyPr wrap="none">
+            <a:spAutoFit/>
+          </a:bodyPr>
+          <a:lstStyle/>
+          <a:p>
+            <a:pPr>
+              <a:defRPr sz="1400">
+                <a:solidFill>
+                  <a:srgbClr val="646464"/>
+                </a:solidFill>
+              </a:defRPr>
+            </a:pPr>
+            <a:r>
+              <a:t>取最后时间步输出，Linear映射为未来需求预测</a:t>
+            </a:r>
+          </a:p>
+        </p:txBody>
+      </p:sp>
+      <p:sp>
+        <p:nvSpPr>
+          <p:cNvPr id="4" name="TextBox 3"/>
+          <p:cNvSpPr txBox="1"/>
+          <p:nvPr/>
+        </p:nvSpPr>
+        <p:spPr>
+          <a:xfrm>
+            <a:off x="548640" y="1554480"/>
+            <a:ext cx="11064240" cy="5303520"/>
+          </a:xfrm>
+          <a:prstGeom prst="rect">
+            <a:avLst/>
+          </a:prstGeom>
+          <a:noFill/>
+        </p:spPr>
+        <p:txBody>
+          <a:bodyPr wrap="none">
+            <a:spAutoFit/>
+          </a:bodyPr>
+          <a:lstStyle/>
+          <a:p>
+            <a:r>
+              <a:rPr sz="1400">
+                <a:solidFill>
+                  <a:srgbClr val="202020"/>
+                </a:solidFill>
+                <a:latin typeface="Consolas"/>
+              </a:rPr>
+              <a:t>        )
+        self.encoder = nn.TransformerEncoder(layer, num_layers=num_encoder_layers)
+        self.spatial = (
+            SpatialAttention(d_model, nhead, dropout=dropout)
+            if use_spatial_attention and num_nodes &gt; 1
+            else None
+        )
+        self.head = nn.Sequential(
+            nn.LayerNorm(d_model),
+            nn.Linear(d_model, horizon * output_dim),
+        )
+    def forward(self, x: Tensor) -&gt; Tensor:
+        if x.ndim != 3:</a:t>
             </a:r>
           </a:p>
         </p:txBody>
@@ -5089,7 +5591,7 @@
         <p:spPr>
           <a:xfrm>
             <a:off x="548640" y="228600"/>
-            <a:ext cx="11064240" cy="640080"/>
+            <a:ext cx="11064240" cy="685800"/>
           </a:xfrm>
           <a:prstGeom prst="rect">
             <a:avLst/>
@@ -5103,14 +5605,14 @@
           <a:lstStyle/>
           <a:p>
             <a:pPr>
-              <a:defRPr sz="2000" b="1">
+              <a:defRPr sz="2200" b="1">
                 <a:solidFill>
                   <a:srgbClr val="1F4E79"/>
                 </a:solidFill>
               </a:defRPr>
             </a:pPr>
             <a:r>
-              <a:t>源代码：Transformer模型定义 - transformer_model.py (4/4)</a:t>
+              <a:t>核心代码 4/6：数据窗口构造（train_transformer.py）</a:t>
             </a:r>
           </a:p>
         </p:txBody>
@@ -5123,8 +5625,8 @@
         </p:nvSpPr>
         <p:spPr>
           <a:xfrm>
-            <a:off x="457200" y="914400"/>
-            <a:ext cx="11247120" cy="5760720"/>
+            <a:off x="640080" y="960120"/>
+            <a:ext cx="10972800" cy="502920"/>
           </a:xfrm>
           <a:prstGeom prst="rect">
             <a:avLst/>
@@ -5137,36 +5639,193 @@
           </a:bodyPr>
           <a:lstStyle/>
           <a:p>
-            <a:r>
-              <a:rPr sz="900">
+            <a:pPr>
+              <a:defRPr sz="1400">
+                <a:solidFill>
+                  <a:srgbClr val="646464"/>
+                </a:solidFill>
+              </a:defRPr>
+            </a:pPr>
+            <a:r>
+              <a:t>lag48特征：前一日同时刻需求，为残差学习提供显式基线</a:t>
+            </a:r>
+          </a:p>
+        </p:txBody>
+      </p:sp>
+      <p:sp>
+        <p:nvSpPr>
+          <p:cNvPr id="4" name="TextBox 3"/>
+          <p:cNvSpPr txBox="1"/>
+          <p:nvPr/>
+        </p:nvSpPr>
+        <p:spPr>
+          <a:xfrm>
+            <a:off x="548640" y="1554480"/>
+            <a:ext cx="11064240" cy="5303520"/>
+          </a:xfrm>
+          <a:prstGeom prst="rect">
+            <a:avLst/>
+          </a:prstGeom>
+          <a:noFill/>
+        </p:spPr>
+        <p:txBody>
+          <a:bodyPr wrap="none">
+            <a:spAutoFit/>
+          </a:bodyPr>
+          <a:lstStyle/>
+          <a:p>
+            <a:r>
+              <a:rPr sz="1400">
+                <a:solidFill>
+                  <a:srgbClr val="202020"/>
+                </a:solidFill>
                 <a:latin typeface="Consolas"/>
               </a:rPr>
-              <a:t>            SpatialAttention(d_model, nhead, dropout=dropout)
-            if use_spatial_attention and num_nodes &gt; 1
-            else None
-        )
-        self.head = nn.Sequential(
-            nn.LayerNorm(d_model),
-            nn.Linear(d_model, horizon * output_dim),
-        )
-    def forward(self, x: Tensor) -&gt; Tensor:
-        if x.ndim != 3:
-            raise ValueError("输入必须是[batch, time, feature]三维张量")
-        z = self.input_projection(x)
-        z = self.position(z)
-        z = self.encoder(z)
-        if self.spatial is not None:
-            z = self.spatial(z, self.num_nodes)
-        last_state = z[:, -1]
-        prediction = self.head(last_state)
-        return prediction.view(x.size(0), self.horizon, self.output_dim)
-if __name__ == "__main__":
-    model = TemporalTransformer(input_dim=80, output_dim=60)
-    sample = torch.randn(4, 48, 80)
-    result = model(sample)
-    print("input:", tuple(sample.shape))
-    print("output:", tuple(result.shape))
-</a:t>
+              <a:t>
+class WindowDataset(Dataset):
+    def __init__(self, x: np.ndarray, y: np.ndarray, targets: np.ndarray, lookback: int, horizon: int):
+        self.x, self.y, self.targets = x, y, targets
+        self.lookback, self.horizon = lookback, horizon
+    def __len__(self) -&gt; int:
+        return len(self.targets)
+    def __getitem__(self, index: int):
+        t = int(self.targets[index])
+        lag48 = np.repeat(self.x[t - 48:t - 47], self.lookback, axis=0)
+        features = np.concatenate(
+            [self.x[t - self.lookback:t], self.y[t - self.lookback:t], lag48], axis=1</a:t>
+            </a:r>
+          </a:p>
+        </p:txBody>
+      </p:sp>
+    </p:spTree>
+  </p:cSld>
+  <p:clrMapOvr>
+    <a:masterClrMapping/>
+  </p:clrMapOvr>
+</p:sld>
+</file>
+
+<file path=ppt/slides/slide24.xml><?xml version="1.0" encoding="utf-8"?>
+<p:sld xmlns:a="http://schemas.openxmlformats.org/drawingml/2006/main" xmlns:p="http://schemas.openxmlformats.org/presentationml/2006/main" xmlns:r="http://schemas.openxmlformats.org/officeDocument/2006/relationships">
+  <p:cSld>
+    <p:spTree>
+      <p:nvGrpSpPr>
+        <p:cNvPr id="1" name=""/>
+        <p:cNvGrpSpPr/>
+        <p:nvPr/>
+      </p:nvGrpSpPr>
+      <p:grpSpPr/>
+      <p:sp>
+        <p:nvSpPr>
+          <p:cNvPr id="2" name="TextBox 1"/>
+          <p:cNvSpPr txBox="1"/>
+          <p:nvPr/>
+        </p:nvSpPr>
+        <p:spPr>
+          <a:xfrm>
+            <a:off x="548640" y="228600"/>
+            <a:ext cx="11064240" cy="685800"/>
+          </a:xfrm>
+          <a:prstGeom prst="rect">
+            <a:avLst/>
+          </a:prstGeom>
+          <a:noFill/>
+        </p:spPr>
+        <p:txBody>
+          <a:bodyPr wrap="none">
+            <a:spAutoFit/>
+          </a:bodyPr>
+          <a:lstStyle/>
+          <a:p>
+            <a:pPr>
+              <a:defRPr sz="2200" b="1">
+                <a:solidFill>
+                  <a:srgbClr val="1F4E79"/>
+                </a:solidFill>
+              </a:defRPr>
+            </a:pPr>
+            <a:r>
+              <a:t>核心代码 4/6：数据窗口构造（train_transformer.py）</a:t>
+            </a:r>
+          </a:p>
+        </p:txBody>
+      </p:sp>
+      <p:sp>
+        <p:nvSpPr>
+          <p:cNvPr id="3" name="TextBox 2"/>
+          <p:cNvSpPr txBox="1"/>
+          <p:nvPr/>
+        </p:nvSpPr>
+        <p:spPr>
+          <a:xfrm>
+            <a:off x="640080" y="960120"/>
+            <a:ext cx="10972800" cy="502920"/>
+          </a:xfrm>
+          <a:prstGeom prst="rect">
+            <a:avLst/>
+          </a:prstGeom>
+          <a:noFill/>
+        </p:spPr>
+        <p:txBody>
+          <a:bodyPr wrap="none">
+            <a:spAutoFit/>
+          </a:bodyPr>
+          <a:lstStyle/>
+          <a:p>
+            <a:pPr>
+              <a:defRPr sz="1400">
+                <a:solidFill>
+                  <a:srgbClr val="646464"/>
+                </a:solidFill>
+              </a:defRPr>
+            </a:pPr>
+            <a:r>
+              <a:t>lag48特征：前一日同时刻需求，为残差学习提供显式基线</a:t>
+            </a:r>
+          </a:p>
+        </p:txBody>
+      </p:sp>
+      <p:sp>
+        <p:nvSpPr>
+          <p:cNvPr id="4" name="TextBox 3"/>
+          <p:cNvSpPr txBox="1"/>
+          <p:nvPr/>
+        </p:nvSpPr>
+        <p:spPr>
+          <a:xfrm>
+            <a:off x="548640" y="1554480"/>
+            <a:ext cx="11064240" cy="5303520"/>
+          </a:xfrm>
+          <a:prstGeom prst="rect">
+            <a:avLst/>
+          </a:prstGeom>
+          <a:noFill/>
+        </p:spPr>
+        <p:txBody>
+          <a:bodyPr wrap="none">
+            <a:spAutoFit/>
+          </a:bodyPr>
+          <a:lstStyle/>
+          <a:p>
+            <a:r>
+              <a:rPr sz="1400">
+                <a:solidFill>
+                  <a:srgbClr val="202020"/>
+                </a:solidFill>
+                <a:latin typeface="Consolas"/>
+              </a:rPr>
+              <a:t>
+class WindowDataset(Dataset):
+    def __init__(self, x: np.ndarray, y: np.ndarray, targets: np.ndarray, lookback: int, horizon: int):
+        self.x, self.y, self.targets = x, y, targets
+        self.lookback, self.horizon = lookback, horizon
+    def __len__(self) -&gt; int:
+        return len(self.targets)
+    def __getitem__(self, index: int):
+        t = int(self.targets[index])
+        lag48 = np.repeat(self.x[t - 48:t - 47], self.lookback, axis=0)
+        features = np.concatenate(
+            [self.x[t - self.lookback:t], self.y[t - self.lookback:t], lag48], axis=1</a:t>
             </a:r>
           </a:p>
         </p:txBody>
@@ -5198,7 +5857,7 @@
         <p:spPr>
           <a:xfrm>
             <a:off x="548640" y="228600"/>
-            <a:ext cx="11064240" cy="640080"/>
+            <a:ext cx="11064240" cy="685800"/>
           </a:xfrm>
           <a:prstGeom prst="rect">
             <a:avLst/>
@@ -5212,14 +5871,14 @@
           <a:lstStyle/>
           <a:p>
             <a:pPr>
-              <a:defRPr sz="2000" b="1">
+              <a:defRPr sz="2200" b="1">
                 <a:solidFill>
                   <a:srgbClr val="1F4E79"/>
                 </a:solidFill>
               </a:defRPr>
             </a:pPr>
             <a:r>
-              <a:t>源代码：Transformer训练脚本 - train_transformer.py (1/8)</a:t>
+              <a:t>核心代码 5/6：评价指标（train_transformer.py）</a:t>
             </a:r>
           </a:p>
         </p:txBody>
@@ -5232,8 +5891,8 @@
         </p:nvSpPr>
         <p:spPr>
           <a:xfrm>
-            <a:off x="457200" y="914400"/>
-            <a:ext cx="11247120" cy="5760720"/>
+            <a:off x="640080" y="960120"/>
+            <a:ext cx="10972800" cy="502920"/>
           </a:xfrm>
           <a:prstGeom prst="rect">
             <a:avLst/>
@@ -5246,33 +5905,183 @@
           </a:bodyPr>
           <a:lstStyle/>
           <a:p>
-            <a:r>
-              <a:rPr sz="900">
+            <a:pPr>
+              <a:defRPr sz="1400">
+                <a:solidFill>
+                  <a:srgbClr val="646464"/>
+                </a:solidFill>
+              </a:defRPr>
+            </a:pPr>
+            <a:r>
+              <a:t>MAE / RMSE / MAPE / WMAPE 四项指标，WMAPE为主要参考</a:t>
+            </a:r>
+          </a:p>
+        </p:txBody>
+      </p:sp>
+      <p:sp>
+        <p:nvSpPr>
+          <p:cNvPr id="4" name="TextBox 3"/>
+          <p:cNvSpPr txBox="1"/>
+          <p:nvPr/>
+        </p:nvSpPr>
+        <p:spPr>
+          <a:xfrm>
+            <a:off x="548640" y="1554480"/>
+            <a:ext cx="11064240" cy="5303520"/>
+          </a:xfrm>
+          <a:prstGeom prst="rect">
+            <a:avLst/>
+          </a:prstGeom>
+          <a:noFill/>
+        </p:spPr>
+        <p:txBody>
+          <a:bodyPr wrap="none">
+            <a:spAutoFit/>
+          </a:bodyPr>
+          <a:lstStyle/>
+          <a:p>
+            <a:r>
+              <a:rPr sz="1400">
+                <a:solidFill>
+                  <a:srgbClr val="202020"/>
+                </a:solidFill>
                 <a:latin typeface="Consolas"/>
               </a:rPr>
-              <a:t>#!/usr/bin/env python3
-"""训练多区域时序 Transformer，并和两个简单基线比较。
-典型运行：
-    python src/aggregate_demand.py
-    python src/train_transformer.py --epochs 30
-目标改为残差：y 减去前一天同期需求（lag48），模型学习对 previous-day 基线的修正量，评估时把残差加回基线后还原为订单数。
-"""
-from __future__ import annotations
-import argparse
-import json
-import random
-from pathlib import Path
-import numpy as np
-import torch
-from torch import nn
-from torch.utils.data import DataLoader, Dataset
-from transformer_model import TemporalTransformer
-class WindowDataset(Dataset):
-    def __init__(self, x: np.ndarray, y: np.ndarray, targets: np.ndarray, lookback: int, horizon: int):
-        self.x, self.y, self.targets = x, y, targets
-        self.lookback, self.horizon = lookback, horizon
-    def __len__(self) -&gt; int:
-        return len(self.targets)</a:t>
+              <a:t>def make_targets(start: int, end: int, lookback: int, horizon: int) -&gt; np.ndarray:
+    first = max(start, lookback)
+    last = end - horizon + 1
+    return np.arange(first, max(first, last), dtype=np.int64)
+def metrics(y_true: np.ndarray, y_pred: np.ndarray) -&gt; dict[str, float]:
+    err = y_pred - y_true
+    denom = np.maximum(np.abs(y_true), 1.0)</a:t>
+            </a:r>
+          </a:p>
+        </p:txBody>
+      </p:sp>
+    </p:spTree>
+  </p:cSld>
+  <p:clrMapOvr>
+    <a:masterClrMapping/>
+  </p:clrMapOvr>
+</p:sld>
+</file>
+
+<file path=ppt/slides/slide25.xml><?xml version="1.0" encoding="utf-8"?>
+<p:sld xmlns:a="http://schemas.openxmlformats.org/drawingml/2006/main" xmlns:p="http://schemas.openxmlformats.org/presentationml/2006/main" xmlns:r="http://schemas.openxmlformats.org/officeDocument/2006/relationships">
+  <p:cSld>
+    <p:spTree>
+      <p:nvGrpSpPr>
+        <p:cNvPr id="1" name=""/>
+        <p:cNvGrpSpPr/>
+        <p:nvPr/>
+      </p:nvGrpSpPr>
+      <p:grpSpPr/>
+      <p:sp>
+        <p:nvSpPr>
+          <p:cNvPr id="2" name="TextBox 1"/>
+          <p:cNvSpPr txBox="1"/>
+          <p:nvPr/>
+        </p:nvSpPr>
+        <p:spPr>
+          <a:xfrm>
+            <a:off x="548640" y="228600"/>
+            <a:ext cx="11064240" cy="685800"/>
+          </a:xfrm>
+          <a:prstGeom prst="rect">
+            <a:avLst/>
+          </a:prstGeom>
+          <a:noFill/>
+        </p:spPr>
+        <p:txBody>
+          <a:bodyPr wrap="none">
+            <a:spAutoFit/>
+          </a:bodyPr>
+          <a:lstStyle/>
+          <a:p>
+            <a:pPr>
+              <a:defRPr sz="2200" b="1">
+                <a:solidFill>
+                  <a:srgbClr val="1F4E79"/>
+                </a:solidFill>
+              </a:defRPr>
+            </a:pPr>
+            <a:r>
+              <a:t>核心代码 5/6：评价指标（train_transformer.py）</a:t>
+            </a:r>
+          </a:p>
+        </p:txBody>
+      </p:sp>
+      <p:sp>
+        <p:nvSpPr>
+          <p:cNvPr id="3" name="TextBox 2"/>
+          <p:cNvSpPr txBox="1"/>
+          <p:nvPr/>
+        </p:nvSpPr>
+        <p:spPr>
+          <a:xfrm>
+            <a:off x="640080" y="960120"/>
+            <a:ext cx="10972800" cy="502920"/>
+          </a:xfrm>
+          <a:prstGeom prst="rect">
+            <a:avLst/>
+          </a:prstGeom>
+          <a:noFill/>
+        </p:spPr>
+        <p:txBody>
+          <a:bodyPr wrap="none">
+            <a:spAutoFit/>
+          </a:bodyPr>
+          <a:lstStyle/>
+          <a:p>
+            <a:pPr>
+              <a:defRPr sz="1400">
+                <a:solidFill>
+                  <a:srgbClr val="646464"/>
+                </a:solidFill>
+              </a:defRPr>
+            </a:pPr>
+            <a:r>
+              <a:t>MAE / RMSE / MAPE / WMAPE 四项指标，WMAPE为主要参考</a:t>
+            </a:r>
+          </a:p>
+        </p:txBody>
+      </p:sp>
+      <p:sp>
+        <p:nvSpPr>
+          <p:cNvPr id="4" name="TextBox 3"/>
+          <p:cNvSpPr txBox="1"/>
+          <p:nvPr/>
+        </p:nvSpPr>
+        <p:spPr>
+          <a:xfrm>
+            <a:off x="548640" y="1554480"/>
+            <a:ext cx="11064240" cy="5303520"/>
+          </a:xfrm>
+          <a:prstGeom prst="rect">
+            <a:avLst/>
+          </a:prstGeom>
+          <a:noFill/>
+        </p:spPr>
+        <p:txBody>
+          <a:bodyPr wrap="none">
+            <a:spAutoFit/>
+          </a:bodyPr>
+          <a:lstStyle/>
+          <a:p>
+            <a:r>
+              <a:rPr sz="1400">
+                <a:solidFill>
+                  <a:srgbClr val="202020"/>
+                </a:solidFill>
+                <a:latin typeface="Consolas"/>
+              </a:rPr>
+              <a:t>def make_targets(start: int, end: int, lookback: int, horizon: int) -&gt; np.ndarray:
+    first = max(start, lookback)
+    last = end - horizon + 1
+    return np.arange(first, max(first, last), dtype=np.int64)
+def metrics(y_true: np.ndarray, y_pred: np.ndarray) -&gt; dict[str, float]:
+    err = y_pred - y_true
+    denom = np.maximum(np.abs(y_true), 1.0)</a:t>
             </a:r>
           </a:p>
         </p:txBody>
@@ -5304,7 +6113,7 @@
         <p:spPr>
           <a:xfrm>
             <a:off x="548640" y="228600"/>
-            <a:ext cx="11064240" cy="640080"/>
+            <a:ext cx="11064240" cy="685800"/>
           </a:xfrm>
           <a:prstGeom prst="rect">
             <a:avLst/>
@@ -5318,14 +6127,14 @@
           <a:lstStyle/>
           <a:p>
             <a:pPr>
-              <a:defRPr sz="2000" b="1">
+              <a:defRPr sz="2200" b="1">
                 <a:solidFill>
                   <a:srgbClr val="1F4E79"/>
                 </a:solidFill>
               </a:defRPr>
             </a:pPr>
             <a:r>
-              <a:t>源代码：Transformer训练脚本 - train_transformer.py (2/8)</a:t>
+              <a:t>核心代码 6/6：按日期划分与训练循环（train_transformer.py）</a:t>
             </a:r>
           </a:p>
         </p:txBody>
@@ -5338,8 +6147,8 @@
         </p:nvSpPr>
         <p:spPr>
           <a:xfrm>
-            <a:off x="457200" y="914400"/>
-            <a:ext cx="11247120" cy="5760720"/>
+            <a:off x="640080" y="960120"/>
+            <a:ext cx="10972800" cy="502920"/>
           </a:xfrm>
           <a:prstGeom prst="rect">
             <a:avLst/>
@@ -5352,36 +6161,209 @@
           </a:bodyPr>
           <a:lstStyle/>
           <a:p>
-            <a:r>
-              <a:rPr sz="900">
+            <a:pPr>
+              <a:defRPr sz="1400">
+                <a:solidFill>
+                  <a:srgbClr val="646464"/>
+                </a:solidFill>
+              </a:defRPr>
+            </a:pPr>
+            <a:r>
+              <a:t>只以训练段数据估计z-score参数，避免测试集信息泄漏</a:t>
+            </a:r>
+          </a:p>
+        </p:txBody>
+      </p:sp>
+      <p:sp>
+        <p:nvSpPr>
+          <p:cNvPr id="4" name="TextBox 3"/>
+          <p:cNvSpPr txBox="1"/>
+          <p:nvPr/>
+        </p:nvSpPr>
+        <p:spPr>
+          <a:xfrm>
+            <a:off x="548640" y="1554480"/>
+            <a:ext cx="11064240" cy="5303520"/>
+          </a:xfrm>
+          <a:prstGeom prst="rect">
+            <a:avLst/>
+          </a:prstGeom>
+          <a:noFill/>
+        </p:spPr>
+        <p:txBody>
+          <a:bodyPr wrap="none">
+            <a:spAutoFit/>
+          </a:bodyPr>
+          <a:lstStyle/>
+          <a:p>
+            <a:r>
+              <a:rPr sz="1400">
+                <a:solidFill>
+                  <a:srgbClr val="202020"/>
+                </a:solidFill>
                 <a:latin typeface="Consolas"/>
               </a:rPr>
-              <a:t>
-    def __getitem__(self, index: int):
-        t = int(self.targets[index])
-        lag48 = np.repeat(self.x[t - 48:t - 47], self.lookback, axis=0)
-        features = np.concatenate(
-            [self.x[t - self.lookback:t], self.y[t - self.lookback:t], lag48], axis=1
-        )
-        baseline = np.repeat(self.x[t - 48:t - 48 + self.horizon], self.horizon, axis=0)
-        target = self.x[t:t + self.horizon] - baseline
-        return torch.from_numpy(features).float(), torch.from_numpy(target).float()
-def set_seed(seed: int) -&gt; None:
-    random.seed(seed)
-    np.random.seed(seed)
-    torch.manual_seed(seed)
-    if torch.cuda.is_available():
-        torch.cuda.manual_seed_all(seed)
-def make_targets(start: int, end: int, lookback: int, horizon: int) -&gt; np.ndarray:
-    first = max(start, lookback)
-    last = end - horizon + 1
-    return np.arange(first, max(first, last), dtype=np.int64)
-def metrics(y_true: np.ndarray, y_pred: np.ndarray) -&gt; dict[str, float]:
-    err = y_pred - y_true
-    denom = np.maximum(np.abs(y_true), 1.0)
-    return {
-        "MAE": float(np.mean(np.abs(err))),
-        "RMSE": float(np.sqrt(np.mean(err ** 2))),</a:t>
+              <a:t>ts = pd.to_datetime(times, unit="s")
+first_idx = int(np.argmax(ts &gt;= pd.Timestamp(args.train_start)))
+train_end = int(np.argmax(ts &gt;= pd.Timestamp(args.train_end)))
+val_end   = int(np.argmax(ts &gt;= pd.Timestamp(args.val_end)))
+log_demand = np.log1p(demand)
+mean = log_demand[train_start_idx:train_end].mean(axis=0)
+std  = log_demand[train_start_idx:train_end].std(axis=0)
+std[std &lt; 1e-4] = 1.0  # 避免除零
+scaled = ((log_demand - mean) / std).astype(np.float32)
+for epoch in range(1, args.epochs + 1):
+    train_loss = train_epoch(model, train_loader, optimizer, criterion, device)
+    val_loss = evaluate(model, val_loader, criterion, device)
+    if val_loss &lt; best_val:
+        best_val, stale = val_loss, 0
+        torch.save({"model": model.state_dict(),
+                    "mean": mean, "std": std}, checkpoint)
+    else:
+        stale += 1
+        if stale &gt;= args.patience:
+            break  # 早停</a:t>
+            </a:r>
+          </a:p>
+        </p:txBody>
+      </p:sp>
+    </p:spTree>
+  </p:cSld>
+  <p:clrMapOvr>
+    <a:masterClrMapping/>
+  </p:clrMapOvr>
+</p:sld>
+</file>
+
+<file path=ppt/slides/slide26.xml><?xml version="1.0" encoding="utf-8"?>
+<p:sld xmlns:a="http://schemas.openxmlformats.org/drawingml/2006/main" xmlns:p="http://schemas.openxmlformats.org/presentationml/2006/main" xmlns:r="http://schemas.openxmlformats.org/officeDocument/2006/relationships">
+  <p:cSld>
+    <p:spTree>
+      <p:nvGrpSpPr>
+        <p:cNvPr id="1" name=""/>
+        <p:cNvGrpSpPr/>
+        <p:nvPr/>
+      </p:nvGrpSpPr>
+      <p:grpSpPr/>
+      <p:sp>
+        <p:nvSpPr>
+          <p:cNvPr id="2" name="TextBox 1"/>
+          <p:cNvSpPr txBox="1"/>
+          <p:nvPr/>
+        </p:nvSpPr>
+        <p:spPr>
+          <a:xfrm>
+            <a:off x="548640" y="228600"/>
+            <a:ext cx="11064240" cy="685800"/>
+          </a:xfrm>
+          <a:prstGeom prst="rect">
+            <a:avLst/>
+          </a:prstGeom>
+          <a:noFill/>
+        </p:spPr>
+        <p:txBody>
+          <a:bodyPr wrap="none">
+            <a:spAutoFit/>
+          </a:bodyPr>
+          <a:lstStyle/>
+          <a:p>
+            <a:pPr>
+              <a:defRPr sz="2200" b="1">
+                <a:solidFill>
+                  <a:srgbClr val="1F4E79"/>
+                </a:solidFill>
+              </a:defRPr>
+            </a:pPr>
+            <a:r>
+              <a:t>核心代码 6/6：按日期划分与训练循环（train_transformer.py）</a:t>
+            </a:r>
+          </a:p>
+        </p:txBody>
+      </p:sp>
+      <p:sp>
+        <p:nvSpPr>
+          <p:cNvPr id="3" name="TextBox 2"/>
+          <p:cNvSpPr txBox="1"/>
+          <p:nvPr/>
+        </p:nvSpPr>
+        <p:spPr>
+          <a:xfrm>
+            <a:off x="640080" y="960120"/>
+            <a:ext cx="10972800" cy="502920"/>
+          </a:xfrm>
+          <a:prstGeom prst="rect">
+            <a:avLst/>
+          </a:prstGeom>
+          <a:noFill/>
+        </p:spPr>
+        <p:txBody>
+          <a:bodyPr wrap="none">
+            <a:spAutoFit/>
+          </a:bodyPr>
+          <a:lstStyle/>
+          <a:p>
+            <a:pPr>
+              <a:defRPr sz="1400">
+                <a:solidFill>
+                  <a:srgbClr val="646464"/>
+                </a:solidFill>
+              </a:defRPr>
+            </a:pPr>
+            <a:r>
+              <a:t>只以训练段数据估计z-score参数，避免测试集信息泄漏</a:t>
+            </a:r>
+          </a:p>
+        </p:txBody>
+      </p:sp>
+      <p:sp>
+        <p:nvSpPr>
+          <p:cNvPr id="4" name="TextBox 3"/>
+          <p:cNvSpPr txBox="1"/>
+          <p:nvPr/>
+        </p:nvSpPr>
+        <p:spPr>
+          <a:xfrm>
+            <a:off x="548640" y="1554480"/>
+            <a:ext cx="11064240" cy="5303520"/>
+          </a:xfrm>
+          <a:prstGeom prst="rect">
+            <a:avLst/>
+          </a:prstGeom>
+          <a:noFill/>
+        </p:spPr>
+        <p:txBody>
+          <a:bodyPr wrap="none">
+            <a:spAutoFit/>
+          </a:bodyPr>
+          <a:lstStyle/>
+          <a:p>
+            <a:r>
+              <a:rPr sz="1400">
+                <a:solidFill>
+                  <a:srgbClr val="202020"/>
+                </a:solidFill>
+                <a:latin typeface="Consolas"/>
+              </a:rPr>
+              <a:t>ts = pd.to_datetime(times, unit="s")
+first_idx = int(np.argmax(ts &gt;= pd.Timestamp(args.train_start)))
+train_end = int(np.argmax(ts &gt;= pd.Timestamp(args.train_end)))
+val_end   = int(np.argmax(ts &gt;= pd.Timestamp(args.val_end)))
+log_demand = np.log1p(demand)
+mean = log_demand[train_start_idx:train_end].mean(axis=0)
+std  = log_demand[train_start_idx:train_end].std(axis=0)
+std[std &lt; 1e-4] = 1.0  # 避免除零
+scaled = ((log_demand - mean) / std).astype(np.float32)
+for epoch in range(1, args.epochs + 1):
+    train_loss = train_epoch(model, train_loader, optimizer, criterion, device)
+    val_loss = evaluate(model, val_loader, criterion, device)
+    if val_loss &lt; best_val:
+        best_val, stale = val_loss, 0
+        torch.save({"model": model.state_dict(),
+                    "mean": mean, "std": std}, checkpoint)
+    else:
+        stale += 1
+        if stale &gt;= args.patience:
+            break  # 早停</a:t>
             </a:r>
           </a:p>
         </p:txBody>

</xml_diff>